<commit_message>
docs(docs): align the scenario presentation with the shipped scenarios
</commit_message>
<xml_diff>
--- a/docs/scenarios_presentation.pptx
+++ b/docs/scenarios_presentation.pptx
@@ -3293,12 +3293,8 @@
               </a:defRPr>
             </a:pPr>
             <a:r>
-              <a:rPr dirty="0" err="1"/>
-              <a:t>TestCase.xiidm</a:t>
-            </a:r>
-            <a:r>
-              <a:rPr dirty="0"/>
-              <a:t> — Scenario Analysis</a:t>
+              <a:rPr lang="en-GB" dirty="0"/>
+              <a:t>tx-full — Scenario Analysis</a:t>
             </a:r>
           </a:p>
         </p:txBody>
@@ -3333,7 +3329,7 @@
               </a:defRPr>
             </a:pPr>
             <a:r>
-              <a:t>Merged IEEE 14 + IEEE 39 + HVDC — baseline / high RES + low demand / low RES + high demand</a:t>
+              <a:t>IEEE 39 + HVDC + IEEE 14 — S1 baseline · S2 high RES, low demand · S3 low RES, high demand</a:t>
             </a:r>
           </a:p>
         </p:txBody>
@@ -3416,36 +3412,6 @@
           </a:p>
         </p:txBody>
       </p:sp>
-      <p:pic>
-        <p:nvPicPr>
-          <p:cNvPr id="6" name="Picture 20" descr="A diagram of a network&#10;&#10;AI-generated content may be incorrect.">
-            <a:extLst>
-              <a:ext uri="{FF2B5EF4-FFF2-40B4-BE49-F238E27FC236}">
-                <a16:creationId xmlns:a16="http://schemas.microsoft.com/office/drawing/2014/main" id="{F7DDD0A6-C048-79B0-DD1B-DE81EE5F37EF}"/>
-              </a:ext>
-            </a:extLst>
-          </p:cNvPr>
-          <p:cNvPicPr>
-            <a:picLocks noChangeAspect="1"/>
-          </p:cNvPicPr>
-          <p:nvPr/>
-        </p:nvPicPr>
-        <p:blipFill>
-          <a:blip r:embed="rId2"/>
-          <a:stretch>
-            <a:fillRect/>
-          </a:stretch>
-        </p:blipFill>
-        <p:spPr>
-          <a:xfrm>
-            <a:off x="7553132" y="3307804"/>
-            <a:ext cx="4162400" cy="3007001"/>
-          </a:xfrm>
-          <a:prstGeom prst="rect">
-            <a:avLst/>
-          </a:prstGeom>
-        </p:spPr>
-      </p:pic>
       <p:grpSp>
         <p:nvGrpSpPr>
           <p:cNvPr id="3" name="Groupe 2">
@@ -3788,112 +3754,29 @@
           </p:sp>
         </p:grpSp>
       </p:grpSp>
-      <p:sp>
-        <p:nvSpPr>
-          <p:cNvPr id="19" name="ZoneTexte 18">
-            <a:extLst>
-              <a:ext uri="{FF2B5EF4-FFF2-40B4-BE49-F238E27FC236}">
-                <a16:creationId xmlns:a16="http://schemas.microsoft.com/office/drawing/2014/main" id="{75C0F245-A567-49A7-3A6C-2BF0849C61E5}"/>
-              </a:ext>
-            </a:extLst>
-          </p:cNvPr>
-          <p:cNvSpPr txBox="1"/>
-          <p:nvPr/>
-        </p:nvSpPr>
-        <p:spPr>
-          <a:xfrm>
-            <a:off x="1302555" y="2531867"/>
-            <a:ext cx="3600282" cy="400006"/>
-          </a:xfrm>
-          <a:prstGeom prst="rect">
-            <a:avLst/>
-          </a:prstGeom>
-          <a:noFill/>
-        </p:spPr>
-        <p:txBody>
-          <a:bodyPr wrap="square" rtlCol="0">
-            <a:spAutoFit/>
-          </a:bodyPr>
-          <a:lstStyle/>
-          <a:p>
-            <a:r>
-              <a:rPr lang="en-GB" sz="1999" b="1"/>
-              <a:t>For transmission-level tools</a:t>
-            </a:r>
-          </a:p>
-        </p:txBody>
-      </p:sp>
-      <p:sp>
-        <p:nvSpPr>
-          <p:cNvPr id="20" name="ZoneTexte 19">
-            <a:extLst>
-              <a:ext uri="{FF2B5EF4-FFF2-40B4-BE49-F238E27FC236}">
-                <a16:creationId xmlns:a16="http://schemas.microsoft.com/office/drawing/2014/main" id="{7AF71203-2755-D5E9-F5C0-0FB156C9910A}"/>
-              </a:ext>
-            </a:extLst>
-          </p:cNvPr>
-          <p:cNvSpPr txBox="1"/>
-          <p:nvPr/>
-        </p:nvSpPr>
-        <p:spPr>
-          <a:xfrm>
-            <a:off x="1447101" y="2938569"/>
-            <a:ext cx="4355109" cy="369236"/>
-          </a:xfrm>
-          <a:prstGeom prst="rect">
-            <a:avLst/>
-          </a:prstGeom>
-          <a:noFill/>
-        </p:spPr>
-        <p:txBody>
-          <a:bodyPr wrap="square" rtlCol="0">
-            <a:spAutoFit/>
-          </a:bodyPr>
-          <a:lstStyle/>
-          <a:p>
-            <a:pPr algn="ctr"/>
-            <a:r>
-              <a:rPr lang="en-GB" sz="1799"/>
-              <a:t>IEEE 39-Bus + HVDC link + IEEE 14-Bus</a:t>
-            </a:r>
-          </a:p>
-        </p:txBody>
-      </p:sp>
       <p:grpSp>
         <p:nvGrpSpPr>
-          <p:cNvPr id="16" name="Groupe 15">
-            <a:extLst>
-              <a:ext uri="{FF2B5EF4-FFF2-40B4-BE49-F238E27FC236}">
-                <a16:creationId xmlns:a16="http://schemas.microsoft.com/office/drawing/2014/main" id="{D23A0851-E1F6-CB9C-579D-7983D20A49BD}"/>
-              </a:ext>
-            </a:extLst>
-          </p:cNvPr>
+          <p:cNvPr id="32" name="Groupe 31"/>
           <p:cNvGrpSpPr/>
           <p:nvPr/>
         </p:nvGrpSpPr>
         <p:grpSpPr>
           <a:xfrm>
-            <a:off x="11042319" y="2530311"/>
-            <a:ext cx="769568" cy="417491"/>
-            <a:chOff x="3654176" y="5284908"/>
+            <a:off x="6546000" y="2514381"/>
+            <a:ext cx="769768" cy="417600"/>
+            <a:chOff x="6546000" y="2514381"/>
             <a:chExt cx="769768" cy="417600"/>
           </a:xfrm>
         </p:grpSpPr>
         <p:sp>
           <p:nvSpPr>
-            <p:cNvPr id="17" name="Ellipse 16">
-              <a:extLst>
-                <a:ext uri="{FF2B5EF4-FFF2-40B4-BE49-F238E27FC236}">
-                  <a16:creationId xmlns:a16="http://schemas.microsoft.com/office/drawing/2014/main" id="{E155D716-048E-5D04-5D63-57B001E07EC7}"/>
-                </a:ext>
-              </a:extLst>
-            </p:cNvPr>
+            <p:cNvPr id="33" name="Ellipse 32"/>
             <p:cNvSpPr/>
             <p:nvPr/>
           </p:nvSpPr>
           <p:spPr>
             <a:xfrm>
-              <a:off x="3830260" y="5284908"/>
+              <a:off x="6722084" y="2514381"/>
               <a:ext cx="417600" cy="417600"/>
             </a:xfrm>
             <a:prstGeom prst="ellipse">
@@ -3902,15 +3785,15 @@
           </p:spPr>
           <p:style>
             <a:lnRef idx="2">
-              <a:schemeClr val="accent5">
+              <a:schemeClr val="accent4">
                 <a:shade val="15000"/>
               </a:schemeClr>
             </a:lnRef>
             <a:fillRef idx="1">
-              <a:schemeClr val="accent5"/>
+              <a:schemeClr val="accent4"/>
             </a:fillRef>
             <a:effectRef idx="0">
-              <a:schemeClr val="accent5"/>
+              <a:schemeClr val="accent4"/>
             </a:effectRef>
             <a:fontRef idx="minor">
               <a:schemeClr val="lt1"/>
@@ -3927,19 +3810,13 @@
         </p:sp>
         <p:sp>
           <p:nvSpPr>
-            <p:cNvPr id="18" name="ZoneTexte 17">
-              <a:extLst>
-                <a:ext uri="{FF2B5EF4-FFF2-40B4-BE49-F238E27FC236}">
-                  <a16:creationId xmlns:a16="http://schemas.microsoft.com/office/drawing/2014/main" id="{6E8CEB00-C08C-7BBA-25C7-E1AB5F4391A4}"/>
-                </a:ext>
-              </a:extLst>
-            </p:cNvPr>
+            <p:cNvPr id="34" name="ZoneTexte 33"/>
             <p:cNvSpPr txBox="1"/>
             <p:nvPr/>
           </p:nvSpPr>
           <p:spPr>
             <a:xfrm>
-              <a:off x="3654176" y="5309042"/>
+              <a:off x="6546000" y="2538515"/>
               <a:ext cx="769768" cy="369332"/>
             </a:xfrm>
             <a:prstGeom prst="rect">
@@ -3960,7 +3837,7 @@
                     <a:schemeClr val="bg1"/>
                   </a:solidFill>
                 </a:rPr>
-                <a:t>#6</a:t>
+                <a:t>#3</a:t>
               </a:r>
             </a:p>
           </p:txBody>
@@ -3968,10 +3845,10 @@
       </p:grpSp>
       <p:sp>
         <p:nvSpPr>
-          <p:cNvPr id="21" name="ZoneTexte 20">
+          <p:cNvPr id="19" name="ZoneTexte 18">
             <a:extLst>
               <a:ext uri="{FF2B5EF4-FFF2-40B4-BE49-F238E27FC236}">
-                <a16:creationId xmlns:a16="http://schemas.microsoft.com/office/drawing/2014/main" id="{FCC425EE-70F8-A5EB-B047-6CA37E47881D}"/>
+                <a16:creationId xmlns:a16="http://schemas.microsoft.com/office/drawing/2014/main" id="{75C0F245-A567-49A7-3A6C-2BF0849C61E5}"/>
               </a:ext>
             </a:extLst>
           </p:cNvPr>
@@ -3980,8 +3857,8 @@
         </p:nvSpPr>
         <p:spPr>
           <a:xfrm>
-            <a:off x="7817927" y="2530311"/>
-            <a:ext cx="3335122" cy="400006"/>
+            <a:off x="1302555" y="2531867"/>
+            <a:ext cx="3600282" cy="400006"/>
           </a:xfrm>
           <a:prstGeom prst="rect">
             <a:avLst/>
@@ -3996,17 +3873,17 @@
           <a:p>
             <a:r>
               <a:rPr lang="en-GB" sz="1999" b="1"/>
-              <a:t>For distribution-level tools</a:t>
-            </a:r>
-          </a:p>
-        </p:txBody>
-      </p:sp>
-      <p:sp>
-        <p:nvSpPr>
-          <p:cNvPr id="22" name="ZoneTexte 21">
+              <a:t>For transmission-level tools</a:t>
+            </a:r>
+          </a:p>
+        </p:txBody>
+      </p:sp>
+      <p:sp>
+        <p:nvSpPr>
+          <p:cNvPr id="20" name="ZoneTexte 19">
             <a:extLst>
               <a:ext uri="{FF2B5EF4-FFF2-40B4-BE49-F238E27FC236}">
-                <a16:creationId xmlns:a16="http://schemas.microsoft.com/office/drawing/2014/main" id="{20BB41BF-9414-B8DF-E2DE-0B83EA5BF1FC}"/>
+                <a16:creationId xmlns:a16="http://schemas.microsoft.com/office/drawing/2014/main" id="{7AF71203-2755-D5E9-F5C0-0FB156C9910A}"/>
               </a:ext>
             </a:extLst>
           </p:cNvPr>
@@ -4015,7 +3892,7 @@
         </p:nvSpPr>
         <p:spPr>
           <a:xfrm>
-            <a:off x="7456778" y="2938569"/>
+            <a:off x="1447101" y="2938569"/>
             <a:ext cx="4355109" cy="369236"/>
           </a:xfrm>
           <a:prstGeom prst="rect">
@@ -4032,14 +3909,14 @@
             <a:pPr algn="ctr"/>
             <a:r>
               <a:rPr lang="en-GB" sz="1799"/>
-              <a:t>Modified IEEE 33-Bus</a:t>
+              <a:t>IEEE 39-Bus + HVDC link + IEEE 14-Bus</a:t>
             </a:r>
           </a:p>
         </p:txBody>
       </p:sp>
       <p:pic>
         <p:nvPicPr>
-          <p:cNvPr id="23" name="Image 22">
+          <p:cNvPr id="23" name="Image 22" descr="IEEE 39-bus system linked to the IEEE 14-bus system by an HVDC link from bus 16 to bus 13 of IEEE 14">
             <a:extLst>
               <a:ext uri="{FF2B5EF4-FFF2-40B4-BE49-F238E27FC236}">
                 <a16:creationId xmlns:a16="http://schemas.microsoft.com/office/drawing/2014/main" id="{9BBC668C-AFF9-28BB-FABA-DD2F948D8741}"/>
@@ -4061,56 +3938,13 @@
         <p:spPr>
           <a:xfrm>
             <a:off x="837982" y="3307805"/>
-            <a:ext cx="5769118" cy="2587544"/>
+            <a:ext cx="7200000" cy="3229291"/>
           </a:xfrm>
           <a:prstGeom prst="rect">
             <a:avLst/>
           </a:prstGeom>
         </p:spPr>
       </p:pic>
-      <p:cxnSp>
-        <p:nvCxnSpPr>
-          <p:cNvPr id="25" name="Connecteur : en angle 24">
-            <a:extLst>
-              <a:ext uri="{FF2B5EF4-FFF2-40B4-BE49-F238E27FC236}">
-                <a16:creationId xmlns:a16="http://schemas.microsoft.com/office/drawing/2014/main" id="{4D6DE557-2194-0078-8269-B37C22C75DBA}"/>
-              </a:ext>
-            </a:extLst>
-          </p:cNvPr>
-          <p:cNvCxnSpPr>
-            <a:cxnSpLocks/>
-          </p:cNvCxnSpPr>
-          <p:nvPr/>
-        </p:nvCxnSpPr>
-        <p:spPr>
-          <a:xfrm rot="16200000" flipH="1">
-            <a:off x="2386911" y="5898950"/>
-            <a:ext cx="363723" cy="356523"/>
-          </a:xfrm>
-          <a:prstGeom prst="bentConnector3">
-            <a:avLst>
-              <a:gd name="adj1" fmla="val 100267"/>
-            </a:avLst>
-          </a:prstGeom>
-          <a:ln w="76200">
-            <a:tailEnd type="triangle"/>
-          </a:ln>
-        </p:spPr>
-        <p:style>
-          <a:lnRef idx="2">
-            <a:schemeClr val="accent1"/>
-          </a:lnRef>
-          <a:fillRef idx="0">
-            <a:schemeClr val="accent1"/>
-          </a:fillRef>
-          <a:effectRef idx="1">
-            <a:schemeClr val="accent1"/>
-          </a:effectRef>
-          <a:fontRef idx="minor">
-            <a:schemeClr val="tx1"/>
-          </a:fontRef>
-        </p:style>
-      </p:cxnSp>
       <p:sp>
         <p:nvSpPr>
           <p:cNvPr id="29" name="ZoneTexte 28">
@@ -4125,8 +3959,8 @@
         </p:nvSpPr>
         <p:spPr>
           <a:xfrm>
-            <a:off x="2856395" y="5797528"/>
-            <a:ext cx="2577936" cy="923090"/>
+            <a:off x="8330000" y="3600000"/>
+            <a:ext cx="3400000" cy="1900000"/>
           </a:xfrm>
           <a:prstGeom prst="rect">
             <a:avLst/>
@@ -4139,33 +3973,63 @@
           </a:bodyPr>
           <a:lstStyle/>
           <a:p>
+            <a:r>
+              <a:rPr lang="en-GB" sz="1799" b="1"/>
+              <a:t>Shipped formats</a:t>
+            </a:r>
+          </a:p>
+          <a:p>
             <a:pPr marL="285664" indent="-285664">
+              <a:spcAft>
+                <a:spcPts val="300"/>
+              </a:spcAft>
               <a:buFont typeface="Arial" panose="020B0604020202020204" pitchFamily="34" charset="0"/>
               <a:buChar char="•"/>
             </a:pPr>
             <a:r>
-              <a:rPr lang="fr-FR" sz="1799"/>
-              <a:t>PSS/E format</a:t>
+              <a:rPr lang="en-GB" sz="1600"/>
+              <a:t>XIIDM</a:t>
             </a:r>
           </a:p>
           <a:p>
             <a:pPr marL="285664" indent="-285664">
+              <a:spcAft>
+                <a:spcPts val="300"/>
+              </a:spcAft>
               <a:buFont typeface="Arial" panose="020B0604020202020204" pitchFamily="34" charset="0"/>
               <a:buChar char="•"/>
             </a:pPr>
             <a:r>
-              <a:rPr lang="fr-FR" sz="1799"/>
-              <a:t>CGMES</a:t>
+              <a:rPr lang="en-GB" sz="1600"/>
+              <a:t>CGMES 2.4.15</a:t>
             </a:r>
           </a:p>
           <a:p>
             <a:pPr marL="285664" indent="-285664">
+              <a:spcAft>
+                <a:spcPts val="300"/>
+              </a:spcAft>
               <a:buFont typeface="Arial" panose="020B0604020202020204" pitchFamily="34" charset="0"/>
               <a:buChar char="•"/>
             </a:pPr>
             <a:r>
-              <a:rPr lang="fr-FR" sz="1799"/>
-              <a:t>XIIDM</a:t>
+              <a:rPr lang="en-GB" sz="1600"/>
+              <a:t>PowerFactory .pfd (base case only)</a:t>
+            </a:r>
+          </a:p>
+          <a:p>
+            <a:pPr>
+              <a:spcBef>
+                <a:spcPts val="1200"/>
+              </a:spcBef>
+            </a:pPr>
+            <a:r>
+              <a:rPr lang="en-GB" sz="1200" i="1">
+                <a:solidFill>
+                  <a:srgbClr val="555555"/>
+                </a:solidFill>
+              </a:rPr>
+              <a:t>IEEE 14 bus &lt;n&gt; of the diagram is bus 100 + n in the model (e.g. &lt;13&gt; is B113).</a:t>
             </a:r>
           </a:p>
         </p:txBody>
@@ -4320,33 +4184,6 @@
                                 </p:cTn>
                               </p:par>
                               <p:par>
-                                <p:cTn id="9" presetID="1" presetClass="entr" presetSubtype="0" fill="hold" nodeType="withEffect">
-                                  <p:stCondLst>
-                                    <p:cond delay="0"/>
-                                  </p:stCondLst>
-                                  <p:childTnLst>
-                                    <p:set>
-                                      <p:cBhvr>
-                                        <p:cTn id="10" dur="1" fill="hold">
-                                          <p:stCondLst>
-                                            <p:cond delay="0"/>
-                                          </p:stCondLst>
-                                        </p:cTn>
-                                        <p:tgtEl>
-                                          <p:spTgt spid="25"/>
-                                        </p:tgtEl>
-                                        <p:attrNameLst>
-                                          <p:attrName>style.visibility</p:attrName>
-                                        </p:attrNameLst>
-                                      </p:cBhvr>
-                                      <p:to>
-                                        <p:strVal val="visible"/>
-                                      </p:to>
-                                    </p:set>
-                                  </p:childTnLst>
-                                </p:cTn>
-                              </p:par>
-                              <p:par>
                                 <p:cTn id="11" presetID="1" presetClass="entr" presetSubtype="0" fill="hold" grpId="0" nodeType="withEffect">
                                   <p:stCondLst>
                                     <p:cond delay="0"/>
@@ -4361,78 +4198,6 @@
                                         </p:cTn>
                                         <p:tgtEl>
                                           <p:spTgt spid="29"/>
-                                        </p:tgtEl>
-                                        <p:attrNameLst>
-                                          <p:attrName>style.visibility</p:attrName>
-                                        </p:attrNameLst>
-                                      </p:cBhvr>
-                                      <p:to>
-                                        <p:strVal val="visible"/>
-                                      </p:to>
-                                    </p:set>
-                                  </p:childTnLst>
-                                </p:cTn>
-                              </p:par>
-                            </p:childTnLst>
-                          </p:cTn>
-                        </p:par>
-                      </p:childTnLst>
-                    </p:cTn>
-                  </p:par>
-                  <p:par>
-                    <p:cTn id="13" fill="hold">
-                      <p:stCondLst>
-                        <p:cond delay="indefinite"/>
-                      </p:stCondLst>
-                      <p:childTnLst>
-                        <p:par>
-                          <p:cTn id="14" fill="hold">
-                            <p:stCondLst>
-                              <p:cond delay="0"/>
-                            </p:stCondLst>
-                            <p:childTnLst>
-                              <p:par>
-                                <p:cTn id="15" presetID="1" presetClass="entr" presetSubtype="0" fill="hold" grpId="0" nodeType="clickEffect">
-                                  <p:stCondLst>
-                                    <p:cond delay="0"/>
-                                  </p:stCondLst>
-                                  <p:childTnLst>
-                                    <p:set>
-                                      <p:cBhvr>
-                                        <p:cTn id="16" dur="1" fill="hold">
-                                          <p:stCondLst>
-                                            <p:cond delay="0"/>
-                                          </p:stCondLst>
-                                        </p:cTn>
-                                        <p:tgtEl>
-                                          <p:spTgt spid="22"/>
-                                        </p:tgtEl>
-                                        <p:attrNameLst>
-                                          <p:attrName>style.visibility</p:attrName>
-                                        </p:attrNameLst>
-                                      </p:cBhvr>
-                                      <p:to>
-                                        <p:strVal val="visible"/>
-                                      </p:to>
-                                    </p:set>
-                                  </p:childTnLst>
-                                </p:cTn>
-                              </p:par>
-                              <p:par>
-                                <p:cTn id="17" presetID="1" presetClass="entr" presetSubtype="0" fill="hold" nodeType="withEffect">
-                                  <p:stCondLst>
-                                    <p:cond delay="0"/>
-                                  </p:stCondLst>
-                                  <p:childTnLst>
-                                    <p:set>
-                                      <p:cBhvr>
-                                        <p:cTn id="18" dur="1" fill="hold">
-                                          <p:stCondLst>
-                                            <p:cond delay="0"/>
-                                          </p:stCondLst>
-                                        </p:cTn>
-                                        <p:tgtEl>
-                                          <p:spTgt spid="6"/>
                                         </p:tgtEl>
                                         <p:attrNameLst>
                                           <p:attrName>style.visibility</p:attrName>
@@ -4474,7 +4239,6 @@
     </p:tnLst>
     <p:bldLst>
       <p:bldP spid="20" grpId="0"/>
-      <p:bldP spid="22" grpId="0"/>
       <p:bldP spid="29" grpId="0"/>
     </p:bldLst>
   </p:timing>
@@ -5863,8 +5627,12 @@
               </a:defRPr>
             </a:pPr>
             <a:r>
-              <a:rPr dirty="0"/>
-              <a:t>Scenario: baseline</a:t>
+              <a:rPr lang="en-GB" dirty="0"/>
+              <a:t>Scenario S1: </a:t>
+            </a:r>
+            <a:r>
+              <a:rPr lang="en-GB" dirty="0" err="1"/>
+              <a:t>baseline</a:t>
             </a:r>
           </a:p>
           <a:p>
@@ -5876,8 +5644,8 @@
               </a:defRPr>
             </a:pPr>
             <a:r>
-              <a:rPr dirty="0"/>
-              <a:t>Reference operating point</a:t>
+              <a:rPr lang="en-GB" dirty="0"/>
+              <a:t>Reference operating point · 2025-01-01T00:00:00Z</a:t>
             </a:r>
           </a:p>
         </p:txBody>
@@ -5949,18 +5717,9 @@
               <a:defRPr sz="1400"/>
             </a:pPr>
             <a:r>
-              <a:rPr dirty="0"/>
-              <a:t>Loads kept at their stored p0 / q0 (</a:t>
-            </a:r>
-            <a:r>
-              <a:rPr dirty="0" err="1"/>
-              <a:t>load_scale</a:t>
-            </a:r>
-            <a:r>
-              <a:rPr dirty="0"/>
-              <a:t> = 1.00). </a:t>
-            </a:r>
-            <a:endParaRPr lang="fr-FR" dirty="0"/>
+              <a:rPr lang="en-GB" dirty="0"/>
+              <a:t>Loads at their source values (× 1.00 on P and Q).</a:t>
+            </a:r>
           </a:p>
           <a:p>
             <a:pPr marL="285750" indent="-285750">
@@ -5972,8 +5731,64 @@
               <a:defRPr sz="1400"/>
             </a:pPr>
             <a:r>
-              <a:rPr dirty="0"/>
-              <a:t>HVDC link held at its file value: 50 MW from IEEE 39 -&gt; IEEE 14.</a:t>
+              <a:rPr lang="en-GB" dirty="0"/>
+              <a:t>RES units (wind, solar, hydro) at 50 % of nominal P.</a:t>
+            </a:r>
+          </a:p>
+          <a:p>
+            <a:pPr marL="285750" indent="-285750">
+              <a:spcAft>
+                <a:spcPts val="400"/>
+              </a:spcAft>
+              <a:buFont typeface="Arial" panose="020B0604020202020204" pitchFamily="34" charset="0"/>
+              <a:buChar char="•"/>
+              <a:defRPr sz="1400"/>
+            </a:pPr>
+            <a:r>
+              <a:rPr lang="en-GB" dirty="0"/>
+              <a:t>Other units in merit order within each AC island (ties in file order).</a:t>
+            </a:r>
+          </a:p>
+          <a:p>
+            <a:pPr marL="285750" indent="-285750">
+              <a:spcAft>
+                <a:spcPts val="400"/>
+              </a:spcAft>
+              <a:buFont typeface="Arial" panose="020B0604020202020204" pitchFamily="34" charset="0"/>
+              <a:buChar char="•"/>
+              <a:defRPr sz="1400"/>
+            </a:pPr>
+            <a:r>
+              <a:rPr lang="en-GB" dirty="0"/>
+              <a:t>HVDC link at 50 MW from IEEE 39 → IEEE 14.</a:t>
+            </a:r>
+          </a:p>
+          <a:p>
+            <a:pPr marL="285750" indent="-285750">
+              <a:spcAft>
+                <a:spcPts val="400"/>
+              </a:spcAft>
+              <a:buFont typeface="Arial" panose="020B0604020202020204" pitchFamily="34" charset="0"/>
+              <a:buChar char="•"/>
+              <a:defRPr sz="1400"/>
+            </a:pPr>
+            <a:r>
+              <a:rPr lang="en-GB" dirty="0"/>
+              <a:t>Batteries BAT-B6-1 and BAT-B106-1 idle (0 MW).</a:t>
+            </a:r>
+          </a:p>
+          <a:p>
+            <a:pPr marL="285750" indent="-285750">
+              <a:spcAft>
+                <a:spcPts val="400"/>
+              </a:spcAft>
+              <a:buFont typeface="Arial" panose="020B0604020202020204" pitchFamily="34" charset="0"/>
+              <a:buChar char="•"/>
+              <a:defRPr sz="1400"/>
+            </a:pPr>
+            <a:r>
+              <a:rPr lang="en-GB" dirty="0"/>
+              <a:t>Goal: clean reference state, no branch above 100 %, voltages in 0.90–1.10 p.u.</a:t>
             </a:r>
           </a:p>
         </p:txBody>
@@ -6008,8 +5823,8 @@
               </a:defRPr>
             </a:pPr>
             <a:r>
-              <a:rPr dirty="0"/>
-              <a:t>Expected results after AC load flow</a:t>
+              <a:rPr lang="en-GB" dirty="0"/>
+              <a:t>Expected results after AC load flow (pypowsybl validation, not a HYNET tool result)</a:t>
             </a:r>
           </a:p>
         </p:txBody>
@@ -6045,8 +5860,8 @@
               <a:defRPr sz="1300"/>
             </a:pPr>
             <a:r>
-              <a:rPr dirty="0"/>
-              <a:t>HVDC target: 50 MW (IEEE 39 → IEEE 14)</a:t>
+              <a:rPr lang="en-GB" dirty="0"/>
+              <a:t>HVDC: 50 MW (IEEE 39 → IEEE 14), maximum 60 MW</a:t>
             </a:r>
           </a:p>
           <a:p>
@@ -6059,8 +5874,8 @@
               <a:defRPr sz="1300"/>
             </a:pPr>
             <a:r>
-              <a:rPr dirty="0"/>
-              <a:t>Generation per area: IEEE 14: MW  |  IEEE 39: MW</a:t>
+              <a:rPr lang="en-GB" dirty="0"/>
+              <a:t>Dispatched generation: IEEE 14: 209.0 MW  |  IEEE 39: 6199.5 MW (losses covered by the distributed slack)</a:t>
             </a:r>
           </a:p>
           <a:p>
@@ -6073,8 +5888,8 @@
               <a:defRPr sz="1300"/>
             </a:pPr>
             <a:r>
-              <a:rPr dirty="0"/>
-              <a:t>Load per area: IEEE 14: MW  |  IEEE 39: MW</a:t>
+              <a:rPr lang="en-GB" dirty="0"/>
+              <a:t>Load: IEEE 14: 259.0 MW / 73.5 Mvar  |  IEEE 39: 6149.5 MW / 1408.9 Mvar</a:t>
             </a:r>
           </a:p>
           <a:p>
@@ -6087,14 +5902,23 @@
               <a:defRPr sz="1300"/>
             </a:pPr>
             <a:r>
-              <a:rPr dirty="0"/>
-              <a:t>Bus voltages</a:t>
-            </a:r>
-            <a:r>
-              <a:rPr lang="fr-FR" dirty="0"/>
-              <a:t>:</a:t>
-            </a:r>
-            <a:endParaRPr dirty="0"/>
+              <a:rPr lang="en-GB" dirty="0"/>
+              <a:t>Bus voltages: 0.98–1.09 p.u.</a:t>
+            </a:r>
+          </a:p>
+          <a:p>
+            <a:pPr marL="285750" indent="-285750">
+              <a:spcAft>
+                <a:spcPts val="400"/>
+              </a:spcAft>
+              <a:buFont typeface="Arial" panose="020B0604020202020204" pitchFamily="34" charset="0"/>
+              <a:buChar char="•"/>
+              <a:defRPr sz="1300"/>
+            </a:pPr>
+            <a:r>
+              <a:rPr lang="en-GB" dirty="0"/>
+              <a:t>Highest branch loading: 92 % (T-10-32-1), no overload</a:t>
+            </a:r>
           </a:p>
         </p:txBody>
       </p:sp>
@@ -6153,14 +5977,13 @@
               </a:defRPr>
             </a:pPr>
             <a:r>
-              <a:rPr dirty="0"/>
-              <a:t>Scenario: </a:t>
-            </a:r>
-            <a:r>
-              <a:rPr dirty="0" err="1"/>
+              <a:rPr lang="en-GB" dirty="0"/>
+              <a:t>Scenario S2: </a:t>
+            </a:r>
+            <a:r>
+              <a:rPr lang="en-GB" dirty="0" err="1"/>
               <a:t>high_res_low_demand</a:t>
             </a:r>
-            <a:endParaRPr dirty="0"/>
           </a:p>
           <a:p>
             <a:pPr>
@@ -6171,8 +5994,8 @@
               </a:defRPr>
             </a:pPr>
             <a:r>
-              <a:rPr dirty="0"/>
-              <a:t>RES at full output, demand depressed, HVDC at maximum</a:t>
+              <a:rPr lang="en-GB" dirty="0"/>
+              <a:t>High RES, low demand, HVDC at maximum · 2025-01-01T01:00:00Z</a:t>
             </a:r>
           </a:p>
         </p:txBody>
@@ -6243,16 +6066,8 @@
               <a:defRPr sz="1400"/>
             </a:pPr>
             <a:r>
-              <a:rPr dirty="0"/>
-              <a:t>Loads scaled to 70 % (</a:t>
-            </a:r>
-            <a:r>
-              <a:rPr dirty="0" err="1"/>
-              <a:t>load_scale</a:t>
-            </a:r>
-            <a:r>
-              <a:rPr dirty="0"/>
-              <a:t> = 0.70).</a:t>
+              <a:rPr lang="en-GB" dirty="0"/>
+              <a:t>Loads scaled by 0.70 on P and Q.</a:t>
             </a:r>
           </a:p>
           <a:p>
@@ -6265,12 +6080,8 @@
               <a:defRPr sz="1400"/>
             </a:pPr>
             <a:r>
-              <a:rPr dirty="0"/>
-              <a:t>All RES units (WIND, SOLAR, HYDRO) pinned at 100 % of nominal P.</a:t>
-            </a:r>
-            <a:r>
-              <a:rPr lang="fr-FR" dirty="0"/>
-              <a:t> </a:t>
+              <a:rPr lang="en-GB" dirty="0"/>
+              <a:t>RES units (wind, solar, hydro) at 100 % of nominal P.</a:t>
             </a:r>
           </a:p>
           <a:p>
@@ -6283,8 +6094,8 @@
               <a:defRPr sz="1400"/>
             </a:pPr>
             <a:r>
-              <a:rPr dirty="0"/>
-              <a:t>HVDC forced to its maximum: 60 MW from IEEE 39 -&gt; IEEE 14, to stress the small IEEE 14 system.</a:t>
+              <a:rPr lang="en-GB" dirty="0"/>
+              <a:t>Other units in merit order within each AC island (ties in file order).</a:t>
             </a:r>
           </a:p>
           <a:p>
@@ -6297,8 +6108,36 @@
               <a:defRPr sz="1400"/>
             </a:pPr>
             <a:r>
-              <a:rPr dirty="0"/>
-              <a:t>Goal: provoke voltage rise on the IEEE 14 side and test HVDC congestion.</a:t>
+              <a:rPr lang="en-GB" dirty="0"/>
+              <a:t>HVDC link forced to its maximum: 60 MW from IEEE 39 → IEEE 14.</a:t>
+            </a:r>
+          </a:p>
+          <a:p>
+            <a:pPr marL="285750" indent="-285750">
+              <a:spcAft>
+                <a:spcPts val="400"/>
+              </a:spcAft>
+              <a:buFont typeface="Arial" panose="020B0604020202020204" pitchFamily="34" charset="0"/>
+              <a:buChar char="•"/>
+              <a:defRPr sz="1400"/>
+            </a:pPr>
+            <a:r>
+              <a:rPr lang="en-GB" dirty="0"/>
+              <a:t>Batteries BAT-B6-1 and BAT-B106-1 idle (0 MW).</a:t>
+            </a:r>
+          </a:p>
+          <a:p>
+            <a:pPr marL="285750" indent="-285750">
+              <a:spcAft>
+                <a:spcPts val="400"/>
+              </a:spcAft>
+              <a:buFont typeface="Arial" panose="020B0604020202020204" pitchFamily="34" charset="0"/>
+              <a:buChar char="•"/>
+              <a:defRPr sz="1400"/>
+            </a:pPr>
+            <a:r>
+              <a:rPr lang="en-GB" dirty="0"/>
+              <a:t>Goal: voltage rise and congestion of the HVDC interconnection.</a:t>
             </a:r>
           </a:p>
         </p:txBody>
@@ -6333,7 +6172,8 @@
               </a:defRPr>
             </a:pPr>
             <a:r>
-              <a:t>Expected results after AC load flow</a:t>
+              <a:rPr lang="en-GB" dirty="0"/>
+              <a:t>Expected results after AC load flow (pypowsybl validation, not a HYNET tool result)</a:t>
             </a:r>
           </a:p>
         </p:txBody>
@@ -6369,8 +6209,8 @@
               <a:defRPr sz="1300"/>
             </a:pPr>
             <a:r>
-              <a:rPr dirty="0"/>
-              <a:t>HVDC target: 60 MW (IEEE 39 → IEEE 14)</a:t>
+              <a:rPr lang="en-GB" dirty="0"/>
+              <a:t>HVDC: 60 MW (IEEE 39 → IEEE 14), at its maximum</a:t>
             </a:r>
           </a:p>
           <a:p>
@@ -6383,8 +6223,8 @@
               <a:defRPr sz="1300"/>
             </a:pPr>
             <a:r>
-              <a:rPr dirty="0"/>
-              <a:t>Generation per area: IEEE 14: MW  |  IEEE 39: MW</a:t>
+              <a:rPr lang="en-GB" dirty="0"/>
+              <a:t>Dispatched generation: IEEE 14: 121.3 MW  |  IEEE 39: 4364.6 MW (losses covered by the distributed slack)</a:t>
             </a:r>
           </a:p>
           <a:p>
@@ -6397,8 +6237,8 @@
               <a:defRPr sz="1300"/>
             </a:pPr>
             <a:r>
-              <a:rPr dirty="0"/>
-              <a:t>Load per area: IEEE 14: MW  |  IEEE 39: MW</a:t>
+              <a:rPr lang="en-GB" dirty="0"/>
+              <a:t>Load: IEEE 14: 181.3 MW / 51.4 Mvar  |  IEEE 39: 4304.6 MW / 986.2 Mvar</a:t>
             </a:r>
           </a:p>
           <a:p>
@@ -6411,8 +6251,22 @@
               <a:defRPr sz="1300"/>
             </a:pPr>
             <a:r>
-              <a:rPr dirty="0"/>
-              <a:t>Bus voltages:</a:t>
+              <a:rPr lang="en-GB" dirty="0"/>
+              <a:t>Bus voltages: 0.98–1.09 p.u.; largest rise from S1 +0.026 p.u. at B12 (IEEE 39)</a:t>
+            </a:r>
+          </a:p>
+          <a:p>
+            <a:pPr marL="285750" indent="-285750">
+              <a:spcAft>
+                <a:spcPts val="400"/>
+              </a:spcAft>
+              <a:buFont typeface="Arial" panose="020B0604020202020204" pitchFamily="34" charset="0"/>
+              <a:buChar char="•"/>
+              <a:defRPr sz="1300"/>
+            </a:pPr>
+            <a:r>
+              <a:rPr lang="en-GB" dirty="0"/>
+              <a:t>Highest branch loading: 95 % (L-28-29-1), no overload</a:t>
             </a:r>
           </a:p>
         </p:txBody>
@@ -6472,14 +6326,13 @@
               </a:defRPr>
             </a:pPr>
             <a:r>
-              <a:rPr dirty="0"/>
-              <a:t>Scenario: </a:t>
-            </a:r>
-            <a:r>
-              <a:rPr dirty="0" err="1"/>
+              <a:rPr lang="en-GB" dirty="0"/>
+              <a:t>Scenario S3: </a:t>
+            </a:r>
+            <a:r>
+              <a:rPr lang="en-GB" dirty="0" err="1"/>
               <a:t>low_res_high_demand</a:t>
             </a:r>
-            <a:endParaRPr dirty="0"/>
           </a:p>
           <a:p>
             <a:pPr>
@@ -6490,8 +6343,8 @@
               </a:defRPr>
             </a:pPr>
             <a:r>
-              <a:rPr dirty="0"/>
-              <a:t>RES collapsed, demand near peak</a:t>
+              <a:rPr lang="en-GB" dirty="0"/>
+              <a:t>Low RES, high demand at low power factor · 2025-01-01T02:00:00Z</a:t>
             </a:r>
           </a:p>
         </p:txBody>
@@ -6562,16 +6415,8 @@
               <a:defRPr sz="1400"/>
             </a:pPr>
             <a:r>
-              <a:rPr dirty="0"/>
-              <a:t>Loads scaled to 105 % (</a:t>
-            </a:r>
-            <a:r>
-              <a:rPr dirty="0" err="1"/>
-              <a:t>load_scale</a:t>
-            </a:r>
-            <a:r>
-              <a:rPr dirty="0"/>
-              <a:t> = 1.05).</a:t>
+              <a:rPr lang="en-GB" dirty="0"/>
+              <a:t>Loads scaled by 1.08 on P and 1.50 on Q.</a:t>
             </a:r>
           </a:p>
           <a:p>
@@ -6584,8 +6429,8 @@
               <a:defRPr sz="1400"/>
             </a:pPr>
             <a:r>
-              <a:rPr dirty="0"/>
-              <a:t>All RES units curtailed to 10 % of nominal P (low wind / dawn solar).</a:t>
+              <a:rPr lang="en-GB" dirty="0"/>
+              <a:t>RES units (wind, solar, hydro) at 10 % of nominal P.</a:t>
             </a:r>
           </a:p>
           <a:p>
@@ -6598,8 +6443,8 @@
               <a:defRPr sz="1400"/>
             </a:pPr>
             <a:r>
-              <a:rPr dirty="0"/>
-              <a:t>Non-RES filled by merit order to meet the higher residual demand.</a:t>
+              <a:rPr lang="en-GB" dirty="0"/>
+              <a:t>Other units in merit order within each AC island (ties in file order).</a:t>
             </a:r>
           </a:p>
           <a:p>
@@ -6612,8 +6457,8 @@
               <a:defRPr sz="1400"/>
             </a:pPr>
             <a:r>
-              <a:rPr dirty="0"/>
-              <a:t>HVDC kept at the baseline 50 MW.</a:t>
+              <a:rPr lang="en-GB" dirty="0"/>
+              <a:t>HVDC link at 50 MW from IEEE 39 → IEEE 14.</a:t>
             </a:r>
           </a:p>
           <a:p>
@@ -6626,8 +6471,22 @@
               <a:defRPr sz="1400"/>
             </a:pPr>
             <a:r>
-              <a:rPr dirty="0"/>
-              <a:t>Goal: stress the thermal fleet and check that prices/dispatch can still cover demand.</a:t>
+              <a:rPr lang="en-GB" dirty="0"/>
+              <a:t>Batteries BAT-B6-1 and BAT-B106-1 idle (0 MW).</a:t>
+            </a:r>
+          </a:p>
+          <a:p>
+            <a:pPr marL="285750" indent="-285750">
+              <a:spcAft>
+                <a:spcPts val="400"/>
+              </a:spcAft>
+              <a:buFont typeface="Arial" panose="020B0604020202020204" pitchFamily="34" charset="0"/>
+              <a:buChar char="•"/>
+              <a:defRPr sz="1400"/>
+            </a:pPr>
+            <a:r>
+              <a:rPr lang="en-GB" dirty="0"/>
+              <a:t>Goal: voltage drop and thermal-limit stress.</a:t>
             </a:r>
           </a:p>
         </p:txBody>
@@ -6662,7 +6521,8 @@
               </a:defRPr>
             </a:pPr>
             <a:r>
-              <a:t>Expected results after AC load flow</a:t>
+              <a:rPr lang="en-GB" dirty="0"/>
+              <a:t>Expected results after AC load flow (pypowsybl validation, not a HYNET tool result)</a:t>
             </a:r>
           </a:p>
         </p:txBody>
@@ -6698,8 +6558,8 @@
               <a:defRPr sz="1300"/>
             </a:pPr>
             <a:r>
-              <a:rPr dirty="0"/>
-              <a:t>HVDC target: 50 MW (IEEE 39 → IEEE 14)</a:t>
+              <a:rPr lang="en-GB" dirty="0"/>
+              <a:t>HVDC: 50 MW (IEEE 39 → IEEE 14), maximum 60 MW</a:t>
             </a:r>
           </a:p>
           <a:p>
@@ -6712,8 +6572,8 @@
               <a:defRPr sz="1300"/>
             </a:pPr>
             <a:r>
-              <a:rPr dirty="0"/>
-              <a:t>Generation per area: IEEE 14: MW  |  IEEE 39: MW</a:t>
+              <a:rPr lang="en-GB" dirty="0"/>
+              <a:t>Dispatched generation: IEEE 14: 229.7 MW  |  IEEE 39: 6691.5 MW (losses covered by the distributed slack)</a:t>
             </a:r>
           </a:p>
           <a:p>
@@ -6726,8 +6586,8 @@
               <a:defRPr sz="1300"/>
             </a:pPr>
             <a:r>
-              <a:rPr dirty="0"/>
-              <a:t>Load per area: IEEE 14: MW  |  IEEE 39: MW</a:t>
+              <a:rPr lang="en-GB" dirty="0"/>
+              <a:t>Load: IEEE 14: 279.7 MW / 110.2 Mvar  |  IEEE 39: 6641.5 MW / 2113.4 Mvar</a:t>
             </a:r>
           </a:p>
           <a:p>
@@ -6740,14 +6600,23 @@
               <a:defRPr sz="1300"/>
             </a:pPr>
             <a:r>
-              <a:rPr dirty="0"/>
-              <a:t>Bus voltages</a:t>
-            </a:r>
-            <a:r>
-              <a:rPr lang="fr-FR" dirty="0"/>
-              <a:t>:</a:t>
-            </a:r>
-            <a:endParaRPr dirty="0"/>
+              <a:rPr lang="en-GB" dirty="0"/>
+              <a:t>Bus voltages: 0.94–1.06 p.u.; largest drop from S1 −0.070 p.u. at B102 (IEEE 14)</a:t>
+            </a:r>
+          </a:p>
+          <a:p>
+            <a:pPr marL="285750" indent="-285750">
+              <a:spcAft>
+                <a:spcPts val="400"/>
+              </a:spcAft>
+              <a:buFont typeface="Arial" panose="020B0604020202020204" pitchFamily="34" charset="0"/>
+              <a:buChar char="•"/>
+              <a:defRPr sz="1300"/>
+            </a:pPr>
+            <a:r>
+              <a:rPr lang="en-GB" dirty="0"/>
+              <a:t>Overloads: L-16-19-1 162 %, L-101-102-1 118 %, L-6-11-1 106 %, L-10-11-1 103 %</a:t>
+            </a:r>
           </a:p>
         </p:txBody>
       </p:sp>

</xml_diff>

<commit_message>
docs(docs): add a bus coordinates slide to the scenario presentation
</commit_message>
<xml_diff>
--- a/docs/scenarios_presentation.pptx
+++ b/docs/scenarios_presentation.pptx
@@ -7,10 +7,11 @@
   <p:sldIdLst>
     <p:sldId id="256" r:id="rId5"/>
     <p:sldId id="2146847177" r:id="rId6"/>
-    <p:sldId id="257" r:id="rId7"/>
-    <p:sldId id="258" r:id="rId8"/>
-    <p:sldId id="259" r:id="rId9"/>
-    <p:sldId id="260" r:id="rId10"/>
+    <p:sldId id="2146847179" r:id="rId7"/>
+    <p:sldId id="257" r:id="rId8"/>
+    <p:sldId id="258" r:id="rId9"/>
+    <p:sldId id="259" r:id="rId10"/>
+    <p:sldId id="260" r:id="rId11"/>
   </p:sldIdLst>
   <p:sldSz cx="12188825" cy="6858000"/>
   <p:notesSz cx="6858000" cy="9144000"/>
@@ -475,7 +476,7 @@
           <a:p>
             <a:fld id="{5BCAD085-E8A6-8845-BD4E-CB4CCA059FC4}" type="datetimeFigureOut">
               <a:rPr lang="en-US" smtClean="0"/>
-              <a:t>9/23/2026</a:t>
+              <a:t>10/28/2026</a:t>
             </a:fld>
             <a:endParaRPr lang="en-US"/>
           </a:p>
@@ -643,7 +644,7 @@
           <a:p>
             <a:fld id="{5BCAD085-E8A6-8845-BD4E-CB4CCA059FC4}" type="datetimeFigureOut">
               <a:rPr lang="en-US" smtClean="0"/>
-              <a:t>9/23/2026</a:t>
+              <a:t>10/28/2026</a:t>
             </a:fld>
             <a:endParaRPr lang="en-US"/>
           </a:p>
@@ -821,7 +822,7 @@
           <a:p>
             <a:fld id="{5BCAD085-E8A6-8845-BD4E-CB4CCA059FC4}" type="datetimeFigureOut">
               <a:rPr lang="en-US" smtClean="0"/>
-              <a:t>9/23/2026</a:t>
+              <a:t>10/28/2026</a:t>
             </a:fld>
             <a:endParaRPr lang="en-US"/>
           </a:p>
@@ -989,7 +990,7 @@
           <a:p>
             <a:fld id="{5BCAD085-E8A6-8845-BD4E-CB4CCA059FC4}" type="datetimeFigureOut">
               <a:rPr lang="en-US" smtClean="0"/>
-              <a:t>9/23/2026</a:t>
+              <a:t>10/28/2026</a:t>
             </a:fld>
             <a:endParaRPr lang="en-US"/>
           </a:p>
@@ -1234,7 +1235,7 @@
           <a:p>
             <a:fld id="{5BCAD085-E8A6-8845-BD4E-CB4CCA059FC4}" type="datetimeFigureOut">
               <a:rPr lang="en-US" smtClean="0"/>
-              <a:t>9/23/2026</a:t>
+              <a:t>10/28/2026</a:t>
             </a:fld>
             <a:endParaRPr lang="en-US"/>
           </a:p>
@@ -1519,7 +1520,7 @@
           <a:p>
             <a:fld id="{5BCAD085-E8A6-8845-BD4E-CB4CCA059FC4}" type="datetimeFigureOut">
               <a:rPr lang="en-US" smtClean="0"/>
-              <a:t>9/23/2026</a:t>
+              <a:t>10/28/2026</a:t>
             </a:fld>
             <a:endParaRPr lang="en-US"/>
           </a:p>
@@ -1938,7 +1939,7 @@
           <a:p>
             <a:fld id="{5BCAD085-E8A6-8845-BD4E-CB4CCA059FC4}" type="datetimeFigureOut">
               <a:rPr lang="en-US" smtClean="0"/>
-              <a:t>9/23/2026</a:t>
+              <a:t>10/28/2026</a:t>
             </a:fld>
             <a:endParaRPr lang="en-US"/>
           </a:p>
@@ -2055,7 +2056,7 @@
           <a:p>
             <a:fld id="{5BCAD085-E8A6-8845-BD4E-CB4CCA059FC4}" type="datetimeFigureOut">
               <a:rPr lang="en-US" smtClean="0"/>
-              <a:t>9/23/2026</a:t>
+              <a:t>10/28/2026</a:t>
             </a:fld>
             <a:endParaRPr lang="en-US"/>
           </a:p>
@@ -2150,7 +2151,7 @@
           <a:p>
             <a:fld id="{5BCAD085-E8A6-8845-BD4E-CB4CCA059FC4}" type="datetimeFigureOut">
               <a:rPr lang="en-US" smtClean="0"/>
-              <a:t>9/23/2026</a:t>
+              <a:t>10/28/2026</a:t>
             </a:fld>
             <a:endParaRPr lang="en-US"/>
           </a:p>
@@ -2425,7 +2426,7 @@
           <a:p>
             <a:fld id="{5BCAD085-E8A6-8845-BD4E-CB4CCA059FC4}" type="datetimeFigureOut">
               <a:rPr lang="en-US" smtClean="0"/>
-              <a:t>9/23/2026</a:t>
+              <a:t>10/28/2026</a:t>
             </a:fld>
             <a:endParaRPr lang="en-US"/>
           </a:p>
@@ -2677,7 +2678,7 @@
           <a:p>
             <a:fld id="{5BCAD085-E8A6-8845-BD4E-CB4CCA059FC4}" type="datetimeFigureOut">
               <a:rPr lang="en-US" smtClean="0"/>
-              <a:t>9/23/2026</a:t>
+              <a:t>10/28/2026</a:t>
             </a:fld>
             <a:endParaRPr lang="en-US"/>
           </a:p>
@@ -2888,7 +2889,7 @@
           <a:p>
             <a:fld id="{5BCAD085-E8A6-8845-BD4E-CB4CCA059FC4}" type="datetimeFigureOut">
               <a:rPr lang="en-US" smtClean="0"/>
-              <a:t>9/23/2026</a:t>
+              <a:t>10/28/2026</a:t>
             </a:fld>
             <a:endParaRPr lang="en-US"/>
           </a:p>
@@ -3929,7 +3930,7 @@
           <p:nvPr/>
         </p:nvPicPr>
         <p:blipFill>
-          <a:blip r:embed="rId3"/>
+          <a:blip r:embed="rId2"/>
           <a:srcRect l="1967" r="957" b="2727"/>
           <a:stretch>
             <a:fillRect/>
@@ -4184,14 +4185,14 @@
                                 </p:cTn>
                               </p:par>
                               <p:par>
-                                <p:cTn id="11" presetID="1" presetClass="entr" presetSubtype="0" fill="hold" grpId="0" nodeType="withEffect">
+                                <p:cTn id="9" presetID="1" presetClass="entr" presetSubtype="0" fill="hold" grpId="0" nodeType="withEffect">
                                   <p:stCondLst>
                                     <p:cond delay="0"/>
                                   </p:stCondLst>
                                   <p:childTnLst>
                                     <p:set>
                                       <p:cBhvr>
-                                        <p:cTn id="12" dur="1" fill="hold">
+                                        <p:cTn id="10" dur="1" fill="hold">
                                           <p:stCondLst>
                                             <p:cond delay="0"/>
                                           </p:stCondLst>
@@ -4246,6 +4247,653 @@
 </file>
 
 <file path=ppt/slides/slide3.xml><?xml version="1.0" encoding="utf-8"?>
+<p:sld xmlns:a="http://schemas.openxmlformats.org/drawingml/2006/main" xmlns:r="http://schemas.openxmlformats.org/officeDocument/2006/relationships" xmlns:p="http://schemas.openxmlformats.org/presentationml/2006/main">
+  <p:cSld>
+    <p:spTree>
+      <p:nvGrpSpPr>
+        <p:cNvPr id="1" name="">
+          <a:extLst>
+            <a:ext uri="{FF2B5EF4-FFF2-40B4-BE49-F238E27FC236}">
+              <a16:creationId xmlns:a16="http://schemas.microsoft.com/office/drawing/2014/main" id="{FC6B4ACF-8F9B-B5EE-A63C-E2179336C2EF}"/>
+            </a:ext>
+          </a:extLst>
+        </p:cNvPr>
+        <p:cNvGrpSpPr/>
+        <p:nvPr/>
+      </p:nvGrpSpPr>
+      <p:grpSpPr>
+        <a:xfrm>
+          <a:off x="0" y="0"/>
+          <a:ext cx="0" cy="0"/>
+          <a:chOff x="0" y="0"/>
+          <a:chExt cx="0" cy="0"/>
+        </a:xfrm>
+      </p:grpSpPr>
+      <p:sp>
+        <p:nvSpPr>
+          <p:cNvPr id="2" name="TextBox 1">
+            <a:extLst>
+              <a:ext uri="{FF2B5EF4-FFF2-40B4-BE49-F238E27FC236}">
+                <a16:creationId xmlns:a16="http://schemas.microsoft.com/office/drawing/2014/main" id="{03EE0303-883B-B8A7-FC76-DFF36B8CE6F7}"/>
+              </a:ext>
+            </a:extLst>
+          </p:cNvPr>
+          <p:cNvSpPr txBox="1"/>
+          <p:nvPr/>
+        </p:nvSpPr>
+        <p:spPr>
+          <a:xfrm>
+            <a:off x="365760" y="228600"/>
+            <a:ext cx="11430000" cy="523220"/>
+          </a:xfrm>
+          <a:prstGeom prst="rect">
+            <a:avLst/>
+          </a:prstGeom>
+          <a:noFill/>
+        </p:spPr>
+        <p:txBody>
+          <a:bodyPr wrap="square">
+            <a:spAutoFit/>
+          </a:bodyPr>
+          <a:lstStyle/>
+          <a:p>
+            <a:pPr>
+              <a:defRPr sz="2800" b="1">
+                <a:solidFill>
+                  <a:srgbClr val="1F3A5F"/>
+                </a:solidFill>
+              </a:defRPr>
+            </a:pPr>
+            <a:r>
+              <a:rPr lang="en-US" noProof="0" dirty="0"/>
+              <a:t>Buses coordinates</a:t>
+            </a:r>
+          </a:p>
+        </p:txBody>
+      </p:sp>
+      <p:pic>
+        <p:nvPicPr>
+          <p:cNvPr id="5" name="Image 4">
+            <a:extLst>
+              <a:ext uri="{FF2B5EF4-FFF2-40B4-BE49-F238E27FC236}">
+                <a16:creationId xmlns:a16="http://schemas.microsoft.com/office/drawing/2014/main" id="{D42A19E8-5D1A-BF84-37E6-2E3BD95E41FC}"/>
+              </a:ext>
+            </a:extLst>
+          </p:cNvPr>
+          <p:cNvPicPr>
+            <a:picLocks noChangeAspect="1"/>
+          </p:cNvPicPr>
+          <p:nvPr/>
+        </p:nvPicPr>
+        <p:blipFill>
+          <a:blip r:embed="rId2"/>
+          <a:stretch>
+            <a:fillRect/>
+          </a:stretch>
+        </p:blipFill>
+        <p:spPr>
+          <a:xfrm>
+            <a:off x="206846" y="1113591"/>
+            <a:ext cx="7201029" cy="5147469"/>
+          </a:xfrm>
+          <a:prstGeom prst="rect">
+            <a:avLst/>
+          </a:prstGeom>
+        </p:spPr>
+      </p:pic>
+      <p:sp>
+        <p:nvSpPr>
+          <p:cNvPr id="7" name="ZoneTexte 6">
+            <a:extLst>
+              <a:ext uri="{FF2B5EF4-FFF2-40B4-BE49-F238E27FC236}">
+                <a16:creationId xmlns:a16="http://schemas.microsoft.com/office/drawing/2014/main" id="{F00CD466-9F8D-AF21-94AB-E2DB523F94AF}"/>
+              </a:ext>
+            </a:extLst>
+          </p:cNvPr>
+          <p:cNvSpPr txBox="1"/>
+          <p:nvPr/>
+        </p:nvSpPr>
+        <p:spPr>
+          <a:xfrm>
+            <a:off x="7499315" y="1840665"/>
+            <a:ext cx="4814489" cy="3693319"/>
+          </a:xfrm>
+          <a:prstGeom prst="rect">
+            <a:avLst/>
+          </a:prstGeom>
+          <a:noFill/>
+        </p:spPr>
+        <p:txBody>
+          <a:bodyPr wrap="square">
+            <a:spAutoFit/>
+          </a:bodyPr>
+          <a:lstStyle/>
+          <a:p>
+            <a:pPr indent="0" algn="l">
+              <a:buNone/>
+            </a:pPr>
+            <a:r>
+              <a:rPr lang="fr-FR" sz="1800" b="0" i="0" dirty="0">
+                <a:solidFill>
+                  <a:schemeClr val="tx1"/>
+                </a:solidFill>
+                <a:effectLst/>
+                <a:latin typeface="+mn-lt"/>
+              </a:rPr>
+              <a:t>Every </a:t>
+            </a:r>
+            <a:r>
+              <a:rPr lang="fr-FR" sz="1800" b="0" i="0" dirty="0" err="1">
+                <a:solidFill>
+                  <a:schemeClr val="tx1"/>
+                </a:solidFill>
+                <a:effectLst/>
+                <a:latin typeface="+mn-lt"/>
+              </a:rPr>
+              <a:t>substation</a:t>
+            </a:r>
+            <a:r>
+              <a:rPr lang="fr-FR" sz="1800" b="0" i="0" dirty="0">
+                <a:solidFill>
+                  <a:schemeClr val="tx1"/>
+                </a:solidFill>
+                <a:effectLst/>
+                <a:latin typeface="+mn-lt"/>
+              </a:rPr>
+              <a:t> </a:t>
+            </a:r>
+            <a:r>
+              <a:rPr lang="fr-FR" sz="1800" b="0" i="0" dirty="0" err="1">
+                <a:solidFill>
+                  <a:schemeClr val="tx1"/>
+                </a:solidFill>
+                <a:effectLst/>
+                <a:latin typeface="+mn-lt"/>
+              </a:rPr>
+              <a:t>now</a:t>
+            </a:r>
+            <a:r>
+              <a:rPr lang="fr-FR" sz="1800" b="0" i="0" dirty="0">
+                <a:solidFill>
+                  <a:schemeClr val="tx1"/>
+                </a:solidFill>
+                <a:effectLst/>
+                <a:latin typeface="+mn-lt"/>
+              </a:rPr>
+              <a:t> has WGS84 </a:t>
+            </a:r>
+            <a:r>
+              <a:rPr lang="fr-FR" sz="1800" b="0" i="0" dirty="0" err="1">
+                <a:solidFill>
+                  <a:schemeClr val="tx1"/>
+                </a:solidFill>
+                <a:effectLst/>
+                <a:latin typeface="+mn-lt"/>
+              </a:rPr>
+              <a:t>coordinates</a:t>
+            </a:r>
+            <a:r>
+              <a:rPr lang="fr-FR" sz="1800" b="0" i="0" dirty="0">
+                <a:solidFill>
+                  <a:schemeClr val="tx1"/>
+                </a:solidFill>
+                <a:effectLst/>
+                <a:latin typeface="+mn-lt"/>
+              </a:rPr>
+              <a:t>:</a:t>
+            </a:r>
+          </a:p>
+          <a:p>
+            <a:pPr marL="342900" lvl="0" indent="-342900" algn="l">
+              <a:buFont typeface="Arial" panose="020B0604020202020204" pitchFamily="34" charset="0"/>
+              <a:buChar char="•"/>
+            </a:pPr>
+            <a:r>
+              <a:rPr lang="fr-FR" sz="1800" b="1" i="0" dirty="0">
+                <a:solidFill>
+                  <a:schemeClr val="tx1"/>
+                </a:solidFill>
+                <a:effectLst/>
+                <a:latin typeface="+mn-lt"/>
+              </a:rPr>
+              <a:t>IEEE 14</a:t>
+            </a:r>
+            <a:r>
+              <a:rPr lang="fr-FR" sz="1800" b="0" i="0" dirty="0">
+                <a:solidFill>
+                  <a:schemeClr val="tx1"/>
+                </a:solidFill>
+                <a:effectLst/>
+                <a:latin typeface="+mn-lt"/>
+              </a:rPr>
+              <a:t> (138 kV, cyan): </a:t>
+            </a:r>
+            <a:r>
+              <a:rPr lang="fr-FR" sz="1800" b="0" i="0" dirty="0" err="1">
+                <a:solidFill>
+                  <a:schemeClr val="tx1"/>
+                </a:solidFill>
+                <a:effectLst/>
+                <a:latin typeface="+mn-lt"/>
+              </a:rPr>
+              <a:t>south-east</a:t>
+            </a:r>
+            <a:r>
+              <a:rPr lang="fr-FR" sz="1800" b="0" i="0" dirty="0">
+                <a:solidFill>
+                  <a:schemeClr val="tx1"/>
+                </a:solidFill>
+                <a:effectLst/>
+                <a:latin typeface="+mn-lt"/>
+              </a:rPr>
+              <a:t> </a:t>
+            </a:r>
+            <a:r>
+              <a:rPr lang="fr-FR" sz="1800" b="0" i="0" dirty="0" err="1">
+                <a:solidFill>
+                  <a:schemeClr val="tx1"/>
+                </a:solidFill>
+                <a:effectLst/>
+                <a:latin typeface="+mn-lt"/>
+              </a:rPr>
+              <a:t>England</a:t>
+            </a:r>
+            <a:r>
+              <a:rPr lang="fr-FR" sz="1800" b="0" i="0" dirty="0">
+                <a:solidFill>
+                  <a:schemeClr val="tx1"/>
+                </a:solidFill>
+                <a:effectLst/>
+                <a:latin typeface="+mn-lt"/>
+              </a:rPr>
+              <a:t>, zone Z0</a:t>
+            </a:r>
+          </a:p>
+          <a:p>
+            <a:pPr marL="342900" lvl="0" indent="-342900" algn="l">
+              <a:buFont typeface="Arial" panose="020B0604020202020204" pitchFamily="34" charset="0"/>
+              <a:buChar char="•"/>
+            </a:pPr>
+            <a:r>
+              <a:rPr lang="fr-FR" sz="1800" b="1" i="0" dirty="0">
+                <a:solidFill>
+                  <a:schemeClr val="tx1"/>
+                </a:solidFill>
+                <a:effectLst/>
+                <a:latin typeface="+mn-lt"/>
+              </a:rPr>
+              <a:t>IEEE 39</a:t>
+            </a:r>
+            <a:r>
+              <a:rPr lang="fr-FR" sz="1800" b="0" i="0" dirty="0">
+                <a:solidFill>
+                  <a:schemeClr val="tx1"/>
+                </a:solidFill>
+                <a:effectLst/>
+                <a:latin typeface="+mn-lt"/>
+              </a:rPr>
+              <a:t> (345 kV, </a:t>
+            </a:r>
+            <a:r>
+              <a:rPr lang="fr-FR" sz="1800" b="0" i="0" dirty="0" err="1">
+                <a:solidFill>
+                  <a:schemeClr val="tx1"/>
+                </a:solidFill>
+                <a:effectLst/>
+                <a:latin typeface="+mn-lt"/>
+              </a:rPr>
+              <a:t>red</a:t>
+            </a:r>
+            <a:r>
+              <a:rPr lang="fr-FR" sz="1800" b="0" i="0" dirty="0">
+                <a:solidFill>
+                  <a:schemeClr val="tx1"/>
+                </a:solidFill>
+                <a:effectLst/>
+                <a:latin typeface="+mn-lt"/>
+              </a:rPr>
+              <a:t>): </a:t>
+            </a:r>
+            <a:r>
+              <a:rPr lang="fr-FR" sz="1800" b="0" i="0" dirty="0" err="1">
+                <a:solidFill>
+                  <a:schemeClr val="tx1"/>
+                </a:solidFill>
+                <a:effectLst/>
+                <a:latin typeface="+mn-lt"/>
+              </a:rPr>
+              <a:t>northern</a:t>
+            </a:r>
+            <a:r>
+              <a:rPr lang="fr-FR" sz="1800" b="0" i="0" dirty="0">
+                <a:solidFill>
+                  <a:schemeClr val="tx1"/>
+                </a:solidFill>
+                <a:effectLst/>
+                <a:latin typeface="+mn-lt"/>
+              </a:rPr>
+              <a:t> France (Z1), </a:t>
+            </a:r>
+            <a:r>
+              <a:rPr lang="fr-FR" sz="1800" b="0" i="0" dirty="0" err="1">
+                <a:solidFill>
+                  <a:schemeClr val="tx1"/>
+                </a:solidFill>
+                <a:effectLst/>
+                <a:latin typeface="+mn-lt"/>
+              </a:rPr>
+              <a:t>Belgium</a:t>
+            </a:r>
+            <a:r>
+              <a:rPr lang="fr-FR" sz="1800" b="0" i="0" dirty="0">
+                <a:solidFill>
+                  <a:schemeClr val="tx1"/>
+                </a:solidFill>
+                <a:effectLst/>
+                <a:latin typeface="+mn-lt"/>
+              </a:rPr>
+              <a:t> (Z2) and the </a:t>
+            </a:r>
+            <a:r>
+              <a:rPr lang="fr-FR" sz="1800" b="0" i="0" dirty="0" err="1">
+                <a:solidFill>
+                  <a:schemeClr val="tx1"/>
+                </a:solidFill>
+                <a:effectLst/>
+                <a:latin typeface="+mn-lt"/>
+              </a:rPr>
+              <a:t>Netherlands</a:t>
+            </a:r>
+            <a:r>
+              <a:rPr lang="fr-FR" sz="1800" b="0" i="0" dirty="0">
+                <a:solidFill>
+                  <a:schemeClr val="tx1"/>
+                </a:solidFill>
+                <a:effectLst/>
+                <a:latin typeface="+mn-lt"/>
+              </a:rPr>
+              <a:t> (Z3)</a:t>
+            </a:r>
+          </a:p>
+          <a:p>
+            <a:pPr marL="342900" lvl="0" indent="-342900" algn="l">
+              <a:buFont typeface="Arial" panose="020B0604020202020204" pitchFamily="34" charset="0"/>
+              <a:buChar char="•"/>
+            </a:pPr>
+            <a:r>
+              <a:rPr lang="fr-FR" sz="1800" b="1" i="0" dirty="0">
+                <a:solidFill>
+                  <a:schemeClr val="tx1"/>
+                </a:solidFill>
+                <a:effectLst/>
+                <a:latin typeface="+mn-lt"/>
+              </a:rPr>
+              <a:t>HVDC </a:t>
+            </a:r>
+            <a:r>
+              <a:rPr lang="fr-FR" sz="1800" b="1" i="0" dirty="0" err="1">
+                <a:solidFill>
+                  <a:schemeClr val="tx1"/>
+                </a:solidFill>
+                <a:effectLst/>
+                <a:latin typeface="+mn-lt"/>
+              </a:rPr>
+              <a:t>link</a:t>
+            </a:r>
+            <a:r>
+              <a:rPr lang="fr-FR" sz="1800" b="0" i="0" dirty="0">
+                <a:solidFill>
+                  <a:schemeClr val="tx1"/>
+                </a:solidFill>
+                <a:effectLst/>
+                <a:latin typeface="+mn-lt"/>
+              </a:rPr>
+              <a:t> </a:t>
+            </a:r>
+            <a:r>
+              <a:rPr lang="fr-FR" sz="1800" b="0" i="0" dirty="0" err="1">
+                <a:solidFill>
+                  <a:schemeClr val="tx1"/>
+                </a:solidFill>
+                <a:effectLst/>
+                <a:latin typeface="+mn-lt"/>
+              </a:rPr>
+              <a:t>across</a:t>
+            </a:r>
+            <a:r>
+              <a:rPr lang="fr-FR" sz="1800" b="0" i="0" dirty="0">
+                <a:solidFill>
+                  <a:schemeClr val="tx1"/>
+                </a:solidFill>
+                <a:effectLst/>
+                <a:latin typeface="+mn-lt"/>
+              </a:rPr>
+              <a:t> the Strait of Dover, Gravelines → Folkestone (~80 km)</a:t>
+            </a:r>
+          </a:p>
+          <a:p>
+            <a:pPr indent="0" algn="l">
+              <a:buNone/>
+            </a:pPr>
+            <a:r>
+              <a:rPr lang="fr-FR" sz="1800" b="0" i="0" dirty="0">
+                <a:solidFill>
+                  <a:schemeClr val="tx1"/>
+                </a:solidFill>
+                <a:effectLst/>
+                <a:latin typeface="+mn-lt"/>
+              </a:rPr>
+              <a:t>The </a:t>
+            </a:r>
+            <a:r>
+              <a:rPr lang="fr-FR" sz="1800" b="0" i="0" dirty="0" err="1">
+                <a:solidFill>
+                  <a:schemeClr val="tx1"/>
+                </a:solidFill>
+                <a:effectLst/>
+                <a:latin typeface="+mn-lt"/>
+              </a:rPr>
+              <a:t>coordinates</a:t>
+            </a:r>
+            <a:r>
+              <a:rPr lang="fr-FR" sz="1800" b="0" i="0" dirty="0">
+                <a:solidFill>
+                  <a:schemeClr val="tx1"/>
+                </a:solidFill>
+                <a:effectLst/>
+                <a:latin typeface="+mn-lt"/>
+              </a:rPr>
+              <a:t> are indicative. They are not real </a:t>
+            </a:r>
+            <a:r>
+              <a:rPr lang="fr-FR" sz="1800" b="0" i="0" dirty="0" err="1">
+                <a:solidFill>
+                  <a:schemeClr val="tx1"/>
+                </a:solidFill>
+                <a:effectLst/>
+                <a:latin typeface="+mn-lt"/>
+              </a:rPr>
+              <a:t>substation</a:t>
+            </a:r>
+            <a:r>
+              <a:rPr lang="fr-FR" sz="1800" b="0" i="0" dirty="0">
+                <a:solidFill>
+                  <a:schemeClr val="tx1"/>
+                </a:solidFill>
+                <a:effectLst/>
+                <a:latin typeface="+mn-lt"/>
+              </a:rPr>
+              <a:t> sites, and the </a:t>
+            </a:r>
+            <a:r>
+              <a:rPr lang="fr-FR" sz="1800" b="0" i="0" dirty="0" err="1">
+                <a:solidFill>
+                  <a:schemeClr val="tx1"/>
+                </a:solidFill>
+                <a:effectLst/>
+                <a:latin typeface="+mn-lt"/>
+              </a:rPr>
+              <a:t>electrical</a:t>
+            </a:r>
+            <a:r>
+              <a:rPr lang="fr-FR" sz="1800" b="0" i="0" dirty="0">
+                <a:solidFill>
+                  <a:schemeClr val="tx1"/>
+                </a:solidFill>
+                <a:effectLst/>
+                <a:latin typeface="+mn-lt"/>
+              </a:rPr>
+              <a:t> model </a:t>
+            </a:r>
+            <a:r>
+              <a:rPr lang="fr-FR" sz="1800" b="0" i="0" dirty="0" err="1">
+                <a:solidFill>
+                  <a:schemeClr val="tx1"/>
+                </a:solidFill>
+                <a:effectLst/>
+                <a:latin typeface="+mn-lt"/>
+              </a:rPr>
+              <a:t>is</a:t>
+            </a:r>
+            <a:r>
+              <a:rPr lang="fr-FR" sz="1800" b="0" i="0" dirty="0">
+                <a:solidFill>
+                  <a:schemeClr val="tx1"/>
+                </a:solidFill>
+                <a:effectLst/>
+                <a:latin typeface="+mn-lt"/>
+              </a:rPr>
+              <a:t> </a:t>
+            </a:r>
+            <a:r>
+              <a:rPr lang="fr-FR" sz="1800" b="0" i="0" dirty="0" err="1">
+                <a:solidFill>
+                  <a:schemeClr val="tx1"/>
+                </a:solidFill>
+                <a:effectLst/>
+                <a:latin typeface="+mn-lt"/>
+              </a:rPr>
+              <a:t>unchanged</a:t>
+            </a:r>
+            <a:r>
+              <a:rPr lang="fr-FR" sz="1800" b="0" i="0" dirty="0">
+                <a:solidFill>
+                  <a:schemeClr val="tx1"/>
+                </a:solidFill>
+                <a:effectLst/>
+                <a:latin typeface="+mn-lt"/>
+              </a:rPr>
+              <a:t>.</a:t>
+            </a:r>
+          </a:p>
+          <a:p>
+            <a:pPr indent="0" algn="l">
+              <a:buNone/>
+            </a:pPr>
+            <a:r>
+              <a:rPr lang="fr-FR" sz="1800" b="0" i="0" dirty="0" err="1">
+                <a:solidFill>
+                  <a:schemeClr val="tx1"/>
+                </a:solidFill>
+                <a:effectLst/>
+                <a:latin typeface="+mn-lt"/>
+              </a:rPr>
+              <a:t>Shipped</a:t>
+            </a:r>
+            <a:r>
+              <a:rPr lang="fr-FR" sz="1800" b="0" i="0" dirty="0">
+                <a:solidFill>
+                  <a:schemeClr val="tx1"/>
+                </a:solidFill>
+                <a:effectLst/>
+                <a:latin typeface="+mn-lt"/>
+              </a:rPr>
+              <a:t> in the XIIDM files (</a:t>
+            </a:r>
+            <a:r>
+              <a:rPr lang="fr-FR" sz="1800" b="0" i="0" dirty="0" err="1">
+                <a:solidFill>
+                  <a:schemeClr val="tx1"/>
+                </a:solidFill>
+                <a:effectLst/>
+                <a:latin typeface="+mn-lt"/>
+              </a:rPr>
+              <a:t>substationPosition</a:t>
+            </a:r>
+            <a:r>
+              <a:rPr lang="fr-FR" sz="1800" b="0" i="0" dirty="0">
+                <a:solidFill>
+                  <a:schemeClr val="tx1"/>
+                </a:solidFill>
+                <a:effectLst/>
+                <a:latin typeface="+mn-lt"/>
+              </a:rPr>
+              <a:t> extension) and, for CGMES and </a:t>
+            </a:r>
+            <a:r>
+              <a:rPr lang="fr-FR" sz="1800" b="0" i="0" dirty="0" err="1">
+                <a:solidFill>
+                  <a:schemeClr val="tx1"/>
+                </a:solidFill>
+                <a:effectLst/>
+                <a:latin typeface="+mn-lt"/>
+              </a:rPr>
+              <a:t>PowerFactory</a:t>
+            </a:r>
+            <a:r>
+              <a:rPr lang="fr-FR" sz="1800" b="0" i="0" dirty="0">
+                <a:solidFill>
+                  <a:schemeClr val="tx1"/>
+                </a:solidFill>
+                <a:effectLst/>
+                <a:latin typeface="+mn-lt"/>
+              </a:rPr>
+              <a:t> </a:t>
+            </a:r>
+            <a:r>
+              <a:rPr lang="fr-FR" sz="1800" b="0" i="0" dirty="0" err="1">
+                <a:solidFill>
+                  <a:schemeClr val="tx1"/>
+                </a:solidFill>
+                <a:effectLst/>
+                <a:latin typeface="+mn-lt"/>
+              </a:rPr>
+              <a:t>users</a:t>
+            </a:r>
+            <a:r>
+              <a:rPr lang="fr-FR" sz="1800" b="0" i="0" dirty="0">
+                <a:solidFill>
+                  <a:schemeClr val="tx1"/>
+                </a:solidFill>
+                <a:effectLst/>
+                <a:latin typeface="+mn-lt"/>
+              </a:rPr>
+              <a:t>, in network/bus_coordinates.csv.</a:t>
+            </a:r>
+            <a:endParaRPr lang="fr-FR" sz="975" b="0" i="0" dirty="0">
+              <a:solidFill>
+                <a:srgbClr val="BFBFBF"/>
+              </a:solidFill>
+              <a:effectLst/>
+              <a:latin typeface="-apple-system"/>
+            </a:endParaRPr>
+          </a:p>
+        </p:txBody>
+      </p:sp>
+    </p:spTree>
+    <p:extLst>
+      <p:ext uri="{BB962C8B-B14F-4D97-AF65-F5344CB8AC3E}">
+        <p14:creationId xmlns:p14="http://schemas.microsoft.com/office/powerpoint/2010/main" val="2310324480"/>
+      </p:ext>
+    </p:extLst>
+  </p:cSld>
+  <p:clrMapOvr>
+    <a:masterClrMapping/>
+  </p:clrMapOvr>
+</p:sld>
+</file>
+
+<file path=ppt/slides/slide4.xml><?xml version="1.0" encoding="utf-8"?>
 <p:sld xmlns:a="http://schemas.openxmlformats.org/drawingml/2006/main" xmlns:r="http://schemas.openxmlformats.org/officeDocument/2006/relationships" xmlns:p="http://schemas.openxmlformats.org/presentationml/2006/main">
   <p:cSld>
     <p:spTree>
@@ -5580,356 +6228,6 @@
 </p:sld>
 </file>
 
-<file path=ppt/slides/slide4.xml><?xml version="1.0" encoding="utf-8"?>
-<p:sld xmlns:a="http://schemas.openxmlformats.org/drawingml/2006/main" xmlns:r="http://schemas.openxmlformats.org/officeDocument/2006/relationships" xmlns:p="http://schemas.openxmlformats.org/presentationml/2006/main">
-  <p:cSld>
-    <p:spTree>
-      <p:nvGrpSpPr>
-        <p:cNvPr id="1" name=""/>
-        <p:cNvGrpSpPr/>
-        <p:nvPr/>
-      </p:nvGrpSpPr>
-      <p:grpSpPr>
-        <a:xfrm>
-          <a:off x="0" y="0"/>
-          <a:ext cx="0" cy="0"/>
-          <a:chOff x="0" y="0"/>
-          <a:chExt cx="0" cy="0"/>
-        </a:xfrm>
-      </p:grpSpPr>
-      <p:sp>
-        <p:nvSpPr>
-          <p:cNvPr id="2" name="TextBox 1"/>
-          <p:cNvSpPr txBox="1"/>
-          <p:nvPr/>
-        </p:nvSpPr>
-        <p:spPr>
-          <a:xfrm>
-            <a:off x="365760" y="228600"/>
-            <a:ext cx="11430000" cy="738664"/>
-          </a:xfrm>
-          <a:prstGeom prst="rect">
-            <a:avLst/>
-          </a:prstGeom>
-          <a:noFill/>
-        </p:spPr>
-        <p:txBody>
-          <a:bodyPr wrap="square">
-            <a:spAutoFit/>
-          </a:bodyPr>
-          <a:lstStyle/>
-          <a:p>
-            <a:pPr>
-              <a:defRPr sz="2800" b="1">
-                <a:solidFill>
-                  <a:srgbClr val="1F3A5F"/>
-                </a:solidFill>
-              </a:defRPr>
-            </a:pPr>
-            <a:r>
-              <a:rPr lang="en-GB" dirty="0"/>
-              <a:t>Scenario S1: </a:t>
-            </a:r>
-            <a:r>
-              <a:rPr lang="en-GB" dirty="0" err="1"/>
-              <a:t>baseline</a:t>
-            </a:r>
-          </a:p>
-          <a:p>
-            <a:pPr>
-              <a:defRPr sz="1400" i="1">
-                <a:solidFill>
-                  <a:srgbClr val="555555"/>
-                </a:solidFill>
-              </a:defRPr>
-            </a:pPr>
-            <a:r>
-              <a:rPr lang="en-GB" dirty="0"/>
-              <a:t>Reference operating point · 2025-01-01T00:00:00Z</a:t>
-            </a:r>
-          </a:p>
-        </p:txBody>
-      </p:sp>
-      <p:sp>
-        <p:nvSpPr>
-          <p:cNvPr id="3" name="TextBox 2"/>
-          <p:cNvSpPr txBox="1"/>
-          <p:nvPr/>
-        </p:nvSpPr>
-        <p:spPr>
-          <a:xfrm>
-            <a:off x="365760" y="1280160"/>
-            <a:ext cx="11430000" cy="365760"/>
-          </a:xfrm>
-          <a:prstGeom prst="rect">
-            <a:avLst/>
-          </a:prstGeom>
-          <a:noFill/>
-        </p:spPr>
-        <p:txBody>
-          <a:bodyPr wrap="none">
-            <a:spAutoFit/>
-          </a:bodyPr>
-          <a:lstStyle/>
-          <a:p>
-            <a:pPr>
-              <a:defRPr sz="1600" b="1">
-                <a:solidFill>
-                  <a:srgbClr val="2E86AB"/>
-                </a:solidFill>
-              </a:defRPr>
-            </a:pPr>
-            <a:r>
-              <a:rPr dirty="0"/>
-              <a:t>How the scenario is built</a:t>
-            </a:r>
-          </a:p>
-        </p:txBody>
-      </p:sp>
-      <p:sp>
-        <p:nvSpPr>
-          <p:cNvPr id="4" name="TextBox 3"/>
-          <p:cNvSpPr txBox="1"/>
-          <p:nvPr/>
-        </p:nvSpPr>
-        <p:spPr>
-          <a:xfrm>
-            <a:off x="548640" y="1691640"/>
-            <a:ext cx="10972800" cy="574516"/>
-          </a:xfrm>
-          <a:prstGeom prst="rect">
-            <a:avLst/>
-          </a:prstGeom>
-          <a:noFill/>
-        </p:spPr>
-        <p:txBody>
-          <a:bodyPr wrap="square">
-            <a:spAutoFit/>
-          </a:bodyPr>
-          <a:lstStyle/>
-          <a:p>
-            <a:pPr marL="285750" indent="-285750">
-              <a:spcAft>
-                <a:spcPts val="400"/>
-              </a:spcAft>
-              <a:buFont typeface="Arial" panose="020B0604020202020204" pitchFamily="34" charset="0"/>
-              <a:buChar char="•"/>
-              <a:defRPr sz="1400"/>
-            </a:pPr>
-            <a:r>
-              <a:rPr lang="en-GB" dirty="0"/>
-              <a:t>Loads at their source values (× 1.00 on P and Q).</a:t>
-            </a:r>
-          </a:p>
-          <a:p>
-            <a:pPr marL="285750" indent="-285750">
-              <a:spcAft>
-                <a:spcPts val="400"/>
-              </a:spcAft>
-              <a:buFont typeface="Arial" panose="020B0604020202020204" pitchFamily="34" charset="0"/>
-              <a:buChar char="•"/>
-              <a:defRPr sz="1400"/>
-            </a:pPr>
-            <a:r>
-              <a:rPr lang="en-GB" dirty="0"/>
-              <a:t>RES units (wind, solar, hydro) at 50 % of nominal P.</a:t>
-            </a:r>
-          </a:p>
-          <a:p>
-            <a:pPr marL="285750" indent="-285750">
-              <a:spcAft>
-                <a:spcPts val="400"/>
-              </a:spcAft>
-              <a:buFont typeface="Arial" panose="020B0604020202020204" pitchFamily="34" charset="0"/>
-              <a:buChar char="•"/>
-              <a:defRPr sz="1400"/>
-            </a:pPr>
-            <a:r>
-              <a:rPr lang="en-GB" dirty="0"/>
-              <a:t>Other units in merit order within each AC island (ties in file order).</a:t>
-            </a:r>
-          </a:p>
-          <a:p>
-            <a:pPr marL="285750" indent="-285750">
-              <a:spcAft>
-                <a:spcPts val="400"/>
-              </a:spcAft>
-              <a:buFont typeface="Arial" panose="020B0604020202020204" pitchFamily="34" charset="0"/>
-              <a:buChar char="•"/>
-              <a:defRPr sz="1400"/>
-            </a:pPr>
-            <a:r>
-              <a:rPr lang="en-GB" dirty="0"/>
-              <a:t>HVDC link at 50 MW from IEEE 39 → IEEE 14.</a:t>
-            </a:r>
-          </a:p>
-          <a:p>
-            <a:pPr marL="285750" indent="-285750">
-              <a:spcAft>
-                <a:spcPts val="400"/>
-              </a:spcAft>
-              <a:buFont typeface="Arial" panose="020B0604020202020204" pitchFamily="34" charset="0"/>
-              <a:buChar char="•"/>
-              <a:defRPr sz="1400"/>
-            </a:pPr>
-            <a:r>
-              <a:rPr lang="en-GB" dirty="0"/>
-              <a:t>Batteries BAT-B6-1 and BAT-B106-1 idle (0 MW).</a:t>
-            </a:r>
-          </a:p>
-          <a:p>
-            <a:pPr marL="285750" indent="-285750">
-              <a:spcAft>
-                <a:spcPts val="400"/>
-              </a:spcAft>
-              <a:buFont typeface="Arial" panose="020B0604020202020204" pitchFamily="34" charset="0"/>
-              <a:buChar char="•"/>
-              <a:defRPr sz="1400"/>
-            </a:pPr>
-            <a:r>
-              <a:rPr lang="en-GB" dirty="0"/>
-              <a:t>Goal: clean reference state, no branch above 100 %, voltages in 0.90–1.10 p.u.</a:t>
-            </a:r>
-          </a:p>
-        </p:txBody>
-      </p:sp>
-      <p:sp>
-        <p:nvSpPr>
-          <p:cNvPr id="5" name="TextBox 4"/>
-          <p:cNvSpPr txBox="1"/>
-          <p:nvPr/>
-        </p:nvSpPr>
-        <p:spPr>
-          <a:xfrm>
-            <a:off x="365760" y="4023360"/>
-            <a:ext cx="11430000" cy="365760"/>
-          </a:xfrm>
-          <a:prstGeom prst="rect">
-            <a:avLst/>
-          </a:prstGeom>
-          <a:noFill/>
-        </p:spPr>
-        <p:txBody>
-          <a:bodyPr wrap="none">
-            <a:spAutoFit/>
-          </a:bodyPr>
-          <a:lstStyle/>
-          <a:p>
-            <a:pPr>
-              <a:defRPr sz="1600" b="1">
-                <a:solidFill>
-                  <a:srgbClr val="2E86AB"/>
-                </a:solidFill>
-              </a:defRPr>
-            </a:pPr>
-            <a:r>
-              <a:rPr lang="en-GB" dirty="0"/>
-              <a:t>Expected results after AC load flow (pypowsybl validation, not a HYNET tool result)</a:t>
-            </a:r>
-          </a:p>
-        </p:txBody>
-      </p:sp>
-      <p:sp>
-        <p:nvSpPr>
-          <p:cNvPr id="6" name="TextBox 5"/>
-          <p:cNvSpPr txBox="1"/>
-          <p:nvPr/>
-        </p:nvSpPr>
-        <p:spPr>
-          <a:xfrm>
-            <a:off x="548640" y="4434840"/>
-            <a:ext cx="10972800" cy="1046440"/>
-          </a:xfrm>
-          <a:prstGeom prst="rect">
-            <a:avLst/>
-          </a:prstGeom>
-          <a:noFill/>
-        </p:spPr>
-        <p:txBody>
-          <a:bodyPr wrap="square">
-            <a:spAutoFit/>
-          </a:bodyPr>
-          <a:lstStyle/>
-          <a:p>
-            <a:pPr marL="285750" indent="-285750">
-              <a:spcAft>
-                <a:spcPts val="400"/>
-              </a:spcAft>
-              <a:buFont typeface="Arial" panose="020B0604020202020204" pitchFamily="34" charset="0"/>
-              <a:buChar char="•"/>
-              <a:defRPr sz="1300"/>
-            </a:pPr>
-            <a:r>
-              <a:rPr lang="en-GB" dirty="0"/>
-              <a:t>HVDC: 50 MW (IEEE 39 → IEEE 14), maximum 60 MW</a:t>
-            </a:r>
-          </a:p>
-          <a:p>
-            <a:pPr marL="285750" indent="-285750">
-              <a:spcAft>
-                <a:spcPts val="400"/>
-              </a:spcAft>
-              <a:buFont typeface="Arial" panose="020B0604020202020204" pitchFamily="34" charset="0"/>
-              <a:buChar char="•"/>
-              <a:defRPr sz="1300"/>
-            </a:pPr>
-            <a:r>
-              <a:rPr lang="en-GB" dirty="0"/>
-              <a:t>Dispatched generation: IEEE 14: 209.0 MW  |  IEEE 39: 6199.5 MW (losses covered by the distributed slack)</a:t>
-            </a:r>
-          </a:p>
-          <a:p>
-            <a:pPr marL="285750" indent="-285750">
-              <a:spcAft>
-                <a:spcPts val="400"/>
-              </a:spcAft>
-              <a:buFont typeface="Arial" panose="020B0604020202020204" pitchFamily="34" charset="0"/>
-              <a:buChar char="•"/>
-              <a:defRPr sz="1300"/>
-            </a:pPr>
-            <a:r>
-              <a:rPr lang="en-GB" dirty="0"/>
-              <a:t>Load: IEEE 14: 259.0 MW / 73.5 Mvar  |  IEEE 39: 6149.5 MW / 1408.9 Mvar</a:t>
-            </a:r>
-          </a:p>
-          <a:p>
-            <a:pPr marL="285750" indent="-285750">
-              <a:spcAft>
-                <a:spcPts val="400"/>
-              </a:spcAft>
-              <a:buFont typeface="Arial" panose="020B0604020202020204" pitchFamily="34" charset="0"/>
-              <a:buChar char="•"/>
-              <a:defRPr sz="1300"/>
-            </a:pPr>
-            <a:r>
-              <a:rPr lang="en-GB" dirty="0"/>
-              <a:t>Bus voltages: 0.98–1.09 p.u.</a:t>
-            </a:r>
-          </a:p>
-          <a:p>
-            <a:pPr marL="285750" indent="-285750">
-              <a:spcAft>
-                <a:spcPts val="400"/>
-              </a:spcAft>
-              <a:buFont typeface="Arial" panose="020B0604020202020204" pitchFamily="34" charset="0"/>
-              <a:buChar char="•"/>
-              <a:defRPr sz="1300"/>
-            </a:pPr>
-            <a:r>
-              <a:rPr lang="en-GB" dirty="0"/>
-              <a:t>Highest branch loading: 92 % (T-10-32-1), no overload</a:t>
-            </a:r>
-          </a:p>
-        </p:txBody>
-      </p:sp>
-    </p:spTree>
-  </p:cSld>
-  <p:clrMapOvr>
-    <a:masterClrMapping/>
-  </p:clrMapOvr>
-</p:sld>
-</file>
-
 <file path=ppt/slides/slide5.xml><?xml version="1.0" encoding="utf-8"?>
 <p:sld xmlns:a="http://schemas.openxmlformats.org/drawingml/2006/main" xmlns:r="http://schemas.openxmlformats.org/officeDocument/2006/relationships" xmlns:p="http://schemas.openxmlformats.org/presentationml/2006/main">
   <p:cSld>
@@ -5978,11 +6276,11 @@
             </a:pPr>
             <a:r>
               <a:rPr lang="en-GB" dirty="0"/>
-              <a:t>Scenario S2: </a:t>
+              <a:t>Scenario S1: </a:t>
             </a:r>
             <a:r>
               <a:rPr lang="en-GB" dirty="0" err="1"/>
-              <a:t>high_res_low_demand</a:t>
+              <a:t>baseline</a:t>
             </a:r>
           </a:p>
           <a:p>
@@ -5995,7 +6293,7 @@
             </a:pPr>
             <a:r>
               <a:rPr lang="en-GB" dirty="0"/>
-              <a:t>High RES, low demand, HVDC at maximum · 2025-01-01T01:00:00Z</a:t>
+              <a:t>Reference operating point · 2025-01-01T00:00:00Z</a:t>
             </a:r>
           </a:p>
         </p:txBody>
@@ -6030,6 +6328,356 @@
               </a:defRPr>
             </a:pPr>
             <a:r>
+              <a:rPr dirty="0"/>
+              <a:t>How the scenario is built</a:t>
+            </a:r>
+          </a:p>
+        </p:txBody>
+      </p:sp>
+      <p:sp>
+        <p:nvSpPr>
+          <p:cNvPr id="4" name="TextBox 3"/>
+          <p:cNvSpPr txBox="1"/>
+          <p:nvPr/>
+        </p:nvSpPr>
+        <p:spPr>
+          <a:xfrm>
+            <a:off x="548640" y="1691640"/>
+            <a:ext cx="10972800" cy="574516"/>
+          </a:xfrm>
+          <a:prstGeom prst="rect">
+            <a:avLst/>
+          </a:prstGeom>
+          <a:noFill/>
+        </p:spPr>
+        <p:txBody>
+          <a:bodyPr wrap="square">
+            <a:spAutoFit/>
+          </a:bodyPr>
+          <a:lstStyle/>
+          <a:p>
+            <a:pPr marL="285750" indent="-285750">
+              <a:spcAft>
+                <a:spcPts val="400"/>
+              </a:spcAft>
+              <a:buFont typeface="Arial" panose="020B0604020202020204" pitchFamily="34" charset="0"/>
+              <a:buChar char="•"/>
+              <a:defRPr sz="1400"/>
+            </a:pPr>
+            <a:r>
+              <a:rPr lang="en-GB" dirty="0"/>
+              <a:t>Loads at their source values (× 1.00 on P and Q).</a:t>
+            </a:r>
+          </a:p>
+          <a:p>
+            <a:pPr marL="285750" indent="-285750">
+              <a:spcAft>
+                <a:spcPts val="400"/>
+              </a:spcAft>
+              <a:buFont typeface="Arial" panose="020B0604020202020204" pitchFamily="34" charset="0"/>
+              <a:buChar char="•"/>
+              <a:defRPr sz="1400"/>
+            </a:pPr>
+            <a:r>
+              <a:rPr lang="en-GB" dirty="0"/>
+              <a:t>RES units (wind, solar, hydro) at 50 % of nominal P.</a:t>
+            </a:r>
+          </a:p>
+          <a:p>
+            <a:pPr marL="285750" indent="-285750">
+              <a:spcAft>
+                <a:spcPts val="400"/>
+              </a:spcAft>
+              <a:buFont typeface="Arial" panose="020B0604020202020204" pitchFamily="34" charset="0"/>
+              <a:buChar char="•"/>
+              <a:defRPr sz="1400"/>
+            </a:pPr>
+            <a:r>
+              <a:rPr lang="en-GB" dirty="0"/>
+              <a:t>Other units in merit order within each AC island (ties in file order).</a:t>
+            </a:r>
+          </a:p>
+          <a:p>
+            <a:pPr marL="285750" indent="-285750">
+              <a:spcAft>
+                <a:spcPts val="400"/>
+              </a:spcAft>
+              <a:buFont typeface="Arial" panose="020B0604020202020204" pitchFamily="34" charset="0"/>
+              <a:buChar char="•"/>
+              <a:defRPr sz="1400"/>
+            </a:pPr>
+            <a:r>
+              <a:rPr lang="en-GB" dirty="0"/>
+              <a:t>HVDC link at 50 MW from IEEE 39 → IEEE 14.</a:t>
+            </a:r>
+          </a:p>
+          <a:p>
+            <a:pPr marL="285750" indent="-285750">
+              <a:spcAft>
+                <a:spcPts val="400"/>
+              </a:spcAft>
+              <a:buFont typeface="Arial" panose="020B0604020202020204" pitchFamily="34" charset="0"/>
+              <a:buChar char="•"/>
+              <a:defRPr sz="1400"/>
+            </a:pPr>
+            <a:r>
+              <a:rPr lang="en-GB" dirty="0"/>
+              <a:t>Batteries BAT-B6-1 and BAT-B106-1 idle (0 MW).</a:t>
+            </a:r>
+          </a:p>
+          <a:p>
+            <a:pPr marL="285750" indent="-285750">
+              <a:spcAft>
+                <a:spcPts val="400"/>
+              </a:spcAft>
+              <a:buFont typeface="Arial" panose="020B0604020202020204" pitchFamily="34" charset="0"/>
+              <a:buChar char="•"/>
+              <a:defRPr sz="1400"/>
+            </a:pPr>
+            <a:r>
+              <a:rPr lang="en-GB" dirty="0"/>
+              <a:t>Goal: clean reference state, no branch above 100 %, voltages in 0.90–1.10 p.u.</a:t>
+            </a:r>
+          </a:p>
+        </p:txBody>
+      </p:sp>
+      <p:sp>
+        <p:nvSpPr>
+          <p:cNvPr id="5" name="TextBox 4"/>
+          <p:cNvSpPr txBox="1"/>
+          <p:nvPr/>
+        </p:nvSpPr>
+        <p:spPr>
+          <a:xfrm>
+            <a:off x="365760" y="4023360"/>
+            <a:ext cx="11430000" cy="365760"/>
+          </a:xfrm>
+          <a:prstGeom prst="rect">
+            <a:avLst/>
+          </a:prstGeom>
+          <a:noFill/>
+        </p:spPr>
+        <p:txBody>
+          <a:bodyPr wrap="none">
+            <a:spAutoFit/>
+          </a:bodyPr>
+          <a:lstStyle/>
+          <a:p>
+            <a:pPr>
+              <a:defRPr sz="1600" b="1">
+                <a:solidFill>
+                  <a:srgbClr val="2E86AB"/>
+                </a:solidFill>
+              </a:defRPr>
+            </a:pPr>
+            <a:r>
+              <a:rPr lang="en-GB" dirty="0"/>
+              <a:t>Expected results after AC load flow (pypowsybl validation, not a HYNET tool result)</a:t>
+            </a:r>
+          </a:p>
+        </p:txBody>
+      </p:sp>
+      <p:sp>
+        <p:nvSpPr>
+          <p:cNvPr id="6" name="TextBox 5"/>
+          <p:cNvSpPr txBox="1"/>
+          <p:nvPr/>
+        </p:nvSpPr>
+        <p:spPr>
+          <a:xfrm>
+            <a:off x="548640" y="4434840"/>
+            <a:ext cx="10972800" cy="1046440"/>
+          </a:xfrm>
+          <a:prstGeom prst="rect">
+            <a:avLst/>
+          </a:prstGeom>
+          <a:noFill/>
+        </p:spPr>
+        <p:txBody>
+          <a:bodyPr wrap="square">
+            <a:spAutoFit/>
+          </a:bodyPr>
+          <a:lstStyle/>
+          <a:p>
+            <a:pPr marL="285750" indent="-285750">
+              <a:spcAft>
+                <a:spcPts val="400"/>
+              </a:spcAft>
+              <a:buFont typeface="Arial" panose="020B0604020202020204" pitchFamily="34" charset="0"/>
+              <a:buChar char="•"/>
+              <a:defRPr sz="1300"/>
+            </a:pPr>
+            <a:r>
+              <a:rPr lang="en-GB" dirty="0"/>
+              <a:t>HVDC: 50 MW (IEEE 39 → IEEE 14), maximum 60 MW</a:t>
+            </a:r>
+          </a:p>
+          <a:p>
+            <a:pPr marL="285750" indent="-285750">
+              <a:spcAft>
+                <a:spcPts val="400"/>
+              </a:spcAft>
+              <a:buFont typeface="Arial" panose="020B0604020202020204" pitchFamily="34" charset="0"/>
+              <a:buChar char="•"/>
+              <a:defRPr sz="1300"/>
+            </a:pPr>
+            <a:r>
+              <a:rPr lang="en-GB" dirty="0"/>
+              <a:t>Dispatched generation: IEEE 14: 209.0 MW  |  IEEE 39: 6199.5 MW (losses covered by the distributed slack)</a:t>
+            </a:r>
+          </a:p>
+          <a:p>
+            <a:pPr marL="285750" indent="-285750">
+              <a:spcAft>
+                <a:spcPts val="400"/>
+              </a:spcAft>
+              <a:buFont typeface="Arial" panose="020B0604020202020204" pitchFamily="34" charset="0"/>
+              <a:buChar char="•"/>
+              <a:defRPr sz="1300"/>
+            </a:pPr>
+            <a:r>
+              <a:rPr lang="en-GB" dirty="0"/>
+              <a:t>Load: IEEE 14: 259.0 MW / 73.5 Mvar  |  IEEE 39: 6149.5 MW / 1408.9 Mvar</a:t>
+            </a:r>
+          </a:p>
+          <a:p>
+            <a:pPr marL="285750" indent="-285750">
+              <a:spcAft>
+                <a:spcPts val="400"/>
+              </a:spcAft>
+              <a:buFont typeface="Arial" panose="020B0604020202020204" pitchFamily="34" charset="0"/>
+              <a:buChar char="•"/>
+              <a:defRPr sz="1300"/>
+            </a:pPr>
+            <a:r>
+              <a:rPr lang="en-GB" dirty="0"/>
+              <a:t>Bus voltages: 0.98–1.09 p.u.</a:t>
+            </a:r>
+          </a:p>
+          <a:p>
+            <a:pPr marL="285750" indent="-285750">
+              <a:spcAft>
+                <a:spcPts val="400"/>
+              </a:spcAft>
+              <a:buFont typeface="Arial" panose="020B0604020202020204" pitchFamily="34" charset="0"/>
+              <a:buChar char="•"/>
+              <a:defRPr sz="1300"/>
+            </a:pPr>
+            <a:r>
+              <a:rPr lang="en-GB" dirty="0"/>
+              <a:t>Highest branch loading: 92 % (T-10-32-1), no overload</a:t>
+            </a:r>
+          </a:p>
+        </p:txBody>
+      </p:sp>
+    </p:spTree>
+  </p:cSld>
+  <p:clrMapOvr>
+    <a:masterClrMapping/>
+  </p:clrMapOvr>
+</p:sld>
+</file>
+
+<file path=ppt/slides/slide6.xml><?xml version="1.0" encoding="utf-8"?>
+<p:sld xmlns:a="http://schemas.openxmlformats.org/drawingml/2006/main" xmlns:r="http://schemas.openxmlformats.org/officeDocument/2006/relationships" xmlns:p="http://schemas.openxmlformats.org/presentationml/2006/main">
+  <p:cSld>
+    <p:spTree>
+      <p:nvGrpSpPr>
+        <p:cNvPr id="1" name=""/>
+        <p:cNvGrpSpPr/>
+        <p:nvPr/>
+      </p:nvGrpSpPr>
+      <p:grpSpPr>
+        <a:xfrm>
+          <a:off x="0" y="0"/>
+          <a:ext cx="0" cy="0"/>
+          <a:chOff x="0" y="0"/>
+          <a:chExt cx="0" cy="0"/>
+        </a:xfrm>
+      </p:grpSpPr>
+      <p:sp>
+        <p:nvSpPr>
+          <p:cNvPr id="2" name="TextBox 1"/>
+          <p:cNvSpPr txBox="1"/>
+          <p:nvPr/>
+        </p:nvSpPr>
+        <p:spPr>
+          <a:xfrm>
+            <a:off x="365760" y="228600"/>
+            <a:ext cx="11430000" cy="738664"/>
+          </a:xfrm>
+          <a:prstGeom prst="rect">
+            <a:avLst/>
+          </a:prstGeom>
+          <a:noFill/>
+        </p:spPr>
+        <p:txBody>
+          <a:bodyPr wrap="square">
+            <a:spAutoFit/>
+          </a:bodyPr>
+          <a:lstStyle/>
+          <a:p>
+            <a:pPr>
+              <a:defRPr sz="2800" b="1">
+                <a:solidFill>
+                  <a:srgbClr val="1F3A5F"/>
+                </a:solidFill>
+              </a:defRPr>
+            </a:pPr>
+            <a:r>
+              <a:rPr lang="en-GB" dirty="0"/>
+              <a:t>Scenario S2: </a:t>
+            </a:r>
+            <a:r>
+              <a:rPr lang="en-GB" dirty="0" err="1"/>
+              <a:t>high_res_low_demand</a:t>
+            </a:r>
+          </a:p>
+          <a:p>
+            <a:pPr>
+              <a:defRPr sz="1400" i="1">
+                <a:solidFill>
+                  <a:srgbClr val="555555"/>
+                </a:solidFill>
+              </a:defRPr>
+            </a:pPr>
+            <a:r>
+              <a:rPr lang="en-GB" dirty="0"/>
+              <a:t>High RES, low demand, HVDC at maximum · 2025-01-01T01:00:00Z</a:t>
+            </a:r>
+          </a:p>
+        </p:txBody>
+      </p:sp>
+      <p:sp>
+        <p:nvSpPr>
+          <p:cNvPr id="3" name="TextBox 2"/>
+          <p:cNvSpPr txBox="1"/>
+          <p:nvPr/>
+        </p:nvSpPr>
+        <p:spPr>
+          <a:xfrm>
+            <a:off x="365760" y="1280160"/>
+            <a:ext cx="11430000" cy="365760"/>
+          </a:xfrm>
+          <a:prstGeom prst="rect">
+            <a:avLst/>
+          </a:prstGeom>
+          <a:noFill/>
+        </p:spPr>
+        <p:txBody>
+          <a:bodyPr wrap="none">
+            <a:spAutoFit/>
+          </a:bodyPr>
+          <a:lstStyle/>
+          <a:p>
+            <a:pPr>
+              <a:defRPr sz="1600" b="1">
+                <a:solidFill>
+                  <a:srgbClr val="2E86AB"/>
+                </a:solidFill>
+              </a:defRPr>
+            </a:pPr>
+            <a:r>
               <a:t>How the scenario is built</a:t>
             </a:r>
           </a:p>
@@ -6279,7 +6927,7 @@
 </p:sld>
 </file>
 
-<file path=ppt/slides/slide6.xml><?xml version="1.0" encoding="utf-8"?>
+<file path=ppt/slides/slide7.xml><?xml version="1.0" encoding="utf-8"?>
 <p:sld xmlns:a="http://schemas.openxmlformats.org/drawingml/2006/main" xmlns:r="http://schemas.openxmlformats.org/officeDocument/2006/relationships" xmlns:p="http://schemas.openxmlformats.org/presentationml/2006/main">
   <p:cSld>
     <p:spTree>
@@ -6949,6 +7597,26 @@
 </file>
 
 <file path=customXml/item1.xml><?xml version="1.0" encoding="utf-8"?>
+<p:properties xmlns:p="http://schemas.microsoft.com/office/2006/metadata/properties" xmlns:xsi="http://www.w3.org/2001/XMLSchema-instance" xmlns:pc="http://schemas.microsoft.com/office/infopath/2007/PartnerControls">
+  <documentManagement>
+    <TaxCatchAll xmlns="039c73dc-0ae7-4985-93c3-7057b4e6726f" xsi:nil="true"/>
+    <lcf76f155ced4ddcb4097134ff3c332f xmlns="8c84694f-e8fa-4c1d-8756-eb7f5d2c5c51">
+      <Terms xmlns="http://schemas.microsoft.com/office/infopath/2007/PartnerControls"/>
+    </lcf76f155ced4ddcb4097134ff3c332f>
+  </documentManagement>
+</p:properties>
+</file>
+
+<file path=customXml/item2.xml><?xml version="1.0" encoding="utf-8"?>
+<?mso-contentType ?>
+<FormTemplates xmlns="http://schemas.microsoft.com/sharepoint/v3/contenttype/forms">
+  <Display>DocumentLibraryForm</Display>
+  <Edit>DocumentLibraryForm</Edit>
+  <New>DocumentLibraryForm</New>
+</FormTemplates>
+</file>
+
+<file path=customXml/item3.xml><?xml version="1.0" encoding="utf-8"?>
 <ct:contentTypeSchema xmlns:ct="http://schemas.microsoft.com/office/2006/metadata/contentType" xmlns:ma="http://schemas.microsoft.com/office/2006/metadata/properties/metaAttributes" ct:_="" ma:_="" ma:contentTypeName="Document" ma:contentTypeID="0x01010007E8BEA08D219B439B85909DE82C7FED" ma:contentTypeVersion="13" ma:contentTypeDescription="Create a new document." ma:contentTypeScope="" ma:versionID="5c8b8e36f1041009dddbbe2f59e629c5">
   <xsd:schema xmlns:xsd="http://www.w3.org/2001/XMLSchema" xmlns:xs="http://www.w3.org/2001/XMLSchema" xmlns:p="http://schemas.microsoft.com/office/2006/metadata/properties" xmlns:ns2="8c84694f-e8fa-4c1d-8756-eb7f5d2c5c51" xmlns:ns3="039c73dc-0ae7-4985-93c3-7057b4e6726f" targetNamespace="http://schemas.microsoft.com/office/2006/metadata/properties" ma:root="true" ma:fieldsID="74426ec90bd82ef3e5365f0517753090" ns2:_="" ns3:_="">
     <xsd:import namespace="8c84694f-e8fa-4c1d-8756-eb7f5d2c5c51"/>
@@ -7155,27 +7823,32 @@
 </ct:contentTypeSchema>
 </file>
 
-<file path=customXml/item2.xml><?xml version="1.0" encoding="utf-8"?>
-<?mso-contentType ?>
-<FormTemplates xmlns="http://schemas.microsoft.com/sharepoint/v3/contenttype/forms">
-  <Display>DocumentLibraryForm</Display>
-  <Edit>DocumentLibraryForm</Edit>
-  <New>DocumentLibraryForm</New>
-</FormTemplates>
+<file path=customXml/itemProps1.xml><?xml version="1.0" encoding="utf-8"?>
+<ds:datastoreItem xmlns:ds="http://schemas.openxmlformats.org/officeDocument/2006/customXml" ds:itemID="{EAB24518-FB02-4EAA-9977-1609659082C5}">
+  <ds:schemaRefs>
+    <ds:schemaRef ds:uri="http://purl.org/dc/dcmitype/"/>
+    <ds:schemaRef ds:uri="http://purl.org/dc/terms/"/>
+    <ds:schemaRef ds:uri="8c84694f-e8fa-4c1d-8756-eb7f5d2c5c51"/>
+    <ds:schemaRef ds:uri="http://www.w3.org/XML/1998/namespace"/>
+    <ds:schemaRef ds:uri="http://purl.org/dc/elements/1.1/"/>
+    <ds:schemaRef ds:uri="http://schemas.microsoft.com/office/2006/metadata/properties"/>
+    <ds:schemaRef ds:uri="http://schemas.microsoft.com/office/2006/documentManagement/types"/>
+    <ds:schemaRef ds:uri="http://schemas.microsoft.com/office/infopath/2007/PartnerControls"/>
+    <ds:schemaRef ds:uri="http://schemas.openxmlformats.org/package/2006/metadata/core-properties"/>
+    <ds:schemaRef ds:uri="039c73dc-0ae7-4985-93c3-7057b4e6726f"/>
+  </ds:schemaRefs>
+</ds:datastoreItem>
 </file>
 
-<file path=customXml/item3.xml><?xml version="1.0" encoding="utf-8"?>
-<p:properties xmlns:p="http://schemas.microsoft.com/office/2006/metadata/properties" xmlns:xsi="http://www.w3.org/2001/XMLSchema-instance" xmlns:pc="http://schemas.microsoft.com/office/infopath/2007/PartnerControls">
-  <documentManagement>
-    <TaxCatchAll xmlns="039c73dc-0ae7-4985-93c3-7057b4e6726f" xsi:nil="true"/>
-    <lcf76f155ced4ddcb4097134ff3c332f xmlns="8c84694f-e8fa-4c1d-8756-eb7f5d2c5c51">
-      <Terms xmlns="http://schemas.microsoft.com/office/infopath/2007/PartnerControls"/>
-    </lcf76f155ced4ddcb4097134ff3c332f>
-  </documentManagement>
-</p:properties>
+<file path=customXml/itemProps2.xml><?xml version="1.0" encoding="utf-8"?>
+<ds:datastoreItem xmlns:ds="http://schemas.openxmlformats.org/officeDocument/2006/customXml" ds:itemID="{B37F9BB1-363E-418B-86A7-127D1D7BED93}">
+  <ds:schemaRefs>
+    <ds:schemaRef ds:uri="http://schemas.microsoft.com/sharepoint/v3/contenttype/forms"/>
+  </ds:schemaRefs>
+</ds:datastoreItem>
 </file>
 
-<file path=customXml/itemProps1.xml><?xml version="1.0" encoding="utf-8"?>
+<file path=customXml/itemProps3.xml><?xml version="1.0" encoding="utf-8"?>
 <ds:datastoreItem xmlns:ds="http://schemas.openxmlformats.org/officeDocument/2006/customXml" ds:itemID="{938DAF59-B3A2-485A-B955-738B77B71B94}">
   <ds:schemaRefs>
     <ds:schemaRef ds:uri="http://schemas.microsoft.com/office/2006/metadata/contentType"/>
@@ -7192,29 +7865,4 @@
     <ds:schemaRef ds:uri="http://schemas.microsoft.com/internal/obd"/>
   </ds:schemaRefs>
 </ds:datastoreItem>
-</file>
-
-<file path=customXml/itemProps2.xml><?xml version="1.0" encoding="utf-8"?>
-<ds:datastoreItem xmlns:ds="http://schemas.openxmlformats.org/officeDocument/2006/customXml" ds:itemID="{B37F9BB1-363E-418B-86A7-127D1D7BED93}">
-  <ds:schemaRefs>
-    <ds:schemaRef ds:uri="http://schemas.microsoft.com/sharepoint/v3/contenttype/forms"/>
-  </ds:schemaRefs>
-</ds:datastoreItem>
-</file>
-
-<file path=customXml/itemProps3.xml><?xml version="1.0" encoding="utf-8"?>
-<ds:datastoreItem xmlns:ds="http://schemas.openxmlformats.org/officeDocument/2006/customXml" ds:itemID="{EAB24518-FB02-4EAA-9977-1609659082C5}">
-  <ds:schemaRefs>
-    <ds:schemaRef ds:uri="http://purl.org/dc/dcmitype/"/>
-    <ds:schemaRef ds:uri="http://purl.org/dc/terms/"/>
-    <ds:schemaRef ds:uri="8c84694f-e8fa-4c1d-8756-eb7f5d2c5c51"/>
-    <ds:schemaRef ds:uri="http://www.w3.org/XML/1998/namespace"/>
-    <ds:schemaRef ds:uri="http://purl.org/dc/elements/1.1/"/>
-    <ds:schemaRef ds:uri="http://schemas.microsoft.com/office/2006/metadata/properties"/>
-    <ds:schemaRef ds:uri="http://schemas.microsoft.com/office/2006/documentManagement/types"/>
-    <ds:schemaRef ds:uri="http://schemas.microsoft.com/office/infopath/2007/PartnerControls"/>
-    <ds:schemaRef ds:uri="http://schemas.openxmlformats.org/package/2006/metadata/core-properties"/>
-    <ds:schemaRef ds:uri="039c73dc-0ae7-4985-93c3-7057b4e6726f"/>
-  </ds:schemaRefs>
-</ds:datastoreItem>
 </file>
</xml_diff>

<commit_message>
chore(testcase): publish from dev@0383471
</commit_message>
<xml_diff>
--- a/docs/scenarios_presentation.pptx
+++ b/docs/scenarios_presentation.pptx
@@ -7,10 +7,11 @@
   <p:sldIdLst>
     <p:sldId id="256" r:id="rId5"/>
     <p:sldId id="2146847177" r:id="rId6"/>
-    <p:sldId id="257" r:id="rId7"/>
-    <p:sldId id="258" r:id="rId8"/>
-    <p:sldId id="259" r:id="rId9"/>
-    <p:sldId id="260" r:id="rId10"/>
+    <p:sldId id="2146847179" r:id="rId7"/>
+    <p:sldId id="257" r:id="rId8"/>
+    <p:sldId id="258" r:id="rId9"/>
+    <p:sldId id="259" r:id="rId10"/>
+    <p:sldId id="260" r:id="rId11"/>
   </p:sldIdLst>
   <p:sldSz cx="12188825" cy="6858000"/>
   <p:notesSz cx="6858000" cy="9144000"/>
@@ -475,7 +476,7 @@
           <a:p>
             <a:fld id="{5BCAD085-E8A6-8845-BD4E-CB4CCA059FC4}" type="datetimeFigureOut">
               <a:rPr lang="en-US" smtClean="0"/>
-              <a:t>9/23/2026</a:t>
+              <a:t>10/28/2026</a:t>
             </a:fld>
             <a:endParaRPr lang="en-US"/>
           </a:p>
@@ -643,7 +644,7 @@
           <a:p>
             <a:fld id="{5BCAD085-E8A6-8845-BD4E-CB4CCA059FC4}" type="datetimeFigureOut">
               <a:rPr lang="en-US" smtClean="0"/>
-              <a:t>9/23/2026</a:t>
+              <a:t>10/28/2026</a:t>
             </a:fld>
             <a:endParaRPr lang="en-US"/>
           </a:p>
@@ -821,7 +822,7 @@
           <a:p>
             <a:fld id="{5BCAD085-E8A6-8845-BD4E-CB4CCA059FC4}" type="datetimeFigureOut">
               <a:rPr lang="en-US" smtClean="0"/>
-              <a:t>9/23/2026</a:t>
+              <a:t>10/28/2026</a:t>
             </a:fld>
             <a:endParaRPr lang="en-US"/>
           </a:p>
@@ -989,7 +990,7 @@
           <a:p>
             <a:fld id="{5BCAD085-E8A6-8845-BD4E-CB4CCA059FC4}" type="datetimeFigureOut">
               <a:rPr lang="en-US" smtClean="0"/>
-              <a:t>9/23/2026</a:t>
+              <a:t>10/28/2026</a:t>
             </a:fld>
             <a:endParaRPr lang="en-US"/>
           </a:p>
@@ -1234,7 +1235,7 @@
           <a:p>
             <a:fld id="{5BCAD085-E8A6-8845-BD4E-CB4CCA059FC4}" type="datetimeFigureOut">
               <a:rPr lang="en-US" smtClean="0"/>
-              <a:t>9/23/2026</a:t>
+              <a:t>10/28/2026</a:t>
             </a:fld>
             <a:endParaRPr lang="en-US"/>
           </a:p>
@@ -1519,7 +1520,7 @@
           <a:p>
             <a:fld id="{5BCAD085-E8A6-8845-BD4E-CB4CCA059FC4}" type="datetimeFigureOut">
               <a:rPr lang="en-US" smtClean="0"/>
-              <a:t>9/23/2026</a:t>
+              <a:t>10/28/2026</a:t>
             </a:fld>
             <a:endParaRPr lang="en-US"/>
           </a:p>
@@ -1938,7 +1939,7 @@
           <a:p>
             <a:fld id="{5BCAD085-E8A6-8845-BD4E-CB4CCA059FC4}" type="datetimeFigureOut">
               <a:rPr lang="en-US" smtClean="0"/>
-              <a:t>9/23/2026</a:t>
+              <a:t>10/28/2026</a:t>
             </a:fld>
             <a:endParaRPr lang="en-US"/>
           </a:p>
@@ -2055,7 +2056,7 @@
           <a:p>
             <a:fld id="{5BCAD085-E8A6-8845-BD4E-CB4CCA059FC4}" type="datetimeFigureOut">
               <a:rPr lang="en-US" smtClean="0"/>
-              <a:t>9/23/2026</a:t>
+              <a:t>10/28/2026</a:t>
             </a:fld>
             <a:endParaRPr lang="en-US"/>
           </a:p>
@@ -2150,7 +2151,7 @@
           <a:p>
             <a:fld id="{5BCAD085-E8A6-8845-BD4E-CB4CCA059FC4}" type="datetimeFigureOut">
               <a:rPr lang="en-US" smtClean="0"/>
-              <a:t>9/23/2026</a:t>
+              <a:t>10/28/2026</a:t>
             </a:fld>
             <a:endParaRPr lang="en-US"/>
           </a:p>
@@ -2425,7 +2426,7 @@
           <a:p>
             <a:fld id="{5BCAD085-E8A6-8845-BD4E-CB4CCA059FC4}" type="datetimeFigureOut">
               <a:rPr lang="en-US" smtClean="0"/>
-              <a:t>9/23/2026</a:t>
+              <a:t>10/28/2026</a:t>
             </a:fld>
             <a:endParaRPr lang="en-US"/>
           </a:p>
@@ -2677,7 +2678,7 @@
           <a:p>
             <a:fld id="{5BCAD085-E8A6-8845-BD4E-CB4CCA059FC4}" type="datetimeFigureOut">
               <a:rPr lang="en-US" smtClean="0"/>
-              <a:t>9/23/2026</a:t>
+              <a:t>10/28/2026</a:t>
             </a:fld>
             <a:endParaRPr lang="en-US"/>
           </a:p>
@@ -2888,7 +2889,7 @@
           <a:p>
             <a:fld id="{5BCAD085-E8A6-8845-BD4E-CB4CCA059FC4}" type="datetimeFigureOut">
               <a:rPr lang="en-US" smtClean="0"/>
-              <a:t>9/23/2026</a:t>
+              <a:t>10/28/2026</a:t>
             </a:fld>
             <a:endParaRPr lang="en-US"/>
           </a:p>
@@ -3929,7 +3930,7 @@
           <p:nvPr/>
         </p:nvPicPr>
         <p:blipFill>
-          <a:blip r:embed="rId3"/>
+          <a:blip r:embed="rId2"/>
           <a:srcRect l="1967" r="957" b="2727"/>
           <a:stretch>
             <a:fillRect/>
@@ -4184,14 +4185,14 @@
                                 </p:cTn>
                               </p:par>
                               <p:par>
-                                <p:cTn id="11" presetID="1" presetClass="entr" presetSubtype="0" fill="hold" grpId="0" nodeType="withEffect">
+                                <p:cTn id="9" presetID="1" presetClass="entr" presetSubtype="0" fill="hold" grpId="0" nodeType="withEffect">
                                   <p:stCondLst>
                                     <p:cond delay="0"/>
                                   </p:stCondLst>
                                   <p:childTnLst>
                                     <p:set>
                                       <p:cBhvr>
-                                        <p:cTn id="12" dur="1" fill="hold">
+                                        <p:cTn id="10" dur="1" fill="hold">
                                           <p:stCondLst>
                                             <p:cond delay="0"/>
                                           </p:stCondLst>
@@ -4246,6 +4247,653 @@
 </file>
 
 <file path=ppt/slides/slide3.xml><?xml version="1.0" encoding="utf-8"?>
+<p:sld xmlns:a="http://schemas.openxmlformats.org/drawingml/2006/main" xmlns:r="http://schemas.openxmlformats.org/officeDocument/2006/relationships" xmlns:p="http://schemas.openxmlformats.org/presentationml/2006/main">
+  <p:cSld>
+    <p:spTree>
+      <p:nvGrpSpPr>
+        <p:cNvPr id="1" name="">
+          <a:extLst>
+            <a:ext uri="{FF2B5EF4-FFF2-40B4-BE49-F238E27FC236}">
+              <a16:creationId xmlns:a16="http://schemas.microsoft.com/office/drawing/2014/main" id="{FC6B4ACF-8F9B-B5EE-A63C-E2179336C2EF}"/>
+            </a:ext>
+          </a:extLst>
+        </p:cNvPr>
+        <p:cNvGrpSpPr/>
+        <p:nvPr/>
+      </p:nvGrpSpPr>
+      <p:grpSpPr>
+        <a:xfrm>
+          <a:off x="0" y="0"/>
+          <a:ext cx="0" cy="0"/>
+          <a:chOff x="0" y="0"/>
+          <a:chExt cx="0" cy="0"/>
+        </a:xfrm>
+      </p:grpSpPr>
+      <p:sp>
+        <p:nvSpPr>
+          <p:cNvPr id="2" name="TextBox 1">
+            <a:extLst>
+              <a:ext uri="{FF2B5EF4-FFF2-40B4-BE49-F238E27FC236}">
+                <a16:creationId xmlns:a16="http://schemas.microsoft.com/office/drawing/2014/main" id="{03EE0303-883B-B8A7-FC76-DFF36B8CE6F7}"/>
+              </a:ext>
+            </a:extLst>
+          </p:cNvPr>
+          <p:cNvSpPr txBox="1"/>
+          <p:nvPr/>
+        </p:nvSpPr>
+        <p:spPr>
+          <a:xfrm>
+            <a:off x="365760" y="228600"/>
+            <a:ext cx="11430000" cy="523220"/>
+          </a:xfrm>
+          <a:prstGeom prst="rect">
+            <a:avLst/>
+          </a:prstGeom>
+          <a:noFill/>
+        </p:spPr>
+        <p:txBody>
+          <a:bodyPr wrap="square">
+            <a:spAutoFit/>
+          </a:bodyPr>
+          <a:lstStyle/>
+          <a:p>
+            <a:pPr>
+              <a:defRPr sz="2800" b="1">
+                <a:solidFill>
+                  <a:srgbClr val="1F3A5F"/>
+                </a:solidFill>
+              </a:defRPr>
+            </a:pPr>
+            <a:r>
+              <a:rPr lang="en-US" noProof="0" dirty="0"/>
+              <a:t>Buses coordinates</a:t>
+            </a:r>
+          </a:p>
+        </p:txBody>
+      </p:sp>
+      <p:pic>
+        <p:nvPicPr>
+          <p:cNvPr id="5" name="Image 4">
+            <a:extLst>
+              <a:ext uri="{FF2B5EF4-FFF2-40B4-BE49-F238E27FC236}">
+                <a16:creationId xmlns:a16="http://schemas.microsoft.com/office/drawing/2014/main" id="{D42A19E8-5D1A-BF84-37E6-2E3BD95E41FC}"/>
+              </a:ext>
+            </a:extLst>
+          </p:cNvPr>
+          <p:cNvPicPr>
+            <a:picLocks noChangeAspect="1"/>
+          </p:cNvPicPr>
+          <p:nvPr/>
+        </p:nvPicPr>
+        <p:blipFill>
+          <a:blip r:embed="rId2"/>
+          <a:stretch>
+            <a:fillRect/>
+          </a:stretch>
+        </p:blipFill>
+        <p:spPr>
+          <a:xfrm>
+            <a:off x="206846" y="1113591"/>
+            <a:ext cx="7201029" cy="5147469"/>
+          </a:xfrm>
+          <a:prstGeom prst="rect">
+            <a:avLst/>
+          </a:prstGeom>
+        </p:spPr>
+      </p:pic>
+      <p:sp>
+        <p:nvSpPr>
+          <p:cNvPr id="7" name="ZoneTexte 6">
+            <a:extLst>
+              <a:ext uri="{FF2B5EF4-FFF2-40B4-BE49-F238E27FC236}">
+                <a16:creationId xmlns:a16="http://schemas.microsoft.com/office/drawing/2014/main" id="{F00CD466-9F8D-AF21-94AB-E2DB523F94AF}"/>
+              </a:ext>
+            </a:extLst>
+          </p:cNvPr>
+          <p:cNvSpPr txBox="1"/>
+          <p:nvPr/>
+        </p:nvSpPr>
+        <p:spPr>
+          <a:xfrm>
+            <a:off x="7499315" y="1840665"/>
+            <a:ext cx="4814489" cy="3693319"/>
+          </a:xfrm>
+          <a:prstGeom prst="rect">
+            <a:avLst/>
+          </a:prstGeom>
+          <a:noFill/>
+        </p:spPr>
+        <p:txBody>
+          <a:bodyPr wrap="square">
+            <a:spAutoFit/>
+          </a:bodyPr>
+          <a:lstStyle/>
+          <a:p>
+            <a:pPr indent="0" algn="l">
+              <a:buNone/>
+            </a:pPr>
+            <a:r>
+              <a:rPr lang="fr-FR" sz="1800" b="0" i="0" dirty="0">
+                <a:solidFill>
+                  <a:schemeClr val="tx1"/>
+                </a:solidFill>
+                <a:effectLst/>
+                <a:latin typeface="+mn-lt"/>
+              </a:rPr>
+              <a:t>Every </a:t>
+            </a:r>
+            <a:r>
+              <a:rPr lang="fr-FR" sz="1800" b="0" i="0" dirty="0" err="1">
+                <a:solidFill>
+                  <a:schemeClr val="tx1"/>
+                </a:solidFill>
+                <a:effectLst/>
+                <a:latin typeface="+mn-lt"/>
+              </a:rPr>
+              <a:t>substation</a:t>
+            </a:r>
+            <a:r>
+              <a:rPr lang="fr-FR" sz="1800" b="0" i="0" dirty="0">
+                <a:solidFill>
+                  <a:schemeClr val="tx1"/>
+                </a:solidFill>
+                <a:effectLst/>
+                <a:latin typeface="+mn-lt"/>
+              </a:rPr>
+              <a:t> </a:t>
+            </a:r>
+            <a:r>
+              <a:rPr lang="fr-FR" sz="1800" b="0" i="0" dirty="0" err="1">
+                <a:solidFill>
+                  <a:schemeClr val="tx1"/>
+                </a:solidFill>
+                <a:effectLst/>
+                <a:latin typeface="+mn-lt"/>
+              </a:rPr>
+              <a:t>now</a:t>
+            </a:r>
+            <a:r>
+              <a:rPr lang="fr-FR" sz="1800" b="0" i="0" dirty="0">
+                <a:solidFill>
+                  <a:schemeClr val="tx1"/>
+                </a:solidFill>
+                <a:effectLst/>
+                <a:latin typeface="+mn-lt"/>
+              </a:rPr>
+              <a:t> has WGS84 </a:t>
+            </a:r>
+            <a:r>
+              <a:rPr lang="fr-FR" sz="1800" b="0" i="0" dirty="0" err="1">
+                <a:solidFill>
+                  <a:schemeClr val="tx1"/>
+                </a:solidFill>
+                <a:effectLst/>
+                <a:latin typeface="+mn-lt"/>
+              </a:rPr>
+              <a:t>coordinates</a:t>
+            </a:r>
+            <a:r>
+              <a:rPr lang="fr-FR" sz="1800" b="0" i="0" dirty="0">
+                <a:solidFill>
+                  <a:schemeClr val="tx1"/>
+                </a:solidFill>
+                <a:effectLst/>
+                <a:latin typeface="+mn-lt"/>
+              </a:rPr>
+              <a:t>:</a:t>
+            </a:r>
+          </a:p>
+          <a:p>
+            <a:pPr marL="342900" lvl="0" indent="-342900" algn="l">
+              <a:buFont typeface="Arial" panose="020B0604020202020204" pitchFamily="34" charset="0"/>
+              <a:buChar char="•"/>
+            </a:pPr>
+            <a:r>
+              <a:rPr lang="fr-FR" sz="1800" b="1" i="0" dirty="0">
+                <a:solidFill>
+                  <a:schemeClr val="tx1"/>
+                </a:solidFill>
+                <a:effectLst/>
+                <a:latin typeface="+mn-lt"/>
+              </a:rPr>
+              <a:t>IEEE 14</a:t>
+            </a:r>
+            <a:r>
+              <a:rPr lang="fr-FR" sz="1800" b="0" i="0" dirty="0">
+                <a:solidFill>
+                  <a:schemeClr val="tx1"/>
+                </a:solidFill>
+                <a:effectLst/>
+                <a:latin typeface="+mn-lt"/>
+              </a:rPr>
+              <a:t> (138 kV, cyan): </a:t>
+            </a:r>
+            <a:r>
+              <a:rPr lang="fr-FR" sz="1800" b="0" i="0" dirty="0" err="1">
+                <a:solidFill>
+                  <a:schemeClr val="tx1"/>
+                </a:solidFill>
+                <a:effectLst/>
+                <a:latin typeface="+mn-lt"/>
+              </a:rPr>
+              <a:t>south-east</a:t>
+            </a:r>
+            <a:r>
+              <a:rPr lang="fr-FR" sz="1800" b="0" i="0" dirty="0">
+                <a:solidFill>
+                  <a:schemeClr val="tx1"/>
+                </a:solidFill>
+                <a:effectLst/>
+                <a:latin typeface="+mn-lt"/>
+              </a:rPr>
+              <a:t> </a:t>
+            </a:r>
+            <a:r>
+              <a:rPr lang="fr-FR" sz="1800" b="0" i="0" dirty="0" err="1">
+                <a:solidFill>
+                  <a:schemeClr val="tx1"/>
+                </a:solidFill>
+                <a:effectLst/>
+                <a:latin typeface="+mn-lt"/>
+              </a:rPr>
+              <a:t>England</a:t>
+            </a:r>
+            <a:r>
+              <a:rPr lang="fr-FR" sz="1800" b="0" i="0" dirty="0">
+                <a:solidFill>
+                  <a:schemeClr val="tx1"/>
+                </a:solidFill>
+                <a:effectLst/>
+                <a:latin typeface="+mn-lt"/>
+              </a:rPr>
+              <a:t>, zone Z0</a:t>
+            </a:r>
+          </a:p>
+          <a:p>
+            <a:pPr marL="342900" lvl="0" indent="-342900" algn="l">
+              <a:buFont typeface="Arial" panose="020B0604020202020204" pitchFamily="34" charset="0"/>
+              <a:buChar char="•"/>
+            </a:pPr>
+            <a:r>
+              <a:rPr lang="fr-FR" sz="1800" b="1" i="0" dirty="0">
+                <a:solidFill>
+                  <a:schemeClr val="tx1"/>
+                </a:solidFill>
+                <a:effectLst/>
+                <a:latin typeface="+mn-lt"/>
+              </a:rPr>
+              <a:t>IEEE 39</a:t>
+            </a:r>
+            <a:r>
+              <a:rPr lang="fr-FR" sz="1800" b="0" i="0" dirty="0">
+                <a:solidFill>
+                  <a:schemeClr val="tx1"/>
+                </a:solidFill>
+                <a:effectLst/>
+                <a:latin typeface="+mn-lt"/>
+              </a:rPr>
+              <a:t> (345 kV, </a:t>
+            </a:r>
+            <a:r>
+              <a:rPr lang="fr-FR" sz="1800" b="0" i="0" dirty="0" err="1">
+                <a:solidFill>
+                  <a:schemeClr val="tx1"/>
+                </a:solidFill>
+                <a:effectLst/>
+                <a:latin typeface="+mn-lt"/>
+              </a:rPr>
+              <a:t>red</a:t>
+            </a:r>
+            <a:r>
+              <a:rPr lang="fr-FR" sz="1800" b="0" i="0" dirty="0">
+                <a:solidFill>
+                  <a:schemeClr val="tx1"/>
+                </a:solidFill>
+                <a:effectLst/>
+                <a:latin typeface="+mn-lt"/>
+              </a:rPr>
+              <a:t>): </a:t>
+            </a:r>
+            <a:r>
+              <a:rPr lang="fr-FR" sz="1800" b="0" i="0" dirty="0" err="1">
+                <a:solidFill>
+                  <a:schemeClr val="tx1"/>
+                </a:solidFill>
+                <a:effectLst/>
+                <a:latin typeface="+mn-lt"/>
+              </a:rPr>
+              <a:t>northern</a:t>
+            </a:r>
+            <a:r>
+              <a:rPr lang="fr-FR" sz="1800" b="0" i="0" dirty="0">
+                <a:solidFill>
+                  <a:schemeClr val="tx1"/>
+                </a:solidFill>
+                <a:effectLst/>
+                <a:latin typeface="+mn-lt"/>
+              </a:rPr>
+              <a:t> France (Z1), </a:t>
+            </a:r>
+            <a:r>
+              <a:rPr lang="fr-FR" sz="1800" b="0" i="0" dirty="0" err="1">
+                <a:solidFill>
+                  <a:schemeClr val="tx1"/>
+                </a:solidFill>
+                <a:effectLst/>
+                <a:latin typeface="+mn-lt"/>
+              </a:rPr>
+              <a:t>Belgium</a:t>
+            </a:r>
+            <a:r>
+              <a:rPr lang="fr-FR" sz="1800" b="0" i="0" dirty="0">
+                <a:solidFill>
+                  <a:schemeClr val="tx1"/>
+                </a:solidFill>
+                <a:effectLst/>
+                <a:latin typeface="+mn-lt"/>
+              </a:rPr>
+              <a:t> (Z2) and the </a:t>
+            </a:r>
+            <a:r>
+              <a:rPr lang="fr-FR" sz="1800" b="0" i="0" dirty="0" err="1">
+                <a:solidFill>
+                  <a:schemeClr val="tx1"/>
+                </a:solidFill>
+                <a:effectLst/>
+                <a:latin typeface="+mn-lt"/>
+              </a:rPr>
+              <a:t>Netherlands</a:t>
+            </a:r>
+            <a:r>
+              <a:rPr lang="fr-FR" sz="1800" b="0" i="0" dirty="0">
+                <a:solidFill>
+                  <a:schemeClr val="tx1"/>
+                </a:solidFill>
+                <a:effectLst/>
+                <a:latin typeface="+mn-lt"/>
+              </a:rPr>
+              <a:t> (Z3)</a:t>
+            </a:r>
+          </a:p>
+          <a:p>
+            <a:pPr marL="342900" lvl="0" indent="-342900" algn="l">
+              <a:buFont typeface="Arial" panose="020B0604020202020204" pitchFamily="34" charset="0"/>
+              <a:buChar char="•"/>
+            </a:pPr>
+            <a:r>
+              <a:rPr lang="fr-FR" sz="1800" b="1" i="0" dirty="0">
+                <a:solidFill>
+                  <a:schemeClr val="tx1"/>
+                </a:solidFill>
+                <a:effectLst/>
+                <a:latin typeface="+mn-lt"/>
+              </a:rPr>
+              <a:t>HVDC </a:t>
+            </a:r>
+            <a:r>
+              <a:rPr lang="fr-FR" sz="1800" b="1" i="0" dirty="0" err="1">
+                <a:solidFill>
+                  <a:schemeClr val="tx1"/>
+                </a:solidFill>
+                <a:effectLst/>
+                <a:latin typeface="+mn-lt"/>
+              </a:rPr>
+              <a:t>link</a:t>
+            </a:r>
+            <a:r>
+              <a:rPr lang="fr-FR" sz="1800" b="0" i="0" dirty="0">
+                <a:solidFill>
+                  <a:schemeClr val="tx1"/>
+                </a:solidFill>
+                <a:effectLst/>
+                <a:latin typeface="+mn-lt"/>
+              </a:rPr>
+              <a:t> </a:t>
+            </a:r>
+            <a:r>
+              <a:rPr lang="fr-FR" sz="1800" b="0" i="0" dirty="0" err="1">
+                <a:solidFill>
+                  <a:schemeClr val="tx1"/>
+                </a:solidFill>
+                <a:effectLst/>
+                <a:latin typeface="+mn-lt"/>
+              </a:rPr>
+              <a:t>across</a:t>
+            </a:r>
+            <a:r>
+              <a:rPr lang="fr-FR" sz="1800" b="0" i="0" dirty="0">
+                <a:solidFill>
+                  <a:schemeClr val="tx1"/>
+                </a:solidFill>
+                <a:effectLst/>
+                <a:latin typeface="+mn-lt"/>
+              </a:rPr>
+              <a:t> the Strait of Dover, Gravelines → Folkestone (~80 km)</a:t>
+            </a:r>
+          </a:p>
+          <a:p>
+            <a:pPr indent="0" algn="l">
+              <a:buNone/>
+            </a:pPr>
+            <a:r>
+              <a:rPr lang="fr-FR" sz="1800" b="0" i="0" dirty="0">
+                <a:solidFill>
+                  <a:schemeClr val="tx1"/>
+                </a:solidFill>
+                <a:effectLst/>
+                <a:latin typeface="+mn-lt"/>
+              </a:rPr>
+              <a:t>The </a:t>
+            </a:r>
+            <a:r>
+              <a:rPr lang="fr-FR" sz="1800" b="0" i="0" dirty="0" err="1">
+                <a:solidFill>
+                  <a:schemeClr val="tx1"/>
+                </a:solidFill>
+                <a:effectLst/>
+                <a:latin typeface="+mn-lt"/>
+              </a:rPr>
+              <a:t>coordinates</a:t>
+            </a:r>
+            <a:r>
+              <a:rPr lang="fr-FR" sz="1800" b="0" i="0" dirty="0">
+                <a:solidFill>
+                  <a:schemeClr val="tx1"/>
+                </a:solidFill>
+                <a:effectLst/>
+                <a:latin typeface="+mn-lt"/>
+              </a:rPr>
+              <a:t> are indicative. They are not real </a:t>
+            </a:r>
+            <a:r>
+              <a:rPr lang="fr-FR" sz="1800" b="0" i="0" dirty="0" err="1">
+                <a:solidFill>
+                  <a:schemeClr val="tx1"/>
+                </a:solidFill>
+                <a:effectLst/>
+                <a:latin typeface="+mn-lt"/>
+              </a:rPr>
+              <a:t>substation</a:t>
+            </a:r>
+            <a:r>
+              <a:rPr lang="fr-FR" sz="1800" b="0" i="0" dirty="0">
+                <a:solidFill>
+                  <a:schemeClr val="tx1"/>
+                </a:solidFill>
+                <a:effectLst/>
+                <a:latin typeface="+mn-lt"/>
+              </a:rPr>
+              <a:t> sites, and the </a:t>
+            </a:r>
+            <a:r>
+              <a:rPr lang="fr-FR" sz="1800" b="0" i="0" dirty="0" err="1">
+                <a:solidFill>
+                  <a:schemeClr val="tx1"/>
+                </a:solidFill>
+                <a:effectLst/>
+                <a:latin typeface="+mn-lt"/>
+              </a:rPr>
+              <a:t>electrical</a:t>
+            </a:r>
+            <a:r>
+              <a:rPr lang="fr-FR" sz="1800" b="0" i="0" dirty="0">
+                <a:solidFill>
+                  <a:schemeClr val="tx1"/>
+                </a:solidFill>
+                <a:effectLst/>
+                <a:latin typeface="+mn-lt"/>
+              </a:rPr>
+              <a:t> model </a:t>
+            </a:r>
+            <a:r>
+              <a:rPr lang="fr-FR" sz="1800" b="0" i="0" dirty="0" err="1">
+                <a:solidFill>
+                  <a:schemeClr val="tx1"/>
+                </a:solidFill>
+                <a:effectLst/>
+                <a:latin typeface="+mn-lt"/>
+              </a:rPr>
+              <a:t>is</a:t>
+            </a:r>
+            <a:r>
+              <a:rPr lang="fr-FR" sz="1800" b="0" i="0" dirty="0">
+                <a:solidFill>
+                  <a:schemeClr val="tx1"/>
+                </a:solidFill>
+                <a:effectLst/>
+                <a:latin typeface="+mn-lt"/>
+              </a:rPr>
+              <a:t> </a:t>
+            </a:r>
+            <a:r>
+              <a:rPr lang="fr-FR" sz="1800" b="0" i="0" dirty="0" err="1">
+                <a:solidFill>
+                  <a:schemeClr val="tx1"/>
+                </a:solidFill>
+                <a:effectLst/>
+                <a:latin typeface="+mn-lt"/>
+              </a:rPr>
+              <a:t>unchanged</a:t>
+            </a:r>
+            <a:r>
+              <a:rPr lang="fr-FR" sz="1800" b="0" i="0" dirty="0">
+                <a:solidFill>
+                  <a:schemeClr val="tx1"/>
+                </a:solidFill>
+                <a:effectLst/>
+                <a:latin typeface="+mn-lt"/>
+              </a:rPr>
+              <a:t>.</a:t>
+            </a:r>
+          </a:p>
+          <a:p>
+            <a:pPr indent="0" algn="l">
+              <a:buNone/>
+            </a:pPr>
+            <a:r>
+              <a:rPr lang="fr-FR" sz="1800" b="0" i="0" dirty="0" err="1">
+                <a:solidFill>
+                  <a:schemeClr val="tx1"/>
+                </a:solidFill>
+                <a:effectLst/>
+                <a:latin typeface="+mn-lt"/>
+              </a:rPr>
+              <a:t>Shipped</a:t>
+            </a:r>
+            <a:r>
+              <a:rPr lang="fr-FR" sz="1800" b="0" i="0" dirty="0">
+                <a:solidFill>
+                  <a:schemeClr val="tx1"/>
+                </a:solidFill>
+                <a:effectLst/>
+                <a:latin typeface="+mn-lt"/>
+              </a:rPr>
+              <a:t> in the XIIDM files (</a:t>
+            </a:r>
+            <a:r>
+              <a:rPr lang="fr-FR" sz="1800" b="0" i="0" dirty="0" err="1">
+                <a:solidFill>
+                  <a:schemeClr val="tx1"/>
+                </a:solidFill>
+                <a:effectLst/>
+                <a:latin typeface="+mn-lt"/>
+              </a:rPr>
+              <a:t>substationPosition</a:t>
+            </a:r>
+            <a:r>
+              <a:rPr lang="fr-FR" sz="1800" b="0" i="0" dirty="0">
+                <a:solidFill>
+                  <a:schemeClr val="tx1"/>
+                </a:solidFill>
+                <a:effectLst/>
+                <a:latin typeface="+mn-lt"/>
+              </a:rPr>
+              <a:t> extension) and, for CGMES and </a:t>
+            </a:r>
+            <a:r>
+              <a:rPr lang="fr-FR" sz="1800" b="0" i="0" dirty="0" err="1">
+                <a:solidFill>
+                  <a:schemeClr val="tx1"/>
+                </a:solidFill>
+                <a:effectLst/>
+                <a:latin typeface="+mn-lt"/>
+              </a:rPr>
+              <a:t>PowerFactory</a:t>
+            </a:r>
+            <a:r>
+              <a:rPr lang="fr-FR" sz="1800" b="0" i="0" dirty="0">
+                <a:solidFill>
+                  <a:schemeClr val="tx1"/>
+                </a:solidFill>
+                <a:effectLst/>
+                <a:latin typeface="+mn-lt"/>
+              </a:rPr>
+              <a:t> </a:t>
+            </a:r>
+            <a:r>
+              <a:rPr lang="fr-FR" sz="1800" b="0" i="0" dirty="0" err="1">
+                <a:solidFill>
+                  <a:schemeClr val="tx1"/>
+                </a:solidFill>
+                <a:effectLst/>
+                <a:latin typeface="+mn-lt"/>
+              </a:rPr>
+              <a:t>users</a:t>
+            </a:r>
+            <a:r>
+              <a:rPr lang="fr-FR" sz="1800" b="0" i="0" dirty="0">
+                <a:solidFill>
+                  <a:schemeClr val="tx1"/>
+                </a:solidFill>
+                <a:effectLst/>
+                <a:latin typeface="+mn-lt"/>
+              </a:rPr>
+              <a:t>, in network/bus_coordinates.csv.</a:t>
+            </a:r>
+            <a:endParaRPr lang="fr-FR" sz="975" b="0" i="0" dirty="0">
+              <a:solidFill>
+                <a:srgbClr val="BFBFBF"/>
+              </a:solidFill>
+              <a:effectLst/>
+              <a:latin typeface="-apple-system"/>
+            </a:endParaRPr>
+          </a:p>
+        </p:txBody>
+      </p:sp>
+    </p:spTree>
+    <p:extLst>
+      <p:ext uri="{BB962C8B-B14F-4D97-AF65-F5344CB8AC3E}">
+        <p14:creationId xmlns:p14="http://schemas.microsoft.com/office/powerpoint/2010/main" val="2310324480"/>
+      </p:ext>
+    </p:extLst>
+  </p:cSld>
+  <p:clrMapOvr>
+    <a:masterClrMapping/>
+  </p:clrMapOvr>
+</p:sld>
+</file>
+
+<file path=ppt/slides/slide4.xml><?xml version="1.0" encoding="utf-8"?>
 <p:sld xmlns:a="http://schemas.openxmlformats.org/drawingml/2006/main" xmlns:r="http://schemas.openxmlformats.org/officeDocument/2006/relationships" xmlns:p="http://schemas.openxmlformats.org/presentationml/2006/main">
   <p:cSld>
     <p:spTree>
@@ -5580,356 +6228,6 @@
 </p:sld>
 </file>
 
-<file path=ppt/slides/slide4.xml><?xml version="1.0" encoding="utf-8"?>
-<p:sld xmlns:a="http://schemas.openxmlformats.org/drawingml/2006/main" xmlns:r="http://schemas.openxmlformats.org/officeDocument/2006/relationships" xmlns:p="http://schemas.openxmlformats.org/presentationml/2006/main">
-  <p:cSld>
-    <p:spTree>
-      <p:nvGrpSpPr>
-        <p:cNvPr id="1" name=""/>
-        <p:cNvGrpSpPr/>
-        <p:nvPr/>
-      </p:nvGrpSpPr>
-      <p:grpSpPr>
-        <a:xfrm>
-          <a:off x="0" y="0"/>
-          <a:ext cx="0" cy="0"/>
-          <a:chOff x="0" y="0"/>
-          <a:chExt cx="0" cy="0"/>
-        </a:xfrm>
-      </p:grpSpPr>
-      <p:sp>
-        <p:nvSpPr>
-          <p:cNvPr id="2" name="TextBox 1"/>
-          <p:cNvSpPr txBox="1"/>
-          <p:nvPr/>
-        </p:nvSpPr>
-        <p:spPr>
-          <a:xfrm>
-            <a:off x="365760" y="228600"/>
-            <a:ext cx="11430000" cy="738664"/>
-          </a:xfrm>
-          <a:prstGeom prst="rect">
-            <a:avLst/>
-          </a:prstGeom>
-          <a:noFill/>
-        </p:spPr>
-        <p:txBody>
-          <a:bodyPr wrap="square">
-            <a:spAutoFit/>
-          </a:bodyPr>
-          <a:lstStyle/>
-          <a:p>
-            <a:pPr>
-              <a:defRPr sz="2800" b="1">
-                <a:solidFill>
-                  <a:srgbClr val="1F3A5F"/>
-                </a:solidFill>
-              </a:defRPr>
-            </a:pPr>
-            <a:r>
-              <a:rPr lang="en-GB" dirty="0"/>
-              <a:t>Scenario S1: </a:t>
-            </a:r>
-            <a:r>
-              <a:rPr lang="en-GB" dirty="0" err="1"/>
-              <a:t>baseline</a:t>
-            </a:r>
-          </a:p>
-          <a:p>
-            <a:pPr>
-              <a:defRPr sz="1400" i="1">
-                <a:solidFill>
-                  <a:srgbClr val="555555"/>
-                </a:solidFill>
-              </a:defRPr>
-            </a:pPr>
-            <a:r>
-              <a:rPr lang="en-GB" dirty="0"/>
-              <a:t>Reference operating point · 2025-01-01T00:00:00Z</a:t>
-            </a:r>
-          </a:p>
-        </p:txBody>
-      </p:sp>
-      <p:sp>
-        <p:nvSpPr>
-          <p:cNvPr id="3" name="TextBox 2"/>
-          <p:cNvSpPr txBox="1"/>
-          <p:nvPr/>
-        </p:nvSpPr>
-        <p:spPr>
-          <a:xfrm>
-            <a:off x="365760" y="1280160"/>
-            <a:ext cx="11430000" cy="365760"/>
-          </a:xfrm>
-          <a:prstGeom prst="rect">
-            <a:avLst/>
-          </a:prstGeom>
-          <a:noFill/>
-        </p:spPr>
-        <p:txBody>
-          <a:bodyPr wrap="none">
-            <a:spAutoFit/>
-          </a:bodyPr>
-          <a:lstStyle/>
-          <a:p>
-            <a:pPr>
-              <a:defRPr sz="1600" b="1">
-                <a:solidFill>
-                  <a:srgbClr val="2E86AB"/>
-                </a:solidFill>
-              </a:defRPr>
-            </a:pPr>
-            <a:r>
-              <a:rPr dirty="0"/>
-              <a:t>How the scenario is built</a:t>
-            </a:r>
-          </a:p>
-        </p:txBody>
-      </p:sp>
-      <p:sp>
-        <p:nvSpPr>
-          <p:cNvPr id="4" name="TextBox 3"/>
-          <p:cNvSpPr txBox="1"/>
-          <p:nvPr/>
-        </p:nvSpPr>
-        <p:spPr>
-          <a:xfrm>
-            <a:off x="548640" y="1691640"/>
-            <a:ext cx="10972800" cy="574516"/>
-          </a:xfrm>
-          <a:prstGeom prst="rect">
-            <a:avLst/>
-          </a:prstGeom>
-          <a:noFill/>
-        </p:spPr>
-        <p:txBody>
-          <a:bodyPr wrap="square">
-            <a:spAutoFit/>
-          </a:bodyPr>
-          <a:lstStyle/>
-          <a:p>
-            <a:pPr marL="285750" indent="-285750">
-              <a:spcAft>
-                <a:spcPts val="400"/>
-              </a:spcAft>
-              <a:buFont typeface="Arial" panose="020B0604020202020204" pitchFamily="34" charset="0"/>
-              <a:buChar char="•"/>
-              <a:defRPr sz="1400"/>
-            </a:pPr>
-            <a:r>
-              <a:rPr lang="en-GB" dirty="0"/>
-              <a:t>Loads at their source values (× 1.00 on P and Q).</a:t>
-            </a:r>
-          </a:p>
-          <a:p>
-            <a:pPr marL="285750" indent="-285750">
-              <a:spcAft>
-                <a:spcPts val="400"/>
-              </a:spcAft>
-              <a:buFont typeface="Arial" panose="020B0604020202020204" pitchFamily="34" charset="0"/>
-              <a:buChar char="•"/>
-              <a:defRPr sz="1400"/>
-            </a:pPr>
-            <a:r>
-              <a:rPr lang="en-GB" dirty="0"/>
-              <a:t>RES units (wind, solar, hydro) at 50 % of nominal P.</a:t>
-            </a:r>
-          </a:p>
-          <a:p>
-            <a:pPr marL="285750" indent="-285750">
-              <a:spcAft>
-                <a:spcPts val="400"/>
-              </a:spcAft>
-              <a:buFont typeface="Arial" panose="020B0604020202020204" pitchFamily="34" charset="0"/>
-              <a:buChar char="•"/>
-              <a:defRPr sz="1400"/>
-            </a:pPr>
-            <a:r>
-              <a:rPr lang="en-GB" dirty="0"/>
-              <a:t>Other units in merit order within each AC island (ties in file order).</a:t>
-            </a:r>
-          </a:p>
-          <a:p>
-            <a:pPr marL="285750" indent="-285750">
-              <a:spcAft>
-                <a:spcPts val="400"/>
-              </a:spcAft>
-              <a:buFont typeface="Arial" panose="020B0604020202020204" pitchFamily="34" charset="0"/>
-              <a:buChar char="•"/>
-              <a:defRPr sz="1400"/>
-            </a:pPr>
-            <a:r>
-              <a:rPr lang="en-GB" dirty="0"/>
-              <a:t>HVDC link at 50 MW from IEEE 39 → IEEE 14.</a:t>
-            </a:r>
-          </a:p>
-          <a:p>
-            <a:pPr marL="285750" indent="-285750">
-              <a:spcAft>
-                <a:spcPts val="400"/>
-              </a:spcAft>
-              <a:buFont typeface="Arial" panose="020B0604020202020204" pitchFamily="34" charset="0"/>
-              <a:buChar char="•"/>
-              <a:defRPr sz="1400"/>
-            </a:pPr>
-            <a:r>
-              <a:rPr lang="en-GB" dirty="0"/>
-              <a:t>Batteries BAT-B6-1 and BAT-B106-1 idle (0 MW).</a:t>
-            </a:r>
-          </a:p>
-          <a:p>
-            <a:pPr marL="285750" indent="-285750">
-              <a:spcAft>
-                <a:spcPts val="400"/>
-              </a:spcAft>
-              <a:buFont typeface="Arial" panose="020B0604020202020204" pitchFamily="34" charset="0"/>
-              <a:buChar char="•"/>
-              <a:defRPr sz="1400"/>
-            </a:pPr>
-            <a:r>
-              <a:rPr lang="en-GB" dirty="0"/>
-              <a:t>Goal: clean reference state, no branch above 100 %, voltages in 0.90–1.10 p.u.</a:t>
-            </a:r>
-          </a:p>
-        </p:txBody>
-      </p:sp>
-      <p:sp>
-        <p:nvSpPr>
-          <p:cNvPr id="5" name="TextBox 4"/>
-          <p:cNvSpPr txBox="1"/>
-          <p:nvPr/>
-        </p:nvSpPr>
-        <p:spPr>
-          <a:xfrm>
-            <a:off x="365760" y="4023360"/>
-            <a:ext cx="11430000" cy="365760"/>
-          </a:xfrm>
-          <a:prstGeom prst="rect">
-            <a:avLst/>
-          </a:prstGeom>
-          <a:noFill/>
-        </p:spPr>
-        <p:txBody>
-          <a:bodyPr wrap="none">
-            <a:spAutoFit/>
-          </a:bodyPr>
-          <a:lstStyle/>
-          <a:p>
-            <a:pPr>
-              <a:defRPr sz="1600" b="1">
-                <a:solidFill>
-                  <a:srgbClr val="2E86AB"/>
-                </a:solidFill>
-              </a:defRPr>
-            </a:pPr>
-            <a:r>
-              <a:rPr lang="en-GB" dirty="0"/>
-              <a:t>Expected results after AC load flow (pypowsybl validation, not a HYNET tool result)</a:t>
-            </a:r>
-          </a:p>
-        </p:txBody>
-      </p:sp>
-      <p:sp>
-        <p:nvSpPr>
-          <p:cNvPr id="6" name="TextBox 5"/>
-          <p:cNvSpPr txBox="1"/>
-          <p:nvPr/>
-        </p:nvSpPr>
-        <p:spPr>
-          <a:xfrm>
-            <a:off x="548640" y="4434840"/>
-            <a:ext cx="10972800" cy="1046440"/>
-          </a:xfrm>
-          <a:prstGeom prst="rect">
-            <a:avLst/>
-          </a:prstGeom>
-          <a:noFill/>
-        </p:spPr>
-        <p:txBody>
-          <a:bodyPr wrap="square">
-            <a:spAutoFit/>
-          </a:bodyPr>
-          <a:lstStyle/>
-          <a:p>
-            <a:pPr marL="285750" indent="-285750">
-              <a:spcAft>
-                <a:spcPts val="400"/>
-              </a:spcAft>
-              <a:buFont typeface="Arial" panose="020B0604020202020204" pitchFamily="34" charset="0"/>
-              <a:buChar char="•"/>
-              <a:defRPr sz="1300"/>
-            </a:pPr>
-            <a:r>
-              <a:rPr lang="en-GB" dirty="0"/>
-              <a:t>HVDC: 50 MW (IEEE 39 → IEEE 14), maximum 60 MW</a:t>
-            </a:r>
-          </a:p>
-          <a:p>
-            <a:pPr marL="285750" indent="-285750">
-              <a:spcAft>
-                <a:spcPts val="400"/>
-              </a:spcAft>
-              <a:buFont typeface="Arial" panose="020B0604020202020204" pitchFamily="34" charset="0"/>
-              <a:buChar char="•"/>
-              <a:defRPr sz="1300"/>
-            </a:pPr>
-            <a:r>
-              <a:rPr lang="en-GB" dirty="0"/>
-              <a:t>Dispatched generation: IEEE 14: 209.0 MW  |  IEEE 39: 6199.5 MW (losses covered by the distributed slack)</a:t>
-            </a:r>
-          </a:p>
-          <a:p>
-            <a:pPr marL="285750" indent="-285750">
-              <a:spcAft>
-                <a:spcPts val="400"/>
-              </a:spcAft>
-              <a:buFont typeface="Arial" panose="020B0604020202020204" pitchFamily="34" charset="0"/>
-              <a:buChar char="•"/>
-              <a:defRPr sz="1300"/>
-            </a:pPr>
-            <a:r>
-              <a:rPr lang="en-GB" dirty="0"/>
-              <a:t>Load: IEEE 14: 259.0 MW / 73.5 Mvar  |  IEEE 39: 6149.5 MW / 1408.9 Mvar</a:t>
-            </a:r>
-          </a:p>
-          <a:p>
-            <a:pPr marL="285750" indent="-285750">
-              <a:spcAft>
-                <a:spcPts val="400"/>
-              </a:spcAft>
-              <a:buFont typeface="Arial" panose="020B0604020202020204" pitchFamily="34" charset="0"/>
-              <a:buChar char="•"/>
-              <a:defRPr sz="1300"/>
-            </a:pPr>
-            <a:r>
-              <a:rPr lang="en-GB" dirty="0"/>
-              <a:t>Bus voltages: 0.98–1.09 p.u.</a:t>
-            </a:r>
-          </a:p>
-          <a:p>
-            <a:pPr marL="285750" indent="-285750">
-              <a:spcAft>
-                <a:spcPts val="400"/>
-              </a:spcAft>
-              <a:buFont typeface="Arial" panose="020B0604020202020204" pitchFamily="34" charset="0"/>
-              <a:buChar char="•"/>
-              <a:defRPr sz="1300"/>
-            </a:pPr>
-            <a:r>
-              <a:rPr lang="en-GB" dirty="0"/>
-              <a:t>Highest branch loading: 92 % (T-10-32-1), no overload</a:t>
-            </a:r>
-          </a:p>
-        </p:txBody>
-      </p:sp>
-    </p:spTree>
-  </p:cSld>
-  <p:clrMapOvr>
-    <a:masterClrMapping/>
-  </p:clrMapOvr>
-</p:sld>
-</file>
-
 <file path=ppt/slides/slide5.xml><?xml version="1.0" encoding="utf-8"?>
 <p:sld xmlns:a="http://schemas.openxmlformats.org/drawingml/2006/main" xmlns:r="http://schemas.openxmlformats.org/officeDocument/2006/relationships" xmlns:p="http://schemas.openxmlformats.org/presentationml/2006/main">
   <p:cSld>
@@ -5978,11 +6276,11 @@
             </a:pPr>
             <a:r>
               <a:rPr lang="en-GB" dirty="0"/>
-              <a:t>Scenario S2: </a:t>
+              <a:t>Scenario S1: </a:t>
             </a:r>
             <a:r>
               <a:rPr lang="en-GB" dirty="0" err="1"/>
-              <a:t>high_res_low_demand</a:t>
+              <a:t>baseline</a:t>
             </a:r>
           </a:p>
           <a:p>
@@ -5995,7 +6293,7 @@
             </a:pPr>
             <a:r>
               <a:rPr lang="en-GB" dirty="0"/>
-              <a:t>High RES, low demand, HVDC at maximum · 2025-01-01T01:00:00Z</a:t>
+              <a:t>Reference operating point · 2025-01-01T00:00:00Z</a:t>
             </a:r>
           </a:p>
         </p:txBody>
@@ -6030,6 +6328,356 @@
               </a:defRPr>
             </a:pPr>
             <a:r>
+              <a:rPr dirty="0"/>
+              <a:t>How the scenario is built</a:t>
+            </a:r>
+          </a:p>
+        </p:txBody>
+      </p:sp>
+      <p:sp>
+        <p:nvSpPr>
+          <p:cNvPr id="4" name="TextBox 3"/>
+          <p:cNvSpPr txBox="1"/>
+          <p:nvPr/>
+        </p:nvSpPr>
+        <p:spPr>
+          <a:xfrm>
+            <a:off x="548640" y="1691640"/>
+            <a:ext cx="10972800" cy="574516"/>
+          </a:xfrm>
+          <a:prstGeom prst="rect">
+            <a:avLst/>
+          </a:prstGeom>
+          <a:noFill/>
+        </p:spPr>
+        <p:txBody>
+          <a:bodyPr wrap="square">
+            <a:spAutoFit/>
+          </a:bodyPr>
+          <a:lstStyle/>
+          <a:p>
+            <a:pPr marL="285750" indent="-285750">
+              <a:spcAft>
+                <a:spcPts val="400"/>
+              </a:spcAft>
+              <a:buFont typeface="Arial" panose="020B0604020202020204" pitchFamily="34" charset="0"/>
+              <a:buChar char="•"/>
+              <a:defRPr sz="1400"/>
+            </a:pPr>
+            <a:r>
+              <a:rPr lang="en-GB" dirty="0"/>
+              <a:t>Loads at their source values (× 1.00 on P and Q).</a:t>
+            </a:r>
+          </a:p>
+          <a:p>
+            <a:pPr marL="285750" indent="-285750">
+              <a:spcAft>
+                <a:spcPts val="400"/>
+              </a:spcAft>
+              <a:buFont typeface="Arial" panose="020B0604020202020204" pitchFamily="34" charset="0"/>
+              <a:buChar char="•"/>
+              <a:defRPr sz="1400"/>
+            </a:pPr>
+            <a:r>
+              <a:rPr lang="en-GB" dirty="0"/>
+              <a:t>RES units (wind, solar, hydro) at 50 % of nominal P.</a:t>
+            </a:r>
+          </a:p>
+          <a:p>
+            <a:pPr marL="285750" indent="-285750">
+              <a:spcAft>
+                <a:spcPts val="400"/>
+              </a:spcAft>
+              <a:buFont typeface="Arial" panose="020B0604020202020204" pitchFamily="34" charset="0"/>
+              <a:buChar char="•"/>
+              <a:defRPr sz="1400"/>
+            </a:pPr>
+            <a:r>
+              <a:rPr lang="en-GB" dirty="0"/>
+              <a:t>Other units in merit order within each AC island (ties in file order).</a:t>
+            </a:r>
+          </a:p>
+          <a:p>
+            <a:pPr marL="285750" indent="-285750">
+              <a:spcAft>
+                <a:spcPts val="400"/>
+              </a:spcAft>
+              <a:buFont typeface="Arial" panose="020B0604020202020204" pitchFamily="34" charset="0"/>
+              <a:buChar char="•"/>
+              <a:defRPr sz="1400"/>
+            </a:pPr>
+            <a:r>
+              <a:rPr lang="en-GB" dirty="0"/>
+              <a:t>HVDC link at 50 MW from IEEE 39 → IEEE 14.</a:t>
+            </a:r>
+          </a:p>
+          <a:p>
+            <a:pPr marL="285750" indent="-285750">
+              <a:spcAft>
+                <a:spcPts val="400"/>
+              </a:spcAft>
+              <a:buFont typeface="Arial" panose="020B0604020202020204" pitchFamily="34" charset="0"/>
+              <a:buChar char="•"/>
+              <a:defRPr sz="1400"/>
+            </a:pPr>
+            <a:r>
+              <a:rPr lang="en-GB" dirty="0"/>
+              <a:t>Batteries BAT-B6-1 and BAT-B106-1 idle (0 MW).</a:t>
+            </a:r>
+          </a:p>
+          <a:p>
+            <a:pPr marL="285750" indent="-285750">
+              <a:spcAft>
+                <a:spcPts val="400"/>
+              </a:spcAft>
+              <a:buFont typeface="Arial" panose="020B0604020202020204" pitchFamily="34" charset="0"/>
+              <a:buChar char="•"/>
+              <a:defRPr sz="1400"/>
+            </a:pPr>
+            <a:r>
+              <a:rPr lang="en-GB" dirty="0"/>
+              <a:t>Goal: clean reference state, no branch above 100 %, voltages in 0.90–1.10 p.u.</a:t>
+            </a:r>
+          </a:p>
+        </p:txBody>
+      </p:sp>
+      <p:sp>
+        <p:nvSpPr>
+          <p:cNvPr id="5" name="TextBox 4"/>
+          <p:cNvSpPr txBox="1"/>
+          <p:nvPr/>
+        </p:nvSpPr>
+        <p:spPr>
+          <a:xfrm>
+            <a:off x="365760" y="4023360"/>
+            <a:ext cx="11430000" cy="365760"/>
+          </a:xfrm>
+          <a:prstGeom prst="rect">
+            <a:avLst/>
+          </a:prstGeom>
+          <a:noFill/>
+        </p:spPr>
+        <p:txBody>
+          <a:bodyPr wrap="none">
+            <a:spAutoFit/>
+          </a:bodyPr>
+          <a:lstStyle/>
+          <a:p>
+            <a:pPr>
+              <a:defRPr sz="1600" b="1">
+                <a:solidFill>
+                  <a:srgbClr val="2E86AB"/>
+                </a:solidFill>
+              </a:defRPr>
+            </a:pPr>
+            <a:r>
+              <a:rPr lang="en-GB" dirty="0"/>
+              <a:t>Expected results after AC load flow (pypowsybl validation, not a HYNET tool result)</a:t>
+            </a:r>
+          </a:p>
+        </p:txBody>
+      </p:sp>
+      <p:sp>
+        <p:nvSpPr>
+          <p:cNvPr id="6" name="TextBox 5"/>
+          <p:cNvSpPr txBox="1"/>
+          <p:nvPr/>
+        </p:nvSpPr>
+        <p:spPr>
+          <a:xfrm>
+            <a:off x="548640" y="4434840"/>
+            <a:ext cx="10972800" cy="1046440"/>
+          </a:xfrm>
+          <a:prstGeom prst="rect">
+            <a:avLst/>
+          </a:prstGeom>
+          <a:noFill/>
+        </p:spPr>
+        <p:txBody>
+          <a:bodyPr wrap="square">
+            <a:spAutoFit/>
+          </a:bodyPr>
+          <a:lstStyle/>
+          <a:p>
+            <a:pPr marL="285750" indent="-285750">
+              <a:spcAft>
+                <a:spcPts val="400"/>
+              </a:spcAft>
+              <a:buFont typeface="Arial" panose="020B0604020202020204" pitchFamily="34" charset="0"/>
+              <a:buChar char="•"/>
+              <a:defRPr sz="1300"/>
+            </a:pPr>
+            <a:r>
+              <a:rPr lang="en-GB" dirty="0"/>
+              <a:t>HVDC: 50 MW (IEEE 39 → IEEE 14), maximum 60 MW</a:t>
+            </a:r>
+          </a:p>
+          <a:p>
+            <a:pPr marL="285750" indent="-285750">
+              <a:spcAft>
+                <a:spcPts val="400"/>
+              </a:spcAft>
+              <a:buFont typeface="Arial" panose="020B0604020202020204" pitchFamily="34" charset="0"/>
+              <a:buChar char="•"/>
+              <a:defRPr sz="1300"/>
+            </a:pPr>
+            <a:r>
+              <a:rPr lang="en-GB" dirty="0"/>
+              <a:t>Dispatched generation: IEEE 14: 209.0 MW  |  IEEE 39: 6199.5 MW (losses covered by the distributed slack)</a:t>
+            </a:r>
+          </a:p>
+          <a:p>
+            <a:pPr marL="285750" indent="-285750">
+              <a:spcAft>
+                <a:spcPts val="400"/>
+              </a:spcAft>
+              <a:buFont typeface="Arial" panose="020B0604020202020204" pitchFamily="34" charset="0"/>
+              <a:buChar char="•"/>
+              <a:defRPr sz="1300"/>
+            </a:pPr>
+            <a:r>
+              <a:rPr lang="en-GB" dirty="0"/>
+              <a:t>Load: IEEE 14: 259.0 MW / 73.5 Mvar  |  IEEE 39: 6149.5 MW / 1408.9 Mvar</a:t>
+            </a:r>
+          </a:p>
+          <a:p>
+            <a:pPr marL="285750" indent="-285750">
+              <a:spcAft>
+                <a:spcPts val="400"/>
+              </a:spcAft>
+              <a:buFont typeface="Arial" panose="020B0604020202020204" pitchFamily="34" charset="0"/>
+              <a:buChar char="•"/>
+              <a:defRPr sz="1300"/>
+            </a:pPr>
+            <a:r>
+              <a:rPr lang="en-GB" dirty="0"/>
+              <a:t>Bus voltages: 0.98–1.09 p.u.</a:t>
+            </a:r>
+          </a:p>
+          <a:p>
+            <a:pPr marL="285750" indent="-285750">
+              <a:spcAft>
+                <a:spcPts val="400"/>
+              </a:spcAft>
+              <a:buFont typeface="Arial" panose="020B0604020202020204" pitchFamily="34" charset="0"/>
+              <a:buChar char="•"/>
+              <a:defRPr sz="1300"/>
+            </a:pPr>
+            <a:r>
+              <a:rPr lang="en-GB" dirty="0"/>
+              <a:t>Highest branch loading: 92 % (T-10-32-1), no overload</a:t>
+            </a:r>
+          </a:p>
+        </p:txBody>
+      </p:sp>
+    </p:spTree>
+  </p:cSld>
+  <p:clrMapOvr>
+    <a:masterClrMapping/>
+  </p:clrMapOvr>
+</p:sld>
+</file>
+
+<file path=ppt/slides/slide6.xml><?xml version="1.0" encoding="utf-8"?>
+<p:sld xmlns:a="http://schemas.openxmlformats.org/drawingml/2006/main" xmlns:r="http://schemas.openxmlformats.org/officeDocument/2006/relationships" xmlns:p="http://schemas.openxmlformats.org/presentationml/2006/main">
+  <p:cSld>
+    <p:spTree>
+      <p:nvGrpSpPr>
+        <p:cNvPr id="1" name=""/>
+        <p:cNvGrpSpPr/>
+        <p:nvPr/>
+      </p:nvGrpSpPr>
+      <p:grpSpPr>
+        <a:xfrm>
+          <a:off x="0" y="0"/>
+          <a:ext cx="0" cy="0"/>
+          <a:chOff x="0" y="0"/>
+          <a:chExt cx="0" cy="0"/>
+        </a:xfrm>
+      </p:grpSpPr>
+      <p:sp>
+        <p:nvSpPr>
+          <p:cNvPr id="2" name="TextBox 1"/>
+          <p:cNvSpPr txBox="1"/>
+          <p:nvPr/>
+        </p:nvSpPr>
+        <p:spPr>
+          <a:xfrm>
+            <a:off x="365760" y="228600"/>
+            <a:ext cx="11430000" cy="738664"/>
+          </a:xfrm>
+          <a:prstGeom prst="rect">
+            <a:avLst/>
+          </a:prstGeom>
+          <a:noFill/>
+        </p:spPr>
+        <p:txBody>
+          <a:bodyPr wrap="square">
+            <a:spAutoFit/>
+          </a:bodyPr>
+          <a:lstStyle/>
+          <a:p>
+            <a:pPr>
+              <a:defRPr sz="2800" b="1">
+                <a:solidFill>
+                  <a:srgbClr val="1F3A5F"/>
+                </a:solidFill>
+              </a:defRPr>
+            </a:pPr>
+            <a:r>
+              <a:rPr lang="en-GB" dirty="0"/>
+              <a:t>Scenario S2: </a:t>
+            </a:r>
+            <a:r>
+              <a:rPr lang="en-GB" dirty="0" err="1"/>
+              <a:t>high_res_low_demand</a:t>
+            </a:r>
+          </a:p>
+          <a:p>
+            <a:pPr>
+              <a:defRPr sz="1400" i="1">
+                <a:solidFill>
+                  <a:srgbClr val="555555"/>
+                </a:solidFill>
+              </a:defRPr>
+            </a:pPr>
+            <a:r>
+              <a:rPr lang="en-GB" dirty="0"/>
+              <a:t>High RES, low demand, HVDC at maximum · 2025-01-01T01:00:00Z</a:t>
+            </a:r>
+          </a:p>
+        </p:txBody>
+      </p:sp>
+      <p:sp>
+        <p:nvSpPr>
+          <p:cNvPr id="3" name="TextBox 2"/>
+          <p:cNvSpPr txBox="1"/>
+          <p:nvPr/>
+        </p:nvSpPr>
+        <p:spPr>
+          <a:xfrm>
+            <a:off x="365760" y="1280160"/>
+            <a:ext cx="11430000" cy="365760"/>
+          </a:xfrm>
+          <a:prstGeom prst="rect">
+            <a:avLst/>
+          </a:prstGeom>
+          <a:noFill/>
+        </p:spPr>
+        <p:txBody>
+          <a:bodyPr wrap="none">
+            <a:spAutoFit/>
+          </a:bodyPr>
+          <a:lstStyle/>
+          <a:p>
+            <a:pPr>
+              <a:defRPr sz="1600" b="1">
+                <a:solidFill>
+                  <a:srgbClr val="2E86AB"/>
+                </a:solidFill>
+              </a:defRPr>
+            </a:pPr>
+            <a:r>
               <a:t>How the scenario is built</a:t>
             </a:r>
           </a:p>
@@ -6279,7 +6927,7 @@
 </p:sld>
 </file>
 
-<file path=ppt/slides/slide6.xml><?xml version="1.0" encoding="utf-8"?>
+<file path=ppt/slides/slide7.xml><?xml version="1.0" encoding="utf-8"?>
 <p:sld xmlns:a="http://schemas.openxmlformats.org/drawingml/2006/main" xmlns:r="http://schemas.openxmlformats.org/officeDocument/2006/relationships" xmlns:p="http://schemas.openxmlformats.org/presentationml/2006/main">
   <p:cSld>
     <p:spTree>
@@ -6949,6 +7597,26 @@
 </file>
 
 <file path=customXml/item1.xml><?xml version="1.0" encoding="utf-8"?>
+<p:properties xmlns:p="http://schemas.microsoft.com/office/2006/metadata/properties" xmlns:xsi="http://www.w3.org/2001/XMLSchema-instance" xmlns:pc="http://schemas.microsoft.com/office/infopath/2007/PartnerControls">
+  <documentManagement>
+    <TaxCatchAll xmlns="039c73dc-0ae7-4985-93c3-7057b4e6726f" xsi:nil="true"/>
+    <lcf76f155ced4ddcb4097134ff3c332f xmlns="8c84694f-e8fa-4c1d-8756-eb7f5d2c5c51">
+      <Terms xmlns="http://schemas.microsoft.com/office/infopath/2007/PartnerControls"/>
+    </lcf76f155ced4ddcb4097134ff3c332f>
+  </documentManagement>
+</p:properties>
+</file>
+
+<file path=customXml/item2.xml><?xml version="1.0" encoding="utf-8"?>
+<?mso-contentType ?>
+<FormTemplates xmlns="http://schemas.microsoft.com/sharepoint/v3/contenttype/forms">
+  <Display>DocumentLibraryForm</Display>
+  <Edit>DocumentLibraryForm</Edit>
+  <New>DocumentLibraryForm</New>
+</FormTemplates>
+</file>
+
+<file path=customXml/item3.xml><?xml version="1.0" encoding="utf-8"?>
 <ct:contentTypeSchema xmlns:ct="http://schemas.microsoft.com/office/2006/metadata/contentType" xmlns:ma="http://schemas.microsoft.com/office/2006/metadata/properties/metaAttributes" ct:_="" ma:_="" ma:contentTypeName="Document" ma:contentTypeID="0x01010007E8BEA08D219B439B85909DE82C7FED" ma:contentTypeVersion="13" ma:contentTypeDescription="Create a new document." ma:contentTypeScope="" ma:versionID="5c8b8e36f1041009dddbbe2f59e629c5">
   <xsd:schema xmlns:xsd="http://www.w3.org/2001/XMLSchema" xmlns:xs="http://www.w3.org/2001/XMLSchema" xmlns:p="http://schemas.microsoft.com/office/2006/metadata/properties" xmlns:ns2="8c84694f-e8fa-4c1d-8756-eb7f5d2c5c51" xmlns:ns3="039c73dc-0ae7-4985-93c3-7057b4e6726f" targetNamespace="http://schemas.microsoft.com/office/2006/metadata/properties" ma:root="true" ma:fieldsID="74426ec90bd82ef3e5365f0517753090" ns2:_="" ns3:_="">
     <xsd:import namespace="8c84694f-e8fa-4c1d-8756-eb7f5d2c5c51"/>
@@ -7155,27 +7823,32 @@
 </ct:contentTypeSchema>
 </file>
 
-<file path=customXml/item2.xml><?xml version="1.0" encoding="utf-8"?>
-<?mso-contentType ?>
-<FormTemplates xmlns="http://schemas.microsoft.com/sharepoint/v3/contenttype/forms">
-  <Display>DocumentLibraryForm</Display>
-  <Edit>DocumentLibraryForm</Edit>
-  <New>DocumentLibraryForm</New>
-</FormTemplates>
+<file path=customXml/itemProps1.xml><?xml version="1.0" encoding="utf-8"?>
+<ds:datastoreItem xmlns:ds="http://schemas.openxmlformats.org/officeDocument/2006/customXml" ds:itemID="{EAB24518-FB02-4EAA-9977-1609659082C5}">
+  <ds:schemaRefs>
+    <ds:schemaRef ds:uri="http://purl.org/dc/dcmitype/"/>
+    <ds:schemaRef ds:uri="http://purl.org/dc/terms/"/>
+    <ds:schemaRef ds:uri="8c84694f-e8fa-4c1d-8756-eb7f5d2c5c51"/>
+    <ds:schemaRef ds:uri="http://www.w3.org/XML/1998/namespace"/>
+    <ds:schemaRef ds:uri="http://purl.org/dc/elements/1.1/"/>
+    <ds:schemaRef ds:uri="http://schemas.microsoft.com/office/2006/metadata/properties"/>
+    <ds:schemaRef ds:uri="http://schemas.microsoft.com/office/2006/documentManagement/types"/>
+    <ds:schemaRef ds:uri="http://schemas.microsoft.com/office/infopath/2007/PartnerControls"/>
+    <ds:schemaRef ds:uri="http://schemas.openxmlformats.org/package/2006/metadata/core-properties"/>
+    <ds:schemaRef ds:uri="039c73dc-0ae7-4985-93c3-7057b4e6726f"/>
+  </ds:schemaRefs>
+</ds:datastoreItem>
 </file>
 
-<file path=customXml/item3.xml><?xml version="1.0" encoding="utf-8"?>
-<p:properties xmlns:p="http://schemas.microsoft.com/office/2006/metadata/properties" xmlns:xsi="http://www.w3.org/2001/XMLSchema-instance" xmlns:pc="http://schemas.microsoft.com/office/infopath/2007/PartnerControls">
-  <documentManagement>
-    <TaxCatchAll xmlns="039c73dc-0ae7-4985-93c3-7057b4e6726f" xsi:nil="true"/>
-    <lcf76f155ced4ddcb4097134ff3c332f xmlns="8c84694f-e8fa-4c1d-8756-eb7f5d2c5c51">
-      <Terms xmlns="http://schemas.microsoft.com/office/infopath/2007/PartnerControls"/>
-    </lcf76f155ced4ddcb4097134ff3c332f>
-  </documentManagement>
-</p:properties>
+<file path=customXml/itemProps2.xml><?xml version="1.0" encoding="utf-8"?>
+<ds:datastoreItem xmlns:ds="http://schemas.openxmlformats.org/officeDocument/2006/customXml" ds:itemID="{B37F9BB1-363E-418B-86A7-127D1D7BED93}">
+  <ds:schemaRefs>
+    <ds:schemaRef ds:uri="http://schemas.microsoft.com/sharepoint/v3/contenttype/forms"/>
+  </ds:schemaRefs>
+</ds:datastoreItem>
 </file>
 
-<file path=customXml/itemProps1.xml><?xml version="1.0" encoding="utf-8"?>
+<file path=customXml/itemProps3.xml><?xml version="1.0" encoding="utf-8"?>
 <ds:datastoreItem xmlns:ds="http://schemas.openxmlformats.org/officeDocument/2006/customXml" ds:itemID="{938DAF59-B3A2-485A-B955-738B77B71B94}">
   <ds:schemaRefs>
     <ds:schemaRef ds:uri="http://schemas.microsoft.com/office/2006/metadata/contentType"/>
@@ -7192,29 +7865,4 @@
     <ds:schemaRef ds:uri="http://schemas.microsoft.com/internal/obd"/>
   </ds:schemaRefs>
 </ds:datastoreItem>
-</file>
-
-<file path=customXml/itemProps2.xml><?xml version="1.0" encoding="utf-8"?>
-<ds:datastoreItem xmlns:ds="http://schemas.openxmlformats.org/officeDocument/2006/customXml" ds:itemID="{B37F9BB1-363E-418B-86A7-127D1D7BED93}">
-  <ds:schemaRefs>
-    <ds:schemaRef ds:uri="http://schemas.microsoft.com/sharepoint/v3/contenttype/forms"/>
-  </ds:schemaRefs>
-</ds:datastoreItem>
-</file>
-
-<file path=customXml/itemProps3.xml><?xml version="1.0" encoding="utf-8"?>
-<ds:datastoreItem xmlns:ds="http://schemas.openxmlformats.org/officeDocument/2006/customXml" ds:itemID="{EAB24518-FB02-4EAA-9977-1609659082C5}">
-  <ds:schemaRefs>
-    <ds:schemaRef ds:uri="http://purl.org/dc/dcmitype/"/>
-    <ds:schemaRef ds:uri="http://purl.org/dc/terms/"/>
-    <ds:schemaRef ds:uri="8c84694f-e8fa-4c1d-8756-eb7f5d2c5c51"/>
-    <ds:schemaRef ds:uri="http://www.w3.org/XML/1998/namespace"/>
-    <ds:schemaRef ds:uri="http://purl.org/dc/elements/1.1/"/>
-    <ds:schemaRef ds:uri="http://schemas.microsoft.com/office/2006/metadata/properties"/>
-    <ds:schemaRef ds:uri="http://schemas.microsoft.com/office/2006/documentManagement/types"/>
-    <ds:schemaRef ds:uri="http://schemas.microsoft.com/office/infopath/2007/PartnerControls"/>
-    <ds:schemaRef ds:uri="http://schemas.openxmlformats.org/package/2006/metadata/core-properties"/>
-    <ds:schemaRef ds:uri="039c73dc-0ae7-4985-93c3-7057b4e6726f"/>
-  </ds:schemaRefs>
-</ds:datastoreItem>
 </file>
</xml_diff>

<commit_message>
fix(network): align tx-full network data with the PowerFactory model
</commit_message>
<xml_diff>
--- a/docs/scenarios_presentation.pptx
+++ b/docs/scenarios_presentation.pptx
@@ -6537,7 +6537,7 @@
             </a:pPr>
             <a:r>
               <a:rPr lang="en-GB" dirty="0"/>
-              <a:t>Load: IEEE 14: 259.0 MW / 73.5 Mvar  |  IEEE 39: 6149.5 MW / 1408.9 Mvar</a:t>
+              <a:t>Load: IEEE 14: 259.0 MW / 73.5 Mvar  |  IEEE 39: 6194.7 MW / 1453.1 Mvar</a:t>
             </a:r>
           </a:p>
           <a:p>
@@ -6551,7 +6551,7 @@
             </a:pPr>
             <a:r>
               <a:rPr lang="en-GB" dirty="0"/>
-              <a:t>Bus voltages: 0.98–1.09 p.u.</a:t>
+              <a:t>Bus voltages: 0.98–1.06 p.u.</a:t>
             </a:r>
           </a:p>
           <a:p>
@@ -6565,7 +6565,7 @@
             </a:pPr>
             <a:r>
               <a:rPr lang="en-GB" dirty="0"/>
-              <a:t>Highest branch loading: 92 % (T-10-32-1), no overload</a:t>
+              <a:t>Highest branch loading: 93 % (T-10-32-1), no overload</a:t>
             </a:r>
           </a:p>
         </p:txBody>
@@ -6886,7 +6886,7 @@
             </a:pPr>
             <a:r>
               <a:rPr lang="en-GB" dirty="0"/>
-              <a:t>Load: IEEE 14: 181.3 MW / 51.4 Mvar  |  IEEE 39: 4304.6 MW / 986.2 Mvar</a:t>
+              <a:t>Load: IEEE 14: 181.3 MW / 51.4 Mvar  |  IEEE 39: 4336.3 MW / 1017.2 Mvar</a:t>
             </a:r>
           </a:p>
           <a:p>
@@ -6900,7 +6900,7 @@
             </a:pPr>
             <a:r>
               <a:rPr lang="en-GB" dirty="0"/>
-              <a:t>Bus voltages: 0.98–1.09 p.u.; largest rise from S1 +0.026 p.u. at B12 (IEEE 39)</a:t>
+              <a:t>Bus voltages: 0.98–1.06 p.u.; largest rise from S1 +0.025 p.u. at B8 (IEEE 39)</a:t>
             </a:r>
           </a:p>
           <a:p>
@@ -7235,7 +7235,7 @@
             </a:pPr>
             <a:r>
               <a:rPr lang="en-GB" dirty="0"/>
-              <a:t>Load: IEEE 14: 279.7 MW / 110.2 Mvar  |  IEEE 39: 6641.5 MW / 2113.4 Mvar</a:t>
+              <a:t>Load: IEEE 14: 279.7 MW / 110.2 Mvar  |  IEEE 39: 6690.3 MW / 2179.6 Mvar</a:t>
             </a:r>
           </a:p>
           <a:p>
@@ -7249,7 +7249,7 @@
             </a:pPr>
             <a:r>
               <a:rPr lang="en-GB" dirty="0"/>
-              <a:t>Bus voltages: 0.94–1.06 p.u.; largest drop from S1 −0.070 p.u. at B102 (IEEE 14)</a:t>
+              <a:t>Bus voltages: 0.96–1.06 p.u.; largest drop from S1 −0.036 p.u. at B109 (IEEE 14)</a:t>
             </a:r>
           </a:p>
           <a:p>
@@ -7263,7 +7263,7 @@
             </a:pPr>
             <a:r>
               <a:rPr lang="en-GB" dirty="0"/>
-              <a:t>Overloads: L-16-19-1 162 %, L-101-102-1 118 %, L-6-11-1 106 %, L-10-11-1 103 %</a:t>
+              <a:t>Overloads: L-16-19-1 172 %, L-6-11-1 108 %, L-10-11-1 104 %</a:t>
             </a:r>
           </a:p>
         </p:txBody>

</xml_diff>

<commit_message>
feat(scenarios): rate units as in PowerFactory, add RES units and rebuild S1–S3
</commit_message>
<xml_diff>
--- a/docs/scenarios_presentation.pptx
+++ b/docs/scenarios_presentation.pptx
@@ -4954,7 +4954,7 @@
             </a:pPr>
             <a:r>
               <a:rPr dirty="0"/>
-              <a:t>15 generators — type, nominal P, marginal price (synthetic, editable)</a:t>
+              <a:t>22 generators — type and rated P from PowerFactory, 7 added wind and solar units, synthetic marginal price</a:t>
             </a:r>
           </a:p>
         </p:txBody>
@@ -4975,7 +4975,7 @@
         </p:nvGraphicFramePr>
         <p:xfrm>
           <a:off x="662876" y="1216152"/>
-          <a:ext cx="9372600" cy="5059680"/>
+          <a:ext cx="9372600" cy="5321786"/>
         </p:xfrm>
         <a:graphic>
           <a:graphicData uri="http://schemas.openxmlformats.org/drawingml/2006/table">
@@ -5020,7 +5020,7 @@
                   </a:extLst>
                 </a:gridCol>
               </a:tblGrid>
-              <a:tr h="320040">
+              <a:tr h="231382">
                 <a:tc>
                   <a:txBody>
                     <a:bodyPr/>
@@ -5036,7 +5036,7 @@
                       </a:r>
                     </a:p>
                   </a:txBody>
-                  <a:tcPr/>
+                  <a:tcPr marT="0" marB="0"/>
                 </a:tc>
                 <a:tc>
                   <a:txBody>
@@ -5053,7 +5053,7 @@
                       </a:r>
                     </a:p>
                   </a:txBody>
-                  <a:tcPr/>
+                  <a:tcPr marT="0" marB="0"/>
                 </a:tc>
                 <a:tc>
                   <a:txBody>
@@ -5070,7 +5070,7 @@
                       </a:r>
                     </a:p>
                   </a:txBody>
-                  <a:tcPr/>
+                  <a:tcPr marT="0" marB="0"/>
                 </a:tc>
                 <a:tc>
                   <a:txBody>
@@ -5083,11 +5083,11 @@
                             <a:srgbClr val="FFFFFF"/>
                           </a:solidFill>
                         </a:rPr>
-                        <a:t>Nominal P (MW)</a:t>
-                      </a:r>
-                    </a:p>
-                  </a:txBody>
-                  <a:tcPr/>
+                        <a:t>Rated P (MW)</a:t>
+                      </a:r>
+                    </a:p>
+                  </a:txBody>
+                  <a:tcPr marT="0" marB="0"/>
                 </a:tc>
                 <a:tc>
                   <a:txBody>
@@ -5104,7 +5104,7 @@
                       </a:r>
                     </a:p>
                   </a:txBody>
-                  <a:tcPr/>
+                  <a:tcPr marT="0" marB="0"/>
                 </a:tc>
                 <a:extLst>
                   <a:ext uri="{0D108BD9-81ED-4DB2-BD59-A6C34878D82A}">
@@ -5112,7 +5112,7 @@
                   </a:ext>
                 </a:extLst>
               </a:tr>
-              <a:tr h="320040">
+              <a:tr h="231382">
                 <a:tc>
                   <a:txBody>
                     <a:bodyPr/>
@@ -5124,7 +5124,7 @@
                       </a:r>
                     </a:p>
                   </a:txBody>
-                  <a:tcPr/>
+                  <a:tcPr marT="0" marB="0"/>
                 </a:tc>
                 <a:tc>
                   <a:txBody>
@@ -5137,7 +5137,7 @@
                       </a:r>
                     </a:p>
                   </a:txBody>
-                  <a:tcPr/>
+                  <a:tcPr marT="0" marB="0"/>
                 </a:tc>
                 <a:tc>
                   <a:txBody>
@@ -5150,20 +5150,20 @@
                       </a:r>
                     </a:p>
                   </a:txBody>
-                  <a:tcPr/>
-                </a:tc>
-                <a:tc>
-                  <a:txBody>
-                    <a:bodyPr/>
-                    <a:lstStyle/>
-                    <a:p>
-                      <a:r>
-                        <a:rPr sz="1100"/>
-                        <a:t>350</a:t>
-                      </a:r>
-                    </a:p>
-                  </a:txBody>
-                  <a:tcPr/>
+                  <a:tcPr marT="0" marB="0"/>
+                </a:tc>
+                <a:tc>
+                  <a:txBody>
+                    <a:bodyPr/>
+                    <a:lstStyle/>
+                    <a:p>
+                      <a:r>
+                        <a:rPr sz="1100"/>
+                        <a:t>380.8</a:t>
+                      </a:r>
+                    </a:p>
+                  </a:txBody>
+                  <a:tcPr marT="0" marB="0"/>
                 </a:tc>
                 <a:tc>
                   <a:txBody>
@@ -5176,7 +5176,7 @@
                       </a:r>
                     </a:p>
                   </a:txBody>
-                  <a:tcPr/>
+                  <a:tcPr marT="0" marB="0"/>
                 </a:tc>
                 <a:extLst>
                   <a:ext uri="{0D108BD9-81ED-4DB2-BD59-A6C34878D82A}">
@@ -5184,7 +5184,7 @@
                   </a:ext>
                 </a:extLst>
               </a:tr>
-              <a:tr h="320040">
+              <a:tr h="231382">
                 <a:tc>
                   <a:txBody>
                     <a:bodyPr/>
@@ -5196,7 +5196,7 @@
                       </a:r>
                     </a:p>
                   </a:txBody>
-                  <a:tcPr/>
+                  <a:tcPr marT="0" marB="0"/>
                 </a:tc>
                 <a:tc>
                   <a:txBody>
@@ -5209,7 +5209,7 @@
                       </a:r>
                     </a:p>
                   </a:txBody>
-                  <a:tcPr/>
+                  <a:tcPr marT="0" marB="0"/>
                 </a:tc>
                 <a:tc>
                   <a:txBody>
@@ -5222,20 +5222,20 @@
                       </a:r>
                     </a:p>
                   </a:txBody>
-                  <a:tcPr/>
-                </a:tc>
-                <a:tc>
-                  <a:txBody>
-                    <a:bodyPr/>
-                    <a:lstStyle/>
-                    <a:p>
-                      <a:r>
-                        <a:rPr sz="1100"/>
-                        <a:t>60</a:t>
-                      </a:r>
-                    </a:p>
-                  </a:txBody>
-                  <a:tcPr/>
+                  <a:tcPr marT="0" marB="0"/>
+                </a:tc>
+                <a:tc>
+                  <a:txBody>
+                    <a:bodyPr/>
+                    <a:lstStyle/>
+                    <a:p>
+                      <a:r>
+                        <a:rPr sz="1100"/>
+                        <a:t>80</a:t>
+                      </a:r>
+                    </a:p>
+                  </a:txBody>
+                  <a:tcPr marT="0" marB="0"/>
                 </a:tc>
                 <a:tc>
                   <a:txBody>
@@ -5248,7 +5248,7 @@
                       </a:r>
                     </a:p>
                   </a:txBody>
-                  <a:tcPr/>
+                  <a:tcPr marT="0" marB="0"/>
                 </a:tc>
                 <a:extLst>
                   <a:ext uri="{0D108BD9-81ED-4DB2-BD59-A6C34878D82A}">
@@ -5256,7 +5256,7 @@
                   </a:ext>
                 </a:extLst>
               </a:tr>
-              <a:tr h="320040">
+              <a:tr h="231382">
                 <a:tc>
                   <a:txBody>
                     <a:bodyPr/>
@@ -5268,7 +5268,7 @@
                       </a:r>
                     </a:p>
                   </a:txBody>
-                  <a:tcPr/>
+                  <a:tcPr marT="0" marB="0"/>
                 </a:tc>
                 <a:tc>
                   <a:txBody>
@@ -5281,7 +5281,1175 @@
                       </a:r>
                     </a:p>
                   </a:txBody>
-                  <a:tcPr/>
+                  <a:tcPr marT="0" marB="0"/>
+                </a:tc>
+                <a:tc>
+                  <a:txBody>
+                    <a:bodyPr/>
+                    <a:lstStyle/>
+                    <a:p>
+                      <a:r>
+                        <a:rPr sz="1100"/>
+                        <a:t>CONDENSER</a:t>
+                      </a:r>
+                    </a:p>
+                  </a:txBody>
+                  <a:tcPr marT="0" marB="0"/>
+                </a:tc>
+                <a:tc>
+                  <a:txBody>
+                    <a:bodyPr/>
+                    <a:lstStyle/>
+                    <a:p>
+                      <a:r>
+                        <a:rPr sz="1100"/>
+                        <a:t>0</a:t>
+                      </a:r>
+                    </a:p>
+                  </a:txBody>
+                  <a:tcPr marT="0" marB="0"/>
+                </a:tc>
+                <a:tc>
+                  <a:txBody>
+                    <a:bodyPr/>
+                    <a:lstStyle/>
+                    <a:p>
+                      <a:r>
+                        <a:rPr sz="1100"/>
+                        <a:t>0</a:t>
+                      </a:r>
+                    </a:p>
+                  </a:txBody>
+                  <a:tcPr marT="0" marB="0"/>
+                </a:tc>
+                <a:extLst>
+                  <a:ext uri="{0D108BD9-81ED-4DB2-BD59-A6C34878D82A}">
+                    <a16:rowId xmlns:a16="http://schemas.microsoft.com/office/drawing/2014/main" val="10001"/>
+                  </a:ext>
+                </a:extLst>
+              </a:tr>
+              <a:tr h="231382">
+                <a:tc>
+                  <a:txBody>
+                    <a:bodyPr/>
+                    <a:lstStyle/>
+                    <a:p>
+                      <a:r>
+                        <a:rPr sz="1100"/>
+                        <a:t>B106-G1</a:t>
+                      </a:r>
+                    </a:p>
+                  </a:txBody>
+                  <a:tcPr marT="0" marB="0"/>
+                </a:tc>
+                <a:tc>
+                  <a:txBody>
+                    <a:bodyPr/>
+                    <a:lstStyle/>
+                    <a:p>
+                      <a:r>
+                        <a:rPr sz="1100"/>
+                        <a:t>IEEE 14</a:t>
+                      </a:r>
+                    </a:p>
+                  </a:txBody>
+                  <a:tcPr marT="0" marB="0"/>
+                </a:tc>
+                <a:tc>
+                  <a:txBody>
+                    <a:bodyPr/>
+                    <a:lstStyle/>
+                    <a:p>
+                      <a:r>
+                        <a:rPr sz="1100"/>
+                        <a:t>CONDENSER</a:t>
+                      </a:r>
+                    </a:p>
+                  </a:txBody>
+                  <a:tcPr marT="0" marB="0"/>
+                </a:tc>
+                <a:tc>
+                  <a:txBody>
+                    <a:bodyPr/>
+                    <a:lstStyle/>
+                    <a:p>
+                      <a:r>
+                        <a:rPr sz="1100"/>
+                        <a:t>0</a:t>
+                      </a:r>
+                    </a:p>
+                  </a:txBody>
+                  <a:tcPr marT="0" marB="0"/>
+                </a:tc>
+                <a:tc>
+                  <a:txBody>
+                    <a:bodyPr/>
+                    <a:lstStyle/>
+                    <a:p>
+                      <a:r>
+                        <a:rPr sz="1100"/>
+                        <a:t>0</a:t>
+                      </a:r>
+                    </a:p>
+                  </a:txBody>
+                  <a:tcPr marT="0" marB="0"/>
+                </a:tc>
+                <a:extLst>
+                  <a:ext uri="{0D108BD9-81ED-4DB2-BD59-A6C34878D82A}">
+                    <a16:rowId xmlns:a16="http://schemas.microsoft.com/office/drawing/2014/main" val="10002"/>
+                  </a:ext>
+                </a:extLst>
+              </a:tr>
+              <a:tr h="231382">
+                <a:tc>
+                  <a:txBody>
+                    <a:bodyPr/>
+                    <a:lstStyle/>
+                    <a:p>
+                      <a:r>
+                        <a:rPr sz="1100"/>
+                        <a:t>B108-G1</a:t>
+                      </a:r>
+                    </a:p>
+                  </a:txBody>
+                  <a:tcPr marT="0" marB="0"/>
+                </a:tc>
+                <a:tc>
+                  <a:txBody>
+                    <a:bodyPr/>
+                    <a:lstStyle/>
+                    <a:p>
+                      <a:r>
+                        <a:rPr sz="1100"/>
+                        <a:t>IEEE 14</a:t>
+                      </a:r>
+                    </a:p>
+                  </a:txBody>
+                  <a:tcPr marT="0" marB="0"/>
+                </a:tc>
+                <a:tc>
+                  <a:txBody>
+                    <a:bodyPr/>
+                    <a:lstStyle/>
+                    <a:p>
+                      <a:r>
+                        <a:rPr sz="1100"/>
+                        <a:t>CONDENSER</a:t>
+                      </a:r>
+                    </a:p>
+                  </a:txBody>
+                  <a:tcPr marT="0" marB="0"/>
+                </a:tc>
+                <a:tc>
+                  <a:txBody>
+                    <a:bodyPr/>
+                    <a:lstStyle/>
+                    <a:p>
+                      <a:r>
+                        <a:rPr sz="1100"/>
+                        <a:t>0</a:t>
+                      </a:r>
+                    </a:p>
+                  </a:txBody>
+                  <a:tcPr marT="0" marB="0"/>
+                </a:tc>
+                <a:tc>
+                  <a:txBody>
+                    <a:bodyPr/>
+                    <a:lstStyle/>
+                    <a:p>
+                      <a:r>
+                        <a:rPr sz="1100"/>
+                        <a:t>0</a:t>
+                      </a:r>
+                    </a:p>
+                  </a:txBody>
+                  <a:tcPr marT="0" marB="0"/>
+                </a:tc>
+                <a:extLst>
+                  <a:ext uri="{0D108BD9-81ED-4DB2-BD59-A6C34878D82A}">
+                    <a16:rowId xmlns:a16="http://schemas.microsoft.com/office/drawing/2014/main" val="10001"/>
+                  </a:ext>
+                </a:extLst>
+              </a:tr>
+              <a:tr h="231382">
+                <a:tc>
+                  <a:txBody>
+                    <a:bodyPr/>
+                    <a:lstStyle/>
+                    <a:p>
+                      <a:r>
+                        <a:rPr sz="1100"/>
+                        <a:t>B30-G1</a:t>
+                      </a:r>
+                    </a:p>
+                  </a:txBody>
+                  <a:tcPr marT="0" marB="0"/>
+                </a:tc>
+                <a:tc>
+                  <a:txBody>
+                    <a:bodyPr/>
+                    <a:lstStyle/>
+                    <a:p>
+                      <a:r>
+                        <a:rPr sz="1100"/>
+                        <a:t>IEEE 39</a:t>
+                      </a:r>
+                    </a:p>
+                  </a:txBody>
+                  <a:tcPr marT="0" marB="0"/>
+                </a:tc>
+                <a:tc>
+                  <a:txBody>
+                    <a:bodyPr/>
+                    <a:lstStyle/>
+                    <a:p>
+                      <a:r>
+                        <a:rPr sz="1100" b="1">
+                          <a:solidFill>
+                            <a:srgbClr val="2E86AB"/>
+                          </a:solidFill>
+                        </a:rPr>
+                        <a:t>HYDRO</a:t>
+                      </a:r>
+                    </a:p>
+                  </a:txBody>
+                  <a:tcPr marT="0" marB="0"/>
+                </a:tc>
+                <a:tc>
+                  <a:txBody>
+                    <a:bodyPr/>
+                    <a:lstStyle/>
+                    <a:p>
+                      <a:r>
+                        <a:rPr sz="1100"/>
+                        <a:t>560.5</a:t>
+                      </a:r>
+                    </a:p>
+                  </a:txBody>
+                  <a:tcPr marT="0" marB="0"/>
+                </a:tc>
+                <a:tc>
+                  <a:txBody>
+                    <a:bodyPr/>
+                    <a:lstStyle/>
+                    <a:p>
+                      <a:r>
+                        <a:rPr sz="1100"/>
+                        <a:t>5</a:t>
+                      </a:r>
+                    </a:p>
+                  </a:txBody>
+                  <a:tcPr marT="0" marB="0"/>
+                </a:tc>
+                <a:extLst>
+                  <a:ext uri="{0D108BD9-81ED-4DB2-BD59-A6C34878D82A}">
+                    <a16:rowId xmlns:a16="http://schemas.microsoft.com/office/drawing/2014/main" val="10004"/>
+                  </a:ext>
+                </a:extLst>
+              </a:tr>
+              <a:tr h="231382">
+                <a:tc>
+                  <a:txBody>
+                    <a:bodyPr/>
+                    <a:lstStyle/>
+                    <a:p>
+                      <a:r>
+                        <a:rPr sz="1100"/>
+                        <a:t>B31-G1</a:t>
+                      </a:r>
+                    </a:p>
+                  </a:txBody>
+                  <a:tcPr marT="0" marB="0"/>
+                </a:tc>
+                <a:tc>
+                  <a:txBody>
+                    <a:bodyPr/>
+                    <a:lstStyle/>
+                    <a:p>
+                      <a:r>
+                        <a:rPr sz="1100"/>
+                        <a:t>IEEE 39</a:t>
+                      </a:r>
+                    </a:p>
+                  </a:txBody>
+                  <a:tcPr marT="0" marB="0"/>
+                </a:tc>
+                <a:tc>
+                  <a:txBody>
+                    <a:bodyPr/>
+                    <a:lstStyle/>
+                    <a:p>
+                      <a:r>
+                        <a:rPr sz="1100"/>
+                        <a:t>NUCLEAR</a:t>
+                      </a:r>
+                    </a:p>
+                  </a:txBody>
+                  <a:tcPr marT="0" marB="0"/>
+                </a:tc>
+                <a:tc>
+                  <a:txBody>
+                    <a:bodyPr/>
+                    <a:lstStyle/>
+                    <a:p>
+                      <a:r>
+                        <a:rPr sz="1100"/>
+                        <a:t>751.5</a:t>
+                      </a:r>
+                    </a:p>
+                  </a:txBody>
+                  <a:tcPr marT="0" marB="0"/>
+                </a:tc>
+                <a:tc>
+                  <a:txBody>
+                    <a:bodyPr/>
+                    <a:lstStyle/>
+                    <a:p>
+                      <a:r>
+                        <a:rPr sz="1100"/>
+                        <a:t>8</a:t>
+                      </a:r>
+                    </a:p>
+                  </a:txBody>
+                  <a:tcPr marT="0" marB="0"/>
+                </a:tc>
+                <a:extLst>
+                  <a:ext uri="{0D108BD9-81ED-4DB2-BD59-A6C34878D82A}">
+                    <a16:rowId xmlns:a16="http://schemas.microsoft.com/office/drawing/2014/main" val="10001"/>
+                  </a:ext>
+                </a:extLst>
+              </a:tr>
+              <a:tr h="231382">
+                <a:tc>
+                  <a:txBody>
+                    <a:bodyPr/>
+                    <a:lstStyle/>
+                    <a:p>
+                      <a:r>
+                        <a:rPr sz="1100"/>
+                        <a:t>B32-G1</a:t>
+                      </a:r>
+                    </a:p>
+                  </a:txBody>
+                  <a:tcPr marT="0" marB="0"/>
+                </a:tc>
+                <a:tc>
+                  <a:txBody>
+                    <a:bodyPr/>
+                    <a:lstStyle/>
+                    <a:p>
+                      <a:r>
+                        <a:rPr sz="1100"/>
+                        <a:t>IEEE 39</a:t>
+                      </a:r>
+                    </a:p>
+                  </a:txBody>
+                  <a:tcPr marT="0" marB="0"/>
+                </a:tc>
+                <a:tc>
+                  <a:txBody>
+                    <a:bodyPr/>
+                    <a:lstStyle/>
+                    <a:p>
+                      <a:r>
+                        <a:rPr sz="1100"/>
+                        <a:t>NUCLEAR</a:t>
+                      </a:r>
+                    </a:p>
+                  </a:txBody>
+                  <a:tcPr marT="0" marB="0"/>
+                </a:tc>
+                <a:tc>
+                  <a:txBody>
+                    <a:bodyPr/>
+                    <a:lstStyle/>
+                    <a:p>
+                      <a:r>
+                        <a:rPr sz="1100"/>
+                        <a:t>751.5</a:t>
+                      </a:r>
+                    </a:p>
+                  </a:txBody>
+                  <a:tcPr marT="0" marB="0"/>
+                </a:tc>
+                <a:tc>
+                  <a:txBody>
+                    <a:bodyPr/>
+                    <a:lstStyle/>
+                    <a:p>
+                      <a:r>
+                        <a:rPr sz="1100"/>
+                        <a:t>8</a:t>
+                      </a:r>
+                    </a:p>
+                  </a:txBody>
+                  <a:tcPr marT="0" marB="0"/>
+                </a:tc>
+                <a:extLst>
+                  <a:ext uri="{0D108BD9-81ED-4DB2-BD59-A6C34878D82A}">
+                    <a16:rowId xmlns:a16="http://schemas.microsoft.com/office/drawing/2014/main" val="10002"/>
+                  </a:ext>
+                </a:extLst>
+              </a:tr>
+              <a:tr h="231382">
+                <a:tc>
+                  <a:txBody>
+                    <a:bodyPr/>
+                    <a:lstStyle/>
+                    <a:p>
+                      <a:r>
+                        <a:rPr sz="1100"/>
+                        <a:t>B33-G1</a:t>
+                      </a:r>
+                    </a:p>
+                  </a:txBody>
+                  <a:tcPr marT="0" marB="0"/>
+                </a:tc>
+                <a:tc>
+                  <a:txBody>
+                    <a:bodyPr/>
+                    <a:lstStyle/>
+                    <a:p>
+                      <a:r>
+                        <a:rPr sz="1100"/>
+                        <a:t>IEEE 39</a:t>
+                      </a:r>
+                    </a:p>
+                  </a:txBody>
+                  <a:tcPr marT="0" marB="0"/>
+                </a:tc>
+                <a:tc>
+                  <a:txBody>
+                    <a:bodyPr/>
+                    <a:lstStyle/>
+                    <a:p>
+                      <a:r>
+                        <a:rPr sz="1100"/>
+                        <a:t>COAL</a:t>
+                      </a:r>
+                    </a:p>
+                  </a:txBody>
+                  <a:tcPr marT="0" marB="0"/>
+                </a:tc>
+                <a:tc>
+                  <a:txBody>
+                    <a:bodyPr/>
+                    <a:lstStyle/>
+                    <a:p>
+                      <a:r>
+                        <a:rPr sz="1100"/>
+                        <a:t>751.5</a:t>
+                      </a:r>
+                    </a:p>
+                  </a:txBody>
+                  <a:tcPr marT="0" marB="0"/>
+                </a:tc>
+                <a:tc>
+                  <a:txBody>
+                    <a:bodyPr/>
+                    <a:lstStyle/>
+                    <a:p>
+                      <a:r>
+                        <a:rPr sz="1100"/>
+                        <a:t>45</a:t>
+                      </a:r>
+                    </a:p>
+                  </a:txBody>
+                  <a:tcPr marT="0" marB="0"/>
+                </a:tc>
+                <a:extLst>
+                  <a:ext uri="{0D108BD9-81ED-4DB2-BD59-A6C34878D82A}">
+                    <a16:rowId xmlns:a16="http://schemas.microsoft.com/office/drawing/2014/main" val="10001"/>
+                  </a:ext>
+                </a:extLst>
+              </a:tr>
+              <a:tr h="231382">
+                <a:tc>
+                  <a:txBody>
+                    <a:bodyPr/>
+                    <a:lstStyle/>
+                    <a:p>
+                      <a:r>
+                        <a:rPr sz="1100"/>
+                        <a:t>B34-G1</a:t>
+                      </a:r>
+                    </a:p>
+                  </a:txBody>
+                  <a:tcPr marT="0" marB="0"/>
+                </a:tc>
+                <a:tc>
+                  <a:txBody>
+                    <a:bodyPr/>
+                    <a:lstStyle/>
+                    <a:p>
+                      <a:r>
+                        <a:rPr sz="1100"/>
+                        <a:t>IEEE 39</a:t>
+                      </a:r>
+                    </a:p>
+                  </a:txBody>
+                  <a:tcPr marT="0" marB="0"/>
+                </a:tc>
+                <a:tc>
+                  <a:txBody>
+                    <a:bodyPr/>
+                    <a:lstStyle/>
+                    <a:p>
+                      <a:r>
+                        <a:rPr sz="1100"/>
+                        <a:t>COAL</a:t>
+                      </a:r>
+                    </a:p>
+                  </a:txBody>
+                  <a:tcPr marT="0" marB="0"/>
+                </a:tc>
+                <a:tc>
+                  <a:txBody>
+                    <a:bodyPr/>
+                    <a:lstStyle/>
+                    <a:p>
+                      <a:r>
+                        <a:rPr sz="1100"/>
+                        <a:t>751.5</a:t>
+                      </a:r>
+                    </a:p>
+                  </a:txBody>
+                  <a:tcPr marT="0" marB="0"/>
+                </a:tc>
+                <a:tc>
+                  <a:txBody>
+                    <a:bodyPr/>
+                    <a:lstStyle/>
+                    <a:p>
+                      <a:r>
+                        <a:rPr sz="1100"/>
+                        <a:t>45</a:t>
+                      </a:r>
+                    </a:p>
+                  </a:txBody>
+                  <a:tcPr marT="0" marB="0"/>
+                </a:tc>
+                <a:extLst>
+                  <a:ext uri="{0D108BD9-81ED-4DB2-BD59-A6C34878D82A}">
+                    <a16:rowId xmlns:a16="http://schemas.microsoft.com/office/drawing/2014/main" val="10002"/>
+                  </a:ext>
+                </a:extLst>
+              </a:tr>
+              <a:tr h="231382">
+                <a:tc>
+                  <a:txBody>
+                    <a:bodyPr/>
+                    <a:lstStyle/>
+                    <a:p>
+                      <a:r>
+                        <a:rPr sz="1100"/>
+                        <a:t>B35-G1</a:t>
+                      </a:r>
+                    </a:p>
+                  </a:txBody>
+                  <a:tcPr marT="0" marB="0"/>
+                </a:tc>
+                <a:tc>
+                  <a:txBody>
+                    <a:bodyPr/>
+                    <a:lstStyle/>
+                    <a:p>
+                      <a:r>
+                        <a:rPr sz="1100"/>
+                        <a:t>IEEE 39</a:t>
+                      </a:r>
+                    </a:p>
+                  </a:txBody>
+                  <a:tcPr marT="0" marB="0"/>
+                </a:tc>
+                <a:tc>
+                  <a:txBody>
+                    <a:bodyPr/>
+                    <a:lstStyle/>
+                    <a:p>
+                      <a:r>
+                        <a:rPr sz="1100"/>
+                        <a:t>NUCLEAR</a:t>
+                      </a:r>
+                    </a:p>
+                  </a:txBody>
+                  <a:tcPr marT="0" marB="0"/>
+                </a:tc>
+                <a:tc>
+                  <a:txBody>
+                    <a:bodyPr/>
+                    <a:lstStyle/>
+                    <a:p>
+                      <a:r>
+                        <a:rPr sz="1100"/>
+                        <a:t>751.5</a:t>
+                      </a:r>
+                    </a:p>
+                  </a:txBody>
+                  <a:tcPr marT="0" marB="0"/>
+                </a:tc>
+                <a:tc>
+                  <a:txBody>
+                    <a:bodyPr/>
+                    <a:lstStyle/>
+                    <a:p>
+                      <a:r>
+                        <a:rPr sz="1100"/>
+                        <a:t>8</a:t>
+                      </a:r>
+                    </a:p>
+                  </a:txBody>
+                  <a:tcPr marT="0" marB="0"/>
+                </a:tc>
+                <a:extLst>
+                  <a:ext uri="{0D108BD9-81ED-4DB2-BD59-A6C34878D82A}">
+                    <a16:rowId xmlns:a16="http://schemas.microsoft.com/office/drawing/2014/main" val="10001"/>
+                  </a:ext>
+                </a:extLst>
+              </a:tr>
+              <a:tr h="231382">
+                <a:tc>
+                  <a:txBody>
+                    <a:bodyPr/>
+                    <a:lstStyle/>
+                    <a:p>
+                      <a:r>
+                        <a:rPr sz="1100"/>
+                        <a:t>B36-G1</a:t>
+                      </a:r>
+                    </a:p>
+                  </a:txBody>
+                  <a:tcPr marT="0" marB="0"/>
+                </a:tc>
+                <a:tc>
+                  <a:txBody>
+                    <a:bodyPr/>
+                    <a:lstStyle/>
+                    <a:p>
+                      <a:r>
+                        <a:rPr sz="1100"/>
+                        <a:t>IEEE 39</a:t>
+                      </a:r>
+                    </a:p>
+                  </a:txBody>
+                  <a:tcPr marT="0" marB="0"/>
+                </a:tc>
+                <a:tc>
+                  <a:txBody>
+                    <a:bodyPr/>
+                    <a:lstStyle/>
+                    <a:p>
+                      <a:r>
+                        <a:rPr sz="1100"/>
+                        <a:t>COAL</a:t>
+                      </a:r>
+                    </a:p>
+                  </a:txBody>
+                  <a:tcPr marT="0" marB="0"/>
+                </a:tc>
+                <a:tc>
+                  <a:txBody>
+                    <a:bodyPr/>
+                    <a:lstStyle/>
+                    <a:p>
+                      <a:r>
+                        <a:rPr sz="1100"/>
+                        <a:t>751.5</a:t>
+                      </a:r>
+                    </a:p>
+                  </a:txBody>
+                  <a:tcPr marT="0" marB="0"/>
+                </a:tc>
+                <a:tc>
+                  <a:txBody>
+                    <a:bodyPr/>
+                    <a:lstStyle/>
+                    <a:p>
+                      <a:r>
+                        <a:rPr sz="1100"/>
+                        <a:t>45</a:t>
+                      </a:r>
+                    </a:p>
+                  </a:txBody>
+                  <a:tcPr marT="0" marB="0"/>
+                </a:tc>
+                <a:extLst>
+                  <a:ext uri="{0D108BD9-81ED-4DB2-BD59-A6C34878D82A}">
+                    <a16:rowId xmlns:a16="http://schemas.microsoft.com/office/drawing/2014/main" val="10002"/>
+                  </a:ext>
+                </a:extLst>
+              </a:tr>
+              <a:tr h="231382">
+                <a:tc>
+                  <a:txBody>
+                    <a:bodyPr/>
+                    <a:lstStyle/>
+                    <a:p>
+                      <a:r>
+                        <a:rPr sz="1100"/>
+                        <a:t>B37-G1</a:t>
+                      </a:r>
+                    </a:p>
+                  </a:txBody>
+                  <a:tcPr marT="0" marB="0"/>
+                </a:tc>
+                <a:tc>
+                  <a:txBody>
+                    <a:bodyPr/>
+                    <a:lstStyle/>
+                    <a:p>
+                      <a:r>
+                        <a:rPr sz="1100"/>
+                        <a:t>IEEE 39</a:t>
+                      </a:r>
+                    </a:p>
+                  </a:txBody>
+                  <a:tcPr marT="0" marB="0"/>
+                </a:tc>
+                <a:tc>
+                  <a:txBody>
+                    <a:bodyPr/>
+                    <a:lstStyle/>
+                    <a:p>
+                      <a:r>
+                        <a:rPr sz="1100"/>
+                        <a:t>NUCLEAR</a:t>
+                      </a:r>
+                    </a:p>
+                  </a:txBody>
+                  <a:tcPr marT="0" marB="0"/>
+                </a:tc>
+                <a:tc>
+                  <a:txBody>
+                    <a:bodyPr/>
+                    <a:lstStyle/>
+                    <a:p>
+                      <a:r>
+                        <a:rPr sz="1100"/>
+                        <a:t>751.5</a:t>
+                      </a:r>
+                    </a:p>
+                  </a:txBody>
+                  <a:tcPr marT="0" marB="0"/>
+                </a:tc>
+                <a:tc>
+                  <a:txBody>
+                    <a:bodyPr/>
+                    <a:lstStyle/>
+                    <a:p>
+                      <a:r>
+                        <a:rPr sz="1100"/>
+                        <a:t>8</a:t>
+                      </a:r>
+                    </a:p>
+                  </a:txBody>
+                  <a:tcPr marT="0" marB="0"/>
+                </a:tc>
+                <a:extLst>
+                  <a:ext uri="{0D108BD9-81ED-4DB2-BD59-A6C34878D82A}">
+                    <a16:rowId xmlns:a16="http://schemas.microsoft.com/office/drawing/2014/main" val="10001"/>
+                  </a:ext>
+                </a:extLst>
+              </a:tr>
+              <a:tr h="231382">
+                <a:tc>
+                  <a:txBody>
+                    <a:bodyPr/>
+                    <a:lstStyle/>
+                    <a:p>
+                      <a:r>
+                        <a:rPr sz="1100"/>
+                        <a:t>B38-G1</a:t>
+                      </a:r>
+                    </a:p>
+                  </a:txBody>
+                  <a:tcPr marT="0" marB="0"/>
+                </a:tc>
+                <a:tc>
+                  <a:txBody>
+                    <a:bodyPr/>
+                    <a:lstStyle/>
+                    <a:p>
+                      <a:r>
+                        <a:rPr sz="1100"/>
+                        <a:t>IEEE 39</a:t>
+                      </a:r>
+                    </a:p>
+                  </a:txBody>
+                  <a:tcPr marT="0" marB="0"/>
+                </a:tc>
+                <a:tc>
+                  <a:txBody>
+                    <a:bodyPr/>
+                    <a:lstStyle/>
+                    <a:p>
+                      <a:r>
+                        <a:rPr sz="1100"/>
+                        <a:t>NUCLEAR</a:t>
+                      </a:r>
+                    </a:p>
+                  </a:txBody>
+                  <a:tcPr marT="0" marB="0"/>
+                </a:tc>
+                <a:tc>
+                  <a:txBody>
+                    <a:bodyPr/>
+                    <a:lstStyle/>
+                    <a:p>
+                      <a:r>
+                        <a:rPr sz="1100"/>
+                        <a:t>865.45</a:t>
+                      </a:r>
+                    </a:p>
+                  </a:txBody>
+                  <a:tcPr marT="0" marB="0"/>
+                </a:tc>
+                <a:tc>
+                  <a:txBody>
+                    <a:bodyPr/>
+                    <a:lstStyle/>
+                    <a:p>
+                      <a:r>
+                        <a:rPr sz="1100"/>
+                        <a:t>8</a:t>
+                      </a:r>
+                    </a:p>
+                  </a:txBody>
+                  <a:tcPr marT="0" marB="0"/>
+                </a:tc>
+                <a:extLst>
+                  <a:ext uri="{0D108BD9-81ED-4DB2-BD59-A6C34878D82A}">
+                    <a16:rowId xmlns:a16="http://schemas.microsoft.com/office/drawing/2014/main" val="10002"/>
+                  </a:ext>
+                </a:extLst>
+              </a:tr>
+              <a:tr h="231382">
+                <a:tc>
+                  <a:txBody>
+                    <a:bodyPr/>
+                    <a:lstStyle/>
+                    <a:p>
+                      <a:r>
+                        <a:rPr sz="1100"/>
+                        <a:t>B39-G1</a:t>
+                      </a:r>
+                    </a:p>
+                  </a:txBody>
+                  <a:tcPr marT="0" marB="0"/>
+                </a:tc>
+                <a:tc>
+                  <a:txBody>
+                    <a:bodyPr/>
+                    <a:lstStyle/>
+                    <a:p>
+                      <a:r>
+                        <a:rPr sz="1100"/>
+                        <a:t>IEEE 39</a:t>
+                      </a:r>
+                    </a:p>
+                  </a:txBody>
+                  <a:tcPr marT="0" marB="0"/>
+                </a:tc>
+                <a:tc>
+                  <a:txBody>
+                    <a:bodyPr/>
+                    <a:lstStyle/>
+                    <a:p>
+                      <a:r>
+                        <a:rPr sz="1100"/>
+                        <a:t>NUCLEAR</a:t>
+                      </a:r>
+                    </a:p>
+                  </a:txBody>
+                  <a:tcPr marT="0" marB="0"/>
+                </a:tc>
+                <a:tc>
+                  <a:txBody>
+                    <a:bodyPr/>
+                    <a:lstStyle/>
+                    <a:p>
+                      <a:r>
+                        <a:rPr sz="1100"/>
+                        <a:t>819.9</a:t>
+                      </a:r>
+                    </a:p>
+                  </a:txBody>
+                  <a:tcPr marT="0" marB="0"/>
+                </a:tc>
+                <a:tc>
+                  <a:txBody>
+                    <a:bodyPr/>
+                    <a:lstStyle/>
+                    <a:p>
+                      <a:r>
+                        <a:rPr sz="1100"/>
+                        <a:t>8</a:t>
+                      </a:r>
+                    </a:p>
+                  </a:txBody>
+                  <a:tcPr marT="0" marB="0"/>
+                </a:tc>
+                <a:extLst>
+                  <a:ext uri="{0D108BD9-81ED-4DB2-BD59-A6C34878D82A}">
+                    <a16:rowId xmlns:a16="http://schemas.microsoft.com/office/drawing/2014/main" val="10001"/>
+                  </a:ext>
+                </a:extLst>
+              </a:tr>
+              <a:tr h="231382">
+                <a:tc>
+                  <a:txBody>
+                    <a:bodyPr/>
+                    <a:lstStyle/>
+                    <a:p>
+                      <a:r>
+                        <a:rPr sz="1100"/>
+                        <a:t>PV-B106-1</a:t>
+                      </a:r>
+                    </a:p>
+                  </a:txBody>
+                  <a:tcPr marT="0" marB="0"/>
+                </a:tc>
+                <a:tc>
+                  <a:txBody>
+                    <a:bodyPr/>
+                    <a:lstStyle/>
+                    <a:p>
+                      <a:r>
+                        <a:rPr sz="1100"/>
+                        <a:t>IEEE 14</a:t>
+                      </a:r>
+                    </a:p>
+                  </a:txBody>
+                  <a:tcPr marT="0" marB="0"/>
+                </a:tc>
+                <a:tc>
+                  <a:txBody>
+                    <a:bodyPr/>
+                    <a:lstStyle/>
+                    <a:p>
+                      <a:r>
+                        <a:rPr sz="1100" b="1">
+                          <a:solidFill>
+                            <a:srgbClr val="2E86AB"/>
+                          </a:solidFill>
+                        </a:rPr>
+                        <a:t>SOLAR</a:t>
+                      </a:r>
+                    </a:p>
+                  </a:txBody>
+                  <a:tcPr marT="0" marB="0"/>
+                </a:tc>
+                <a:tc>
+                  <a:txBody>
+                    <a:bodyPr/>
+                    <a:lstStyle/>
+                    <a:p>
+                      <a:r>
+                        <a:rPr sz="1100"/>
+                        <a:t>30</a:t>
+                      </a:r>
+                    </a:p>
+                  </a:txBody>
+                  <a:tcPr marT="0" marB="0"/>
+                </a:tc>
+                <a:tc>
+                  <a:txBody>
+                    <a:bodyPr/>
+                    <a:lstStyle/>
+                    <a:p>
+                      <a:r>
+                        <a:rPr sz="1100"/>
+                        <a:t>0</a:t>
+                      </a:r>
+                    </a:p>
+                  </a:txBody>
+                  <a:tcPr marT="0" marB="0"/>
+                </a:tc>
+                <a:extLst>
+                  <a:ext uri="{0D108BD9-81ED-4DB2-BD59-A6C34878D82A}">
+                    <a16:rowId xmlns:a16="http://schemas.microsoft.com/office/drawing/2014/main" val="10004"/>
+                  </a:ext>
+                </a:extLst>
+              </a:tr>
+              <a:tr h="231382">
+                <a:tc>
+                  <a:txBody>
+                    <a:bodyPr/>
+                    <a:lstStyle/>
+                    <a:p>
+                      <a:r>
+                        <a:rPr sz="1100"/>
+                        <a:t>PV-B21-1</a:t>
+                      </a:r>
+                    </a:p>
+                  </a:txBody>
+                  <a:tcPr marT="0" marB="0"/>
+                </a:tc>
+                <a:tc>
+                  <a:txBody>
+                    <a:bodyPr/>
+                    <a:lstStyle/>
+                    <a:p>
+                      <a:r>
+                        <a:rPr sz="1100"/>
+                        <a:t>IEEE 39</a:t>
+                      </a:r>
+                    </a:p>
+                  </a:txBody>
+                  <a:tcPr marT="0" marB="0"/>
+                </a:tc>
+                <a:tc>
+                  <a:txBody>
+                    <a:bodyPr/>
+                    <a:lstStyle/>
+                    <a:p>
+                      <a:r>
+                        <a:rPr sz="1100" b="1">
+                          <a:solidFill>
+                            <a:srgbClr val="2E86AB"/>
+                          </a:solidFill>
+                        </a:rPr>
+                        <a:t>SOLAR</a:t>
+                      </a:r>
+                    </a:p>
+                  </a:txBody>
+                  <a:tcPr marT="0" marB="0"/>
+                </a:tc>
+                <a:tc>
+                  <a:txBody>
+                    <a:bodyPr/>
+                    <a:lstStyle/>
+                    <a:p>
+                      <a:r>
+                        <a:rPr sz="1100"/>
+                        <a:t>200</a:t>
+                      </a:r>
+                    </a:p>
+                  </a:txBody>
+                  <a:tcPr marT="0" marB="0"/>
+                </a:tc>
+                <a:tc>
+                  <a:txBody>
+                    <a:bodyPr/>
+                    <a:lstStyle/>
+                    <a:p>
+                      <a:r>
+                        <a:rPr sz="1100"/>
+                        <a:t>0</a:t>
+                      </a:r>
+                    </a:p>
+                  </a:txBody>
+                  <a:tcPr marT="0" marB="0"/>
+                </a:tc>
+                <a:extLst>
+                  <a:ext uri="{0D108BD9-81ED-4DB2-BD59-A6C34878D82A}">
+                    <a16:rowId xmlns:a16="http://schemas.microsoft.com/office/drawing/2014/main" val="10003"/>
+                  </a:ext>
+                </a:extLst>
+              </a:tr>
+              <a:tr h="231382">
+                <a:tc>
+                  <a:txBody>
+                    <a:bodyPr/>
+                    <a:lstStyle/>
+                    <a:p>
+                      <a:r>
+                        <a:rPr sz="1100"/>
+                        <a:t>PV-B6-1</a:t>
+                      </a:r>
+                    </a:p>
+                  </a:txBody>
+                  <a:tcPr marT="0" marB="0"/>
+                </a:tc>
+                <a:tc>
+                  <a:txBody>
+                    <a:bodyPr/>
+                    <a:lstStyle/>
+                    <a:p>
+                      <a:r>
+                        <a:rPr sz="1100"/>
+                        <a:t>IEEE 39</a:t>
+                      </a:r>
+                    </a:p>
+                  </a:txBody>
+                  <a:tcPr marT="0" marB="0"/>
+                </a:tc>
+                <a:tc>
+                  <a:txBody>
+                    <a:bodyPr/>
+                    <a:lstStyle/>
+                    <a:p>
+                      <a:r>
+                        <a:rPr sz="1100" b="1">
+                          <a:solidFill>
+                            <a:srgbClr val="2E86AB"/>
+                          </a:solidFill>
+                        </a:rPr>
+                        <a:t>SOLAR</a:t>
+                      </a:r>
+                    </a:p>
+                  </a:txBody>
+                  <a:tcPr marT="0" marB="0"/>
+                </a:tc>
+                <a:tc>
+                  <a:txBody>
+                    <a:bodyPr/>
+                    <a:lstStyle/>
+                    <a:p>
+                      <a:r>
+                        <a:rPr sz="1100"/>
+                        <a:t>400</a:t>
+                      </a:r>
+                    </a:p>
+                  </a:txBody>
+                  <a:tcPr marT="0" marB="0"/>
+                </a:tc>
+                <a:tc>
+                  <a:txBody>
+                    <a:bodyPr/>
+                    <a:lstStyle/>
+                    <a:p>
+                      <a:r>
+                        <a:rPr sz="1100"/>
+                        <a:t>0</a:t>
+                      </a:r>
+                    </a:p>
+                  </a:txBody>
+                  <a:tcPr marT="0" marB="0"/>
+                </a:tc>
+                <a:extLst>
+                  <a:ext uri="{0D108BD9-81ED-4DB2-BD59-A6C34878D82A}">
+                    <a16:rowId xmlns:a16="http://schemas.microsoft.com/office/drawing/2014/main" val="10004"/>
+                  </a:ext>
+                </a:extLst>
+              </a:tr>
+              <a:tr h="231382">
+                <a:tc>
+                  <a:txBody>
+                    <a:bodyPr/>
+                    <a:lstStyle/>
+                    <a:p>
+                      <a:r>
+                        <a:rPr sz="1100"/>
+                        <a:t>WF-B101-1</a:t>
+                      </a:r>
+                    </a:p>
+                  </a:txBody>
+                  <a:tcPr marT="0" marB="0"/>
+                </a:tc>
+                <a:tc>
+                  <a:txBody>
+                    <a:bodyPr/>
+                    <a:lstStyle/>
+                    <a:p>
+                      <a:r>
+                        <a:rPr sz="1100"/>
+                        <a:t>IEEE 14</a:t>
+                      </a:r>
+                    </a:p>
+                  </a:txBody>
+                  <a:tcPr marT="0" marB="0"/>
                 </a:tc>
                 <a:tc>
                   <a:txBody>
@@ -5298,7 +6466,7 @@
                       </a:r>
                     </a:p>
                   </a:txBody>
-                  <a:tcPr/>
+                  <a:tcPr marT="0" marB="0"/>
                 </a:tc>
                 <a:tc>
                   <a:txBody>
@@ -5311,7 +6479,7 @@
                       </a:r>
                     </a:p>
                   </a:txBody>
-                  <a:tcPr/>
+                  <a:tcPr marT="0" marB="0"/>
                 </a:tc>
                 <a:tc>
                   <a:txBody>
@@ -5324,7 +6492,7 @@
                       </a:r>
                     </a:p>
                   </a:txBody>
-                  <a:tcPr/>
+                  <a:tcPr marT="0" marB="0"/>
                 </a:tc>
                 <a:extLst>
                   <a:ext uri="{0D108BD9-81ED-4DB2-BD59-A6C34878D82A}">
@@ -5332,32 +6500,32 @@
                   </a:ext>
                 </a:extLst>
               </a:tr>
-              <a:tr h="320040">
-                <a:tc>
-                  <a:txBody>
-                    <a:bodyPr/>
-                    <a:lstStyle/>
-                    <a:p>
-                      <a:r>
-                        <a:rPr sz="1100"/>
-                        <a:t>B106-G1</a:t>
-                      </a:r>
-                    </a:p>
-                  </a:txBody>
-                  <a:tcPr/>
-                </a:tc>
-                <a:tc>
-                  <a:txBody>
-                    <a:bodyPr/>
-                    <a:lstStyle/>
-                    <a:p>
-                      <a:r>
-                        <a:rPr sz="1100"/>
-                        <a:t>IEEE 14</a:t>
-                      </a:r>
-                    </a:p>
-                  </a:txBody>
-                  <a:tcPr/>
+              <a:tr h="231382">
+                <a:tc>
+                  <a:txBody>
+                    <a:bodyPr/>
+                    <a:lstStyle/>
+                    <a:p>
+                      <a:r>
+                        <a:rPr sz="1100"/>
+                        <a:t>WF-B14-1</a:t>
+                      </a:r>
+                    </a:p>
+                  </a:txBody>
+                  <a:tcPr marT="0" marB="0"/>
+                </a:tc>
+                <a:tc>
+                  <a:txBody>
+                    <a:bodyPr/>
+                    <a:lstStyle/>
+                    <a:p>
+                      <a:r>
+                        <a:rPr sz="1100"/>
+                        <a:t>IEEE 39</a:t>
+                      </a:r>
+                    </a:p>
+                  </a:txBody>
+                  <a:tcPr marT="0" marB="0"/>
                 </a:tc>
                 <a:tc>
                   <a:txBody>
@@ -5370,37 +6538,37 @@
                             <a:srgbClr val="2E86AB"/>
                           </a:solidFill>
                         </a:rPr>
-                        <a:t>SOLAR</a:t>
-                      </a:r>
-                    </a:p>
-                  </a:txBody>
-                  <a:tcPr/>
-                </a:tc>
-                <a:tc>
-                  <a:txBody>
-                    <a:bodyPr/>
-                    <a:lstStyle/>
-                    <a:p>
-                      <a:r>
-                        <a:rPr sz="1100"/>
-                        <a:t>30</a:t>
-                      </a:r>
-                    </a:p>
-                  </a:txBody>
-                  <a:tcPr/>
-                </a:tc>
-                <a:tc>
-                  <a:txBody>
-                    <a:bodyPr/>
-                    <a:lstStyle/>
-                    <a:p>
-                      <a:r>
-                        <a:rPr sz="1100"/>
-                        <a:t>0</a:t>
-                      </a:r>
-                    </a:p>
-                  </a:txBody>
-                  <a:tcPr/>
+                        <a:t>WIND</a:t>
+                      </a:r>
+                    </a:p>
+                  </a:txBody>
+                  <a:tcPr marT="0" marB="0"/>
+                </a:tc>
+                <a:tc>
+                  <a:txBody>
+                    <a:bodyPr/>
+                    <a:lstStyle/>
+                    <a:p>
+                      <a:r>
+                        <a:rPr sz="1100"/>
+                        <a:t>400</a:t>
+                      </a:r>
+                    </a:p>
+                  </a:txBody>
+                  <a:tcPr marT="0" marB="0"/>
+                </a:tc>
+                <a:tc>
+                  <a:txBody>
+                    <a:bodyPr/>
+                    <a:lstStyle/>
+                    <a:p>
+                      <a:r>
+                        <a:rPr sz="1100"/>
+                        <a:t>1</a:t>
+                      </a:r>
+                    </a:p>
+                  </a:txBody>
+                  <a:tcPr marT="0" marB="0"/>
                 </a:tc>
                 <a:extLst>
                   <a:ext uri="{0D108BD9-81ED-4DB2-BD59-A6C34878D82A}">
@@ -5408,95 +6576,19 @@
                   </a:ext>
                 </a:extLst>
               </a:tr>
-              <a:tr h="320040">
-                <a:tc>
-                  <a:txBody>
-                    <a:bodyPr/>
-                    <a:lstStyle/>
-                    <a:p>
-                      <a:r>
-                        <a:rPr sz="1100"/>
-                        <a:t>B108-G1</a:t>
-                      </a:r>
-                    </a:p>
-                  </a:txBody>
-                  <a:tcPr/>
-                </a:tc>
-                <a:tc>
-                  <a:txBody>
-                    <a:bodyPr/>
-                    <a:lstStyle/>
-                    <a:p>
-                      <a:r>
-                        <a:rPr sz="1100"/>
-                        <a:t>IEEE 14</a:t>
-                      </a:r>
-                    </a:p>
-                  </a:txBody>
-                  <a:tcPr/>
-                </a:tc>
-                <a:tc>
-                  <a:txBody>
-                    <a:bodyPr/>
-                    <a:lstStyle/>
-                    <a:p>
-                      <a:r>
-                        <a:rPr sz="1100" b="1">
-                          <a:solidFill>
-                            <a:srgbClr val="2E86AB"/>
-                          </a:solidFill>
-                        </a:rPr>
-                        <a:t>HYDRO</a:t>
-                      </a:r>
-                    </a:p>
-                  </a:txBody>
-                  <a:tcPr/>
-                </a:tc>
-                <a:tc>
-                  <a:txBody>
-                    <a:bodyPr/>
-                    <a:lstStyle/>
-                    <a:p>
-                      <a:r>
-                        <a:rPr sz="1100"/>
-                        <a:t>25</a:t>
-                      </a:r>
-                    </a:p>
-                  </a:txBody>
-                  <a:tcPr/>
-                </a:tc>
-                <a:tc>
-                  <a:txBody>
-                    <a:bodyPr/>
-                    <a:lstStyle/>
-                    <a:p>
-                      <a:r>
-                        <a:rPr sz="1100"/>
-                        <a:t>5</a:t>
-                      </a:r>
-                    </a:p>
-                  </a:txBody>
-                  <a:tcPr/>
-                </a:tc>
-                <a:extLst>
-                  <a:ext uri="{0D108BD9-81ED-4DB2-BD59-A6C34878D82A}">
-                    <a16:rowId xmlns:a16="http://schemas.microsoft.com/office/drawing/2014/main" val="10005"/>
-                  </a:ext>
-                </a:extLst>
-              </a:tr>
-              <a:tr h="320040">
-                <a:tc>
-                  <a:txBody>
-                    <a:bodyPr/>
-                    <a:lstStyle/>
-                    <a:p>
-                      <a:r>
-                        <a:rPr sz="1100"/>
-                        <a:t>B30-G1</a:t>
-                      </a:r>
-                    </a:p>
-                  </a:txBody>
-                  <a:tcPr/>
+              <a:tr h="231382">
+                <a:tc>
+                  <a:txBody>
+                    <a:bodyPr/>
+                    <a:lstStyle/>
+                    <a:p>
+                      <a:r>
+                        <a:rPr sz="1100"/>
+                        <a:t>WF-B15-1</a:t>
+                      </a:r>
+                    </a:p>
+                  </a:txBody>
+                  <a:tcPr marT="0" marB="0"/>
                 </a:tc>
                 <a:tc>
                   <a:txBody>
@@ -5509,7 +6601,7 @@
                       </a:r>
                     </a:p>
                   </a:txBody>
-                  <a:tcPr/>
+                  <a:tcPr marT="0" marB="0"/>
                 </a:tc>
                 <a:tc>
                   <a:txBody>
@@ -5526,20 +6618,20 @@
                       </a:r>
                     </a:p>
                   </a:txBody>
-                  <a:tcPr/>
-                </a:tc>
-                <a:tc>
-                  <a:txBody>
-                    <a:bodyPr/>
-                    <a:lstStyle/>
-                    <a:p>
-                      <a:r>
-                        <a:rPr sz="1100"/>
-                        <a:t>250</a:t>
-                      </a:r>
-                    </a:p>
-                  </a:txBody>
-                  <a:tcPr/>
+                  <a:tcPr marT="0" marB="0"/>
+                </a:tc>
+                <a:tc>
+                  <a:txBody>
+                    <a:bodyPr/>
+                    <a:lstStyle/>
+                    <a:p>
+                      <a:r>
+                        <a:rPr sz="1100"/>
+                        <a:t>300</a:t>
+                      </a:r>
+                    </a:p>
+                  </a:txBody>
+                  <a:tcPr marT="0" marB="0"/>
                 </a:tc>
                 <a:tc>
                   <a:txBody>
@@ -5552,27 +6644,27 @@
                       </a:r>
                     </a:p>
                   </a:txBody>
-                  <a:tcPr/>
+                  <a:tcPr marT="0" marB="0"/>
                 </a:tc>
                 <a:extLst>
                   <a:ext uri="{0D108BD9-81ED-4DB2-BD59-A6C34878D82A}">
-                    <a16:rowId xmlns:a16="http://schemas.microsoft.com/office/drawing/2014/main" val="10006"/>
+                    <a16:rowId xmlns:a16="http://schemas.microsoft.com/office/drawing/2014/main" val="10003"/>
                   </a:ext>
                 </a:extLst>
               </a:tr>
-              <a:tr h="320040">
-                <a:tc>
-                  <a:txBody>
-                    <a:bodyPr/>
-                    <a:lstStyle/>
-                    <a:p>
-                      <a:r>
-                        <a:rPr sz="1100"/>
-                        <a:t>B31-G1</a:t>
-                      </a:r>
-                    </a:p>
-                  </a:txBody>
-                  <a:tcPr/>
+              <a:tr h="231382">
+                <a:tc>
+                  <a:txBody>
+                    <a:bodyPr/>
+                    <a:lstStyle/>
+                    <a:p>
+                      <a:r>
+                        <a:rPr sz="1100"/>
+                        <a:t>WF-B3-1</a:t>
+                      </a:r>
+                    </a:p>
+                  </a:txBody>
+                  <a:tcPr marT="0" marB="0"/>
                 </a:tc>
                 <a:tc>
                   <a:txBody>
@@ -5585,299 +6677,7 @@
                       </a:r>
                     </a:p>
                   </a:txBody>
-                  <a:tcPr/>
-                </a:tc>
-                <a:tc>
-                  <a:txBody>
-                    <a:bodyPr/>
-                    <a:lstStyle/>
-                    <a:p>
-                      <a:r>
-                        <a:rPr sz="1100" b="1" dirty="0">
-                          <a:solidFill>
-                            <a:srgbClr val="2E86AB"/>
-                          </a:solidFill>
-                        </a:rPr>
-                        <a:t>SOLAR</a:t>
-                      </a:r>
-                    </a:p>
-                  </a:txBody>
-                  <a:tcPr/>
-                </a:tc>
-                <a:tc>
-                  <a:txBody>
-                    <a:bodyPr/>
-                    <a:lstStyle/>
-                    <a:p>
-                      <a:r>
-                        <a:rPr sz="1100"/>
-                        <a:t>570</a:t>
-                      </a:r>
-                    </a:p>
-                  </a:txBody>
-                  <a:tcPr/>
-                </a:tc>
-                <a:tc>
-                  <a:txBody>
-                    <a:bodyPr/>
-                    <a:lstStyle/>
-                    <a:p>
-                      <a:r>
-                        <a:rPr sz="1100"/>
-                        <a:t>0</a:t>
-                      </a:r>
-                    </a:p>
-                  </a:txBody>
-                  <a:tcPr/>
-                </a:tc>
-                <a:extLst>
-                  <a:ext uri="{0D108BD9-81ED-4DB2-BD59-A6C34878D82A}">
-                    <a16:rowId xmlns:a16="http://schemas.microsoft.com/office/drawing/2014/main" val="10007"/>
-                  </a:ext>
-                </a:extLst>
-              </a:tr>
-              <a:tr h="320040">
-                <a:tc>
-                  <a:txBody>
-                    <a:bodyPr/>
-                    <a:lstStyle/>
-                    <a:p>
-                      <a:r>
-                        <a:rPr sz="1100"/>
-                        <a:t>B32-G1</a:t>
-                      </a:r>
-                    </a:p>
-                  </a:txBody>
-                  <a:tcPr/>
-                </a:tc>
-                <a:tc>
-                  <a:txBody>
-                    <a:bodyPr/>
-                    <a:lstStyle/>
-                    <a:p>
-                      <a:r>
-                        <a:rPr sz="1100"/>
-                        <a:t>IEEE 39</a:t>
-                      </a:r>
-                    </a:p>
-                  </a:txBody>
-                  <a:tcPr/>
-                </a:tc>
-                <a:tc>
-                  <a:txBody>
-                    <a:bodyPr/>
-                    <a:lstStyle/>
-                    <a:p>
-                      <a:r>
-                        <a:rPr sz="1100"/>
-                        <a:t>COAL</a:t>
-                      </a:r>
-                    </a:p>
-                  </a:txBody>
-                  <a:tcPr/>
-                </a:tc>
-                <a:tc>
-                  <a:txBody>
-                    <a:bodyPr/>
-                    <a:lstStyle/>
-                    <a:p>
-                      <a:r>
-                        <a:rPr sz="1100"/>
-                        <a:t>975</a:t>
-                      </a:r>
-                    </a:p>
-                  </a:txBody>
-                  <a:tcPr/>
-                </a:tc>
-                <a:tc>
-                  <a:txBody>
-                    <a:bodyPr/>
-                    <a:lstStyle/>
-                    <a:p>
-                      <a:r>
-                        <a:rPr sz="1100"/>
-                        <a:t>45</a:t>
-                      </a:r>
-                    </a:p>
-                  </a:txBody>
-                  <a:tcPr/>
-                </a:tc>
-                <a:extLst>
-                  <a:ext uri="{0D108BD9-81ED-4DB2-BD59-A6C34878D82A}">
-                    <a16:rowId xmlns:a16="http://schemas.microsoft.com/office/drawing/2014/main" val="10008"/>
-                  </a:ext>
-                </a:extLst>
-              </a:tr>
-              <a:tr h="320040">
-                <a:tc>
-                  <a:txBody>
-                    <a:bodyPr/>
-                    <a:lstStyle/>
-                    <a:p>
-                      <a:r>
-                        <a:rPr sz="1100"/>
-                        <a:t>B33-G1</a:t>
-                      </a:r>
-                    </a:p>
-                  </a:txBody>
-                  <a:tcPr/>
-                </a:tc>
-                <a:tc>
-                  <a:txBody>
-                    <a:bodyPr/>
-                    <a:lstStyle/>
-                    <a:p>
-                      <a:r>
-                        <a:rPr sz="1100" dirty="0"/>
-                        <a:t>IEEE 39</a:t>
-                      </a:r>
-                    </a:p>
-                  </a:txBody>
-                  <a:tcPr/>
-                </a:tc>
-                <a:tc>
-                  <a:txBody>
-                    <a:bodyPr/>
-                    <a:lstStyle/>
-                    <a:p>
-                      <a:r>
-                        <a:rPr sz="1100"/>
-                        <a:t>NUCLEAR</a:t>
-                      </a:r>
-                    </a:p>
-                  </a:txBody>
-                  <a:tcPr/>
-                </a:tc>
-                <a:tc>
-                  <a:txBody>
-                    <a:bodyPr/>
-                    <a:lstStyle/>
-                    <a:p>
-                      <a:r>
-                        <a:rPr sz="1100"/>
-                        <a:t>950</a:t>
-                      </a:r>
-                    </a:p>
-                  </a:txBody>
-                  <a:tcPr/>
-                </a:tc>
-                <a:tc>
-                  <a:txBody>
-                    <a:bodyPr/>
-                    <a:lstStyle/>
-                    <a:p>
-                      <a:r>
-                        <a:rPr sz="1100"/>
-                        <a:t>8</a:t>
-                      </a:r>
-                    </a:p>
-                  </a:txBody>
-                  <a:tcPr/>
-                </a:tc>
-                <a:extLst>
-                  <a:ext uri="{0D108BD9-81ED-4DB2-BD59-A6C34878D82A}">
-                    <a16:rowId xmlns:a16="http://schemas.microsoft.com/office/drawing/2014/main" val="10009"/>
-                  </a:ext>
-                </a:extLst>
-              </a:tr>
-              <a:tr h="320040">
-                <a:tc>
-                  <a:txBody>
-                    <a:bodyPr/>
-                    <a:lstStyle/>
-                    <a:p>
-                      <a:r>
-                        <a:rPr sz="1100"/>
-                        <a:t>B34-G1</a:t>
-                      </a:r>
-                    </a:p>
-                  </a:txBody>
-                  <a:tcPr/>
-                </a:tc>
-                <a:tc>
-                  <a:txBody>
-                    <a:bodyPr/>
-                    <a:lstStyle/>
-                    <a:p>
-                      <a:r>
-                        <a:rPr sz="1100"/>
-                        <a:t>IEEE 39</a:t>
-                      </a:r>
-                    </a:p>
-                  </a:txBody>
-                  <a:tcPr/>
-                </a:tc>
-                <a:tc>
-                  <a:txBody>
-                    <a:bodyPr/>
-                    <a:lstStyle/>
-                    <a:p>
-                      <a:r>
-                        <a:rPr sz="1100" dirty="0"/>
-                        <a:t>GAS</a:t>
-                      </a:r>
-                    </a:p>
-                  </a:txBody>
-                  <a:tcPr/>
-                </a:tc>
-                <a:tc>
-                  <a:txBody>
-                    <a:bodyPr/>
-                    <a:lstStyle/>
-                    <a:p>
-                      <a:r>
-                        <a:rPr sz="1100"/>
-                        <a:t>762</a:t>
-                      </a:r>
-                    </a:p>
-                  </a:txBody>
-                  <a:tcPr/>
-                </a:tc>
-                <a:tc>
-                  <a:txBody>
-                    <a:bodyPr/>
-                    <a:lstStyle/>
-                    <a:p>
-                      <a:r>
-                        <a:rPr sz="1100"/>
-                        <a:t>70</a:t>
-                      </a:r>
-                    </a:p>
-                  </a:txBody>
-                  <a:tcPr/>
-                </a:tc>
-                <a:extLst>
-                  <a:ext uri="{0D108BD9-81ED-4DB2-BD59-A6C34878D82A}">
-                    <a16:rowId xmlns:a16="http://schemas.microsoft.com/office/drawing/2014/main" val="10010"/>
-                  </a:ext>
-                </a:extLst>
-              </a:tr>
-              <a:tr h="320040">
-                <a:tc>
-                  <a:txBody>
-                    <a:bodyPr/>
-                    <a:lstStyle/>
-                    <a:p>
-                      <a:r>
-                        <a:rPr sz="1100"/>
-                        <a:t>B35-G1</a:t>
-                      </a:r>
-                    </a:p>
-                  </a:txBody>
-                  <a:tcPr/>
-                </a:tc>
-                <a:tc>
-                  <a:txBody>
-                    <a:bodyPr/>
-                    <a:lstStyle/>
-                    <a:p>
-                      <a:r>
-                        <a:rPr sz="1100"/>
-                        <a:t>IEEE 39</a:t>
-                      </a:r>
-                    </a:p>
-                  </a:txBody>
-                  <a:tcPr/>
+                  <a:tcPr marT="0" marB="0"/>
                 </a:tc>
                 <a:tc>
                   <a:txBody>
@@ -5890,329 +6690,41 @@
                             <a:srgbClr val="2E86AB"/>
                           </a:solidFill>
                         </a:rPr>
-                        <a:t>HYDRO</a:t>
-                      </a:r>
-                    </a:p>
-                  </a:txBody>
-                  <a:tcPr/>
-                </a:tc>
-                <a:tc>
-                  <a:txBody>
-                    <a:bodyPr/>
-                    <a:lstStyle/>
-                    <a:p>
-                      <a:r>
-                        <a:rPr sz="1100"/>
-                        <a:t>650</a:t>
-                      </a:r>
-                    </a:p>
-                  </a:txBody>
-                  <a:tcPr/>
-                </a:tc>
-                <a:tc>
-                  <a:txBody>
-                    <a:bodyPr/>
-                    <a:lstStyle/>
-                    <a:p>
-                      <a:r>
-                        <a:rPr sz="1100"/>
-                        <a:t>5</a:t>
-                      </a:r>
-                    </a:p>
-                  </a:txBody>
-                  <a:tcPr/>
+                        <a:t>WIND</a:t>
+                      </a:r>
+                    </a:p>
+                  </a:txBody>
+                  <a:tcPr marT="0" marB="0"/>
+                </a:tc>
+                <a:tc>
+                  <a:txBody>
+                    <a:bodyPr/>
+                    <a:lstStyle/>
+                    <a:p>
+                      <a:r>
+                        <a:rPr sz="1100"/>
+                        <a:t>200</a:t>
+                      </a:r>
+                    </a:p>
+                  </a:txBody>
+                  <a:tcPr marT="0" marB="0"/>
+                </a:tc>
+                <a:tc>
+                  <a:txBody>
+                    <a:bodyPr/>
+                    <a:lstStyle/>
+                    <a:p>
+                      <a:r>
+                        <a:rPr sz="1100"/>
+                        <a:t>1</a:t>
+                      </a:r>
+                    </a:p>
+                  </a:txBody>
+                  <a:tcPr marT="0" marB="0"/>
                 </a:tc>
                 <a:extLst>
                   <a:ext uri="{0D108BD9-81ED-4DB2-BD59-A6C34878D82A}">
-                    <a16:rowId xmlns:a16="http://schemas.microsoft.com/office/drawing/2014/main" val="10011"/>
-                  </a:ext>
-                </a:extLst>
-              </a:tr>
-              <a:tr h="320040">
-                <a:tc>
-                  <a:txBody>
-                    <a:bodyPr/>
-                    <a:lstStyle/>
-                    <a:p>
-                      <a:r>
-                        <a:rPr sz="1100"/>
-                        <a:t>B36-G1</a:t>
-                      </a:r>
-                    </a:p>
-                  </a:txBody>
-                  <a:tcPr/>
-                </a:tc>
-                <a:tc>
-                  <a:txBody>
-                    <a:bodyPr/>
-                    <a:lstStyle/>
-                    <a:p>
-                      <a:r>
-                        <a:rPr sz="1100"/>
-                        <a:t>IEEE 39</a:t>
-                      </a:r>
-                    </a:p>
-                  </a:txBody>
-                  <a:tcPr/>
-                </a:tc>
-                <a:tc>
-                  <a:txBody>
-                    <a:bodyPr/>
-                    <a:lstStyle/>
-                    <a:p>
-                      <a:r>
-                        <a:rPr sz="1100"/>
-                        <a:t>COAL</a:t>
-                      </a:r>
-                    </a:p>
-                  </a:txBody>
-                  <a:tcPr/>
-                </a:tc>
-                <a:tc>
-                  <a:txBody>
-                    <a:bodyPr/>
-                    <a:lstStyle/>
-                    <a:p>
-                      <a:r>
-                        <a:rPr sz="1100"/>
-                        <a:t>840</a:t>
-                      </a:r>
-                    </a:p>
-                  </a:txBody>
-                  <a:tcPr/>
-                </a:tc>
-                <a:tc>
-                  <a:txBody>
-                    <a:bodyPr/>
-                    <a:lstStyle/>
-                    <a:p>
-                      <a:r>
-                        <a:rPr sz="1100"/>
-                        <a:t>45</a:t>
-                      </a:r>
-                    </a:p>
-                  </a:txBody>
-                  <a:tcPr/>
-                </a:tc>
-                <a:extLst>
-                  <a:ext uri="{0D108BD9-81ED-4DB2-BD59-A6C34878D82A}">
-                    <a16:rowId xmlns:a16="http://schemas.microsoft.com/office/drawing/2014/main" val="10012"/>
-                  </a:ext>
-                </a:extLst>
-              </a:tr>
-              <a:tr h="320040">
-                <a:tc>
-                  <a:txBody>
-                    <a:bodyPr/>
-                    <a:lstStyle/>
-                    <a:p>
-                      <a:r>
-                        <a:rPr sz="1100"/>
-                        <a:t>B37-G1</a:t>
-                      </a:r>
-                    </a:p>
-                  </a:txBody>
-                  <a:tcPr/>
-                </a:tc>
-                <a:tc>
-                  <a:txBody>
-                    <a:bodyPr/>
-                    <a:lstStyle/>
-                    <a:p>
-                      <a:r>
-                        <a:rPr sz="1100"/>
-                        <a:t>IEEE 39</a:t>
-                      </a:r>
-                    </a:p>
-                  </a:txBody>
-                  <a:tcPr/>
-                </a:tc>
-                <a:tc>
-                  <a:txBody>
-                    <a:bodyPr/>
-                    <a:lstStyle/>
-                    <a:p>
-                      <a:r>
-                        <a:rPr sz="1100"/>
-                        <a:t>GAS</a:t>
-                      </a:r>
-                    </a:p>
-                  </a:txBody>
-                  <a:tcPr/>
-                </a:tc>
-                <a:tc>
-                  <a:txBody>
-                    <a:bodyPr/>
-                    <a:lstStyle/>
-                    <a:p>
-                      <a:r>
-                        <a:rPr sz="1100"/>
-                        <a:t>810</a:t>
-                      </a:r>
-                    </a:p>
-                  </a:txBody>
-                  <a:tcPr/>
-                </a:tc>
-                <a:tc>
-                  <a:txBody>
-                    <a:bodyPr/>
-                    <a:lstStyle/>
-                    <a:p>
-                      <a:r>
-                        <a:rPr sz="1100"/>
-                        <a:t>70</a:t>
-                      </a:r>
-                    </a:p>
-                  </a:txBody>
-                  <a:tcPr/>
-                </a:tc>
-                <a:extLst>
-                  <a:ext uri="{0D108BD9-81ED-4DB2-BD59-A6C34878D82A}">
-                    <a16:rowId xmlns:a16="http://schemas.microsoft.com/office/drawing/2014/main" val="10013"/>
-                  </a:ext>
-                </a:extLst>
-              </a:tr>
-              <a:tr h="320040">
-                <a:tc>
-                  <a:txBody>
-                    <a:bodyPr/>
-                    <a:lstStyle/>
-                    <a:p>
-                      <a:r>
-                        <a:rPr sz="1100"/>
-                        <a:t>B38-G1</a:t>
-                      </a:r>
-                    </a:p>
-                  </a:txBody>
-                  <a:tcPr/>
-                </a:tc>
-                <a:tc>
-                  <a:txBody>
-                    <a:bodyPr/>
-                    <a:lstStyle/>
-                    <a:p>
-                      <a:r>
-                        <a:rPr sz="1100"/>
-                        <a:t>IEEE 39</a:t>
-                      </a:r>
-                    </a:p>
-                  </a:txBody>
-                  <a:tcPr/>
-                </a:tc>
-                <a:tc>
-                  <a:txBody>
-                    <a:bodyPr/>
-                    <a:lstStyle/>
-                    <a:p>
-                      <a:r>
-                        <a:rPr sz="1100"/>
-                        <a:t>NUCLEAR</a:t>
-                      </a:r>
-                    </a:p>
-                  </a:txBody>
-                  <a:tcPr/>
-                </a:tc>
-                <a:tc>
-                  <a:txBody>
-                    <a:bodyPr/>
-                    <a:lstStyle/>
-                    <a:p>
-                      <a:r>
-                        <a:rPr sz="1100"/>
-                        <a:t>1245</a:t>
-                      </a:r>
-                    </a:p>
-                  </a:txBody>
-                  <a:tcPr/>
-                </a:tc>
-                <a:tc>
-                  <a:txBody>
-                    <a:bodyPr/>
-                    <a:lstStyle/>
-                    <a:p>
-                      <a:r>
-                        <a:rPr sz="1100"/>
-                        <a:t>8</a:t>
-                      </a:r>
-                    </a:p>
-                  </a:txBody>
-                  <a:tcPr/>
-                </a:tc>
-                <a:extLst>
-                  <a:ext uri="{0D108BD9-81ED-4DB2-BD59-A6C34878D82A}">
-                    <a16:rowId xmlns:a16="http://schemas.microsoft.com/office/drawing/2014/main" val="10014"/>
-                  </a:ext>
-                </a:extLst>
-              </a:tr>
-              <a:tr h="0">
-                <a:tc>
-                  <a:txBody>
-                    <a:bodyPr/>
-                    <a:lstStyle/>
-                    <a:p>
-                      <a:r>
-                        <a:rPr sz="1100"/>
-                        <a:t>B39-G1</a:t>
-                      </a:r>
-                    </a:p>
-                  </a:txBody>
-                  <a:tcPr/>
-                </a:tc>
-                <a:tc>
-                  <a:txBody>
-                    <a:bodyPr/>
-                    <a:lstStyle/>
-                    <a:p>
-                      <a:r>
-                        <a:rPr sz="1100"/>
-                        <a:t>IEEE 39</a:t>
-                      </a:r>
-                    </a:p>
-                  </a:txBody>
-                  <a:tcPr/>
-                </a:tc>
-                <a:tc>
-                  <a:txBody>
-                    <a:bodyPr/>
-                    <a:lstStyle/>
-                    <a:p>
-                      <a:r>
-                        <a:rPr sz="1100"/>
-                        <a:t>NUCLEAR</a:t>
-                      </a:r>
-                    </a:p>
-                  </a:txBody>
-                  <a:tcPr/>
-                </a:tc>
-                <a:tc>
-                  <a:txBody>
-                    <a:bodyPr/>
-                    <a:lstStyle/>
-                    <a:p>
-                      <a:r>
-                        <a:rPr sz="1100"/>
-                        <a:t>1500</a:t>
-                      </a:r>
-                    </a:p>
-                  </a:txBody>
-                  <a:tcPr/>
-                </a:tc>
-                <a:tc>
-                  <a:txBody>
-                    <a:bodyPr/>
-                    <a:lstStyle/>
-                    <a:p>
-                      <a:r>
-                        <a:rPr sz="1100" dirty="0"/>
-                        <a:t>8</a:t>
-                      </a:r>
-                    </a:p>
-                  </a:txBody>
-                  <a:tcPr/>
-                </a:tc>
-                <a:extLst>
-                  <a:ext uri="{0D108BD9-81ED-4DB2-BD59-A6C34878D82A}">
-                    <a16:rowId xmlns:a16="http://schemas.microsoft.com/office/drawing/2014/main" val="10015"/>
+                    <a16:rowId xmlns:a16="http://schemas.microsoft.com/office/drawing/2014/main" val="10004"/>
                   </a:ext>
                 </a:extLst>
               </a:tr>
@@ -6366,7 +6878,7 @@
             </a:pPr>
             <a:r>
               <a:rPr lang="en-GB" dirty="0"/>
-              <a:t>Loads at their source values (× 1.00 on P and Q).</a:t>
+              <a:t>Loads at their base-case values (× 1.00 on P and Q).</a:t>
             </a:r>
           </a:p>
           <a:p>
@@ -6380,7 +6892,7 @@
             </a:pPr>
             <a:r>
               <a:rPr lang="en-GB" dirty="0"/>
-              <a:t>RES units (wind, solar, hydro) at 50 % of nominal P.</a:t>
+              <a:t>Wind and solar units at 50 % of their rating; condensers at 0 MW.</a:t>
             </a:r>
           </a:p>
           <a:p>
@@ -6394,7 +6906,7 @@
             </a:pPr>
             <a:r>
               <a:rPr lang="en-GB" dirty="0"/>
-              <a:t>Other units in merit order within each AC island (ties in file order).</a:t>
+              <a:t>Synchronous units at 30 % minimum, the rest in merit order within each AC island.</a:t>
             </a:r>
           </a:p>
           <a:p>
@@ -6408,7 +6920,7 @@
             </a:pPr>
             <a:r>
               <a:rPr lang="en-GB" dirty="0"/>
-              <a:t>HVDC link at 50 MW from IEEE 39 → IEEE 14.</a:t>
+              <a:t>HVDC link at 40 MW from IEEE 39 → IEEE 14.</a:t>
             </a:r>
           </a:p>
           <a:p>
@@ -6509,7 +7021,7 @@
             </a:pPr>
             <a:r>
               <a:rPr lang="en-GB" dirty="0"/>
-              <a:t>HVDC: 50 MW (IEEE 39 → IEEE 14), maximum 60 MW</a:t>
+              <a:t>HVDC: 40 MW (IEEE 39 → IEEE 14), rating 50 MW</a:t>
             </a:r>
           </a:p>
           <a:p>
@@ -6523,7 +7035,7 @@
             </a:pPr>
             <a:r>
               <a:rPr lang="en-GB" dirty="0"/>
-              <a:t>Dispatched generation: IEEE 14: 209.0 MW  |  IEEE 39: 6199.5 MW (losses covered by the distributed slack)</a:t>
+              <a:t>Dispatched generation: IEEE 14: 219.0 MW  |  IEEE 39: 6234.5 MW (losses covered by the distributed slack)</a:t>
             </a:r>
           </a:p>
           <a:p>
@@ -6565,7 +7077,7 @@
             </a:pPr>
             <a:r>
               <a:rPr lang="en-GB" dirty="0"/>
-              <a:t>Highest branch loading: 93 % (T-10-32-1), no overload</a:t>
+              <a:t>Highest branch loading: 91 % (L-113-114-1), no overload</a:t>
             </a:r>
           </a:p>
         </p:txBody>
@@ -6729,7 +7241,7 @@
             </a:pPr>
             <a:r>
               <a:rPr lang="en-GB" dirty="0"/>
-              <a:t>RES units (wind, solar, hydro) at 100 % of nominal P.</a:t>
+              <a:t>Wind and solar units at 100 % of their rating; condensers at 0 MW.</a:t>
             </a:r>
           </a:p>
           <a:p>
@@ -6743,7 +7255,7 @@
             </a:pPr>
             <a:r>
               <a:rPr lang="en-GB" dirty="0"/>
-              <a:t>Other units in merit order within each AC island (ties in file order).</a:t>
+              <a:t>Synchronous units at 30 % minimum (scaled down in IEEE 14), the rest in merit order.</a:t>
             </a:r>
           </a:p>
           <a:p>
@@ -6757,7 +7269,7 @@
             </a:pPr>
             <a:r>
               <a:rPr lang="en-GB" dirty="0"/>
-              <a:t>HVDC link forced to its maximum: 60 MW from IEEE 39 → IEEE 14.</a:t>
+              <a:t>HVDC link forced to its 50 MW rating from IEEE 39 → IEEE 14.</a:t>
             </a:r>
           </a:p>
           <a:p>
@@ -6858,7 +7370,7 @@
             </a:pPr>
             <a:r>
               <a:rPr lang="en-GB" dirty="0"/>
-              <a:t>HVDC: 60 MW (IEEE 39 → IEEE 14), at its maximum</a:t>
+              <a:t>HVDC: 50 MW (IEEE 39 → IEEE 14), at its maximum</a:t>
             </a:r>
           </a:p>
           <a:p>
@@ -6872,7 +7384,7 @@
             </a:pPr>
             <a:r>
               <a:rPr lang="en-GB" dirty="0"/>
-              <a:t>Dispatched generation: IEEE 14: 121.3 MW  |  IEEE 39: 4364.6 MW (losses covered by the distributed slack)</a:t>
+              <a:t>Dispatched generation: IEEE 14: 131.3 MW  |  IEEE 39: 4386.0 MW (losses covered by the distributed slack)</a:t>
             </a:r>
           </a:p>
           <a:p>
@@ -6900,7 +7412,7 @@
             </a:pPr>
             <a:r>
               <a:rPr lang="en-GB" dirty="0"/>
-              <a:t>Bus voltages: 0.98–1.06 p.u.; largest rise from S1 +0.025 p.u. at B8 (IEEE 39)</a:t>
+              <a:t>Bus voltages: 0.98–1.08 p.u.; largest rise from S1 +0.035 p.u. at B4 (IEEE 39)</a:t>
             </a:r>
           </a:p>
           <a:p>
@@ -6914,7 +7426,7 @@
             </a:pPr>
             <a:r>
               <a:rPr lang="en-GB" dirty="0"/>
-              <a:t>Highest branch loading: 95 % (L-28-29-1), no overload</a:t>
+              <a:t>Highest branch loading: 99 % (L-113-114-1), no overload</a:t>
             </a:r>
           </a:p>
         </p:txBody>
@@ -7064,7 +7576,7 @@
             </a:pPr>
             <a:r>
               <a:rPr lang="en-GB" dirty="0"/>
-              <a:t>Loads scaled by 1.08 on P and 1.50 on Q.</a:t>
+              <a:t>Loads scaled by 1.08 on P and 1.80 on Q.</a:t>
             </a:r>
           </a:p>
           <a:p>
@@ -7078,7 +7590,7 @@
             </a:pPr>
             <a:r>
               <a:rPr lang="en-GB" dirty="0"/>
-              <a:t>RES units (wind, solar, hydro) at 10 % of nominal P.</a:t>
+              <a:t>Wind and solar units at 10 % of their rating; condensers at 0 MW.</a:t>
             </a:r>
           </a:p>
           <a:p>
@@ -7092,7 +7604,7 @@
             </a:pPr>
             <a:r>
               <a:rPr lang="en-GB" dirty="0"/>
-              <a:t>Other units in merit order within each AC island (ties in file order).</a:t>
+              <a:t>Synchronous units at 30 % minimum, the rest in merit order within each AC island.</a:t>
             </a:r>
           </a:p>
           <a:p>
@@ -7106,7 +7618,7 @@
             </a:pPr>
             <a:r>
               <a:rPr lang="en-GB" dirty="0"/>
-              <a:t>HVDC link at 50 MW from IEEE 39 → IEEE 14.</a:t>
+              <a:t>HVDC link at 40 MW from IEEE 39 → IEEE 14.</a:t>
             </a:r>
           </a:p>
           <a:p>
@@ -7207,7 +7719,7 @@
             </a:pPr>
             <a:r>
               <a:rPr lang="en-GB" dirty="0"/>
-              <a:t>HVDC: 50 MW (IEEE 39 → IEEE 14), maximum 60 MW</a:t>
+              <a:t>HVDC: 40 MW (IEEE 39 → IEEE 14), rating 50 MW</a:t>
             </a:r>
           </a:p>
           <a:p>
@@ -7221,7 +7733,7 @@
             </a:pPr>
             <a:r>
               <a:rPr lang="en-GB" dirty="0"/>
-              <a:t>Dispatched generation: IEEE 14: 229.7 MW  |  IEEE 39: 6691.5 MW (losses covered by the distributed slack)</a:t>
+              <a:t>Dispatched generation: IEEE 14: 239.7 MW  |  IEEE 39: 6730.2 MW (losses covered by the distributed slack)</a:t>
             </a:r>
           </a:p>
           <a:p>
@@ -7235,7 +7747,7 @@
             </a:pPr>
             <a:r>
               <a:rPr lang="en-GB" dirty="0"/>
-              <a:t>Load: IEEE 14: 279.7 MW / 110.2 Mvar  |  IEEE 39: 6690.3 MW / 2179.6 Mvar</a:t>
+              <a:t>Load: IEEE 14: 279.7 MW / 132.3 Mvar  |  IEEE 39: 6690.3 MW / 2615.6 Mvar</a:t>
             </a:r>
           </a:p>
           <a:p>
@@ -7249,7 +7761,7 @@
             </a:pPr>
             <a:r>
               <a:rPr lang="en-GB" dirty="0"/>
-              <a:t>Bus voltages: 0.96–1.06 p.u.; largest drop from S1 −0.036 p.u. at B109 (IEEE 14)</a:t>
+              <a:t>Bus voltages: 0.95–1.06 p.u.; largest drop from S1 −0.050 p.u. at B109 (IEEE 14)</a:t>
             </a:r>
           </a:p>
           <a:p>
@@ -7263,7 +7775,7 @@
             </a:pPr>
             <a:r>
               <a:rPr lang="en-GB" dirty="0"/>
-              <a:t>Overloads: L-16-19-1 172 %, L-6-11-1 108 %, L-10-11-1 104 %</a:t>
+              <a:t>Overloads: L-2-3-1 104 %, L-113-114-1 102 %</a:t>
             </a:r>
           </a:p>
         </p:txBody>

</xml_diff>

<commit_message>
chore(testcase): publish from dev@f81a503
</commit_message>
<xml_diff>
--- a/docs/scenarios_presentation.pptx
+++ b/docs/scenarios_presentation.pptx
@@ -4954,7 +4954,7 @@
             </a:pPr>
             <a:r>
               <a:rPr dirty="0"/>
-              <a:t>15 generators — type, nominal P, marginal price (synthetic, editable)</a:t>
+              <a:t>22 generators — type and rated P from PowerFactory, 7 added wind and solar units, synthetic marginal price</a:t>
             </a:r>
           </a:p>
         </p:txBody>
@@ -4975,7 +4975,7 @@
         </p:nvGraphicFramePr>
         <p:xfrm>
           <a:off x="662876" y="1216152"/>
-          <a:ext cx="9372600" cy="5059680"/>
+          <a:ext cx="9372600" cy="5321786"/>
         </p:xfrm>
         <a:graphic>
           <a:graphicData uri="http://schemas.openxmlformats.org/drawingml/2006/table">
@@ -5020,7 +5020,7 @@
                   </a:extLst>
                 </a:gridCol>
               </a:tblGrid>
-              <a:tr h="320040">
+              <a:tr h="231382">
                 <a:tc>
                   <a:txBody>
                     <a:bodyPr/>
@@ -5036,7 +5036,7 @@
                       </a:r>
                     </a:p>
                   </a:txBody>
-                  <a:tcPr/>
+                  <a:tcPr marT="0" marB="0"/>
                 </a:tc>
                 <a:tc>
                   <a:txBody>
@@ -5053,7 +5053,7 @@
                       </a:r>
                     </a:p>
                   </a:txBody>
-                  <a:tcPr/>
+                  <a:tcPr marT="0" marB="0"/>
                 </a:tc>
                 <a:tc>
                   <a:txBody>
@@ -5070,7 +5070,7 @@
                       </a:r>
                     </a:p>
                   </a:txBody>
-                  <a:tcPr/>
+                  <a:tcPr marT="0" marB="0"/>
                 </a:tc>
                 <a:tc>
                   <a:txBody>
@@ -5083,11 +5083,11 @@
                             <a:srgbClr val="FFFFFF"/>
                           </a:solidFill>
                         </a:rPr>
-                        <a:t>Nominal P (MW)</a:t>
-                      </a:r>
-                    </a:p>
-                  </a:txBody>
-                  <a:tcPr/>
+                        <a:t>Rated P (MW)</a:t>
+                      </a:r>
+                    </a:p>
+                  </a:txBody>
+                  <a:tcPr marT="0" marB="0"/>
                 </a:tc>
                 <a:tc>
                   <a:txBody>
@@ -5104,7 +5104,7 @@
                       </a:r>
                     </a:p>
                   </a:txBody>
-                  <a:tcPr/>
+                  <a:tcPr marT="0" marB="0"/>
                 </a:tc>
                 <a:extLst>
                   <a:ext uri="{0D108BD9-81ED-4DB2-BD59-A6C34878D82A}">
@@ -5112,7 +5112,7 @@
                   </a:ext>
                 </a:extLst>
               </a:tr>
-              <a:tr h="320040">
+              <a:tr h="231382">
                 <a:tc>
                   <a:txBody>
                     <a:bodyPr/>
@@ -5124,7 +5124,7 @@
                       </a:r>
                     </a:p>
                   </a:txBody>
-                  <a:tcPr/>
+                  <a:tcPr marT="0" marB="0"/>
                 </a:tc>
                 <a:tc>
                   <a:txBody>
@@ -5137,7 +5137,7 @@
                       </a:r>
                     </a:p>
                   </a:txBody>
-                  <a:tcPr/>
+                  <a:tcPr marT="0" marB="0"/>
                 </a:tc>
                 <a:tc>
                   <a:txBody>
@@ -5150,20 +5150,20 @@
                       </a:r>
                     </a:p>
                   </a:txBody>
-                  <a:tcPr/>
-                </a:tc>
-                <a:tc>
-                  <a:txBody>
-                    <a:bodyPr/>
-                    <a:lstStyle/>
-                    <a:p>
-                      <a:r>
-                        <a:rPr sz="1100"/>
-                        <a:t>350</a:t>
-                      </a:r>
-                    </a:p>
-                  </a:txBody>
-                  <a:tcPr/>
+                  <a:tcPr marT="0" marB="0"/>
+                </a:tc>
+                <a:tc>
+                  <a:txBody>
+                    <a:bodyPr/>
+                    <a:lstStyle/>
+                    <a:p>
+                      <a:r>
+                        <a:rPr sz="1100"/>
+                        <a:t>380.8</a:t>
+                      </a:r>
+                    </a:p>
+                  </a:txBody>
+                  <a:tcPr marT="0" marB="0"/>
                 </a:tc>
                 <a:tc>
                   <a:txBody>
@@ -5176,7 +5176,7 @@
                       </a:r>
                     </a:p>
                   </a:txBody>
-                  <a:tcPr/>
+                  <a:tcPr marT="0" marB="0"/>
                 </a:tc>
                 <a:extLst>
                   <a:ext uri="{0D108BD9-81ED-4DB2-BD59-A6C34878D82A}">
@@ -5184,7 +5184,7 @@
                   </a:ext>
                 </a:extLst>
               </a:tr>
-              <a:tr h="320040">
+              <a:tr h="231382">
                 <a:tc>
                   <a:txBody>
                     <a:bodyPr/>
@@ -5196,7 +5196,7 @@
                       </a:r>
                     </a:p>
                   </a:txBody>
-                  <a:tcPr/>
+                  <a:tcPr marT="0" marB="0"/>
                 </a:tc>
                 <a:tc>
                   <a:txBody>
@@ -5209,7 +5209,7 @@
                       </a:r>
                     </a:p>
                   </a:txBody>
-                  <a:tcPr/>
+                  <a:tcPr marT="0" marB="0"/>
                 </a:tc>
                 <a:tc>
                   <a:txBody>
@@ -5222,20 +5222,20 @@
                       </a:r>
                     </a:p>
                   </a:txBody>
-                  <a:tcPr/>
-                </a:tc>
-                <a:tc>
-                  <a:txBody>
-                    <a:bodyPr/>
-                    <a:lstStyle/>
-                    <a:p>
-                      <a:r>
-                        <a:rPr sz="1100"/>
-                        <a:t>60</a:t>
-                      </a:r>
-                    </a:p>
-                  </a:txBody>
-                  <a:tcPr/>
+                  <a:tcPr marT="0" marB="0"/>
+                </a:tc>
+                <a:tc>
+                  <a:txBody>
+                    <a:bodyPr/>
+                    <a:lstStyle/>
+                    <a:p>
+                      <a:r>
+                        <a:rPr sz="1100"/>
+                        <a:t>80</a:t>
+                      </a:r>
+                    </a:p>
+                  </a:txBody>
+                  <a:tcPr marT="0" marB="0"/>
                 </a:tc>
                 <a:tc>
                   <a:txBody>
@@ -5248,7 +5248,7 @@
                       </a:r>
                     </a:p>
                   </a:txBody>
-                  <a:tcPr/>
+                  <a:tcPr marT="0" marB="0"/>
                 </a:tc>
                 <a:extLst>
                   <a:ext uri="{0D108BD9-81ED-4DB2-BD59-A6C34878D82A}">
@@ -5256,7 +5256,7 @@
                   </a:ext>
                 </a:extLst>
               </a:tr>
-              <a:tr h="320040">
+              <a:tr h="231382">
                 <a:tc>
                   <a:txBody>
                     <a:bodyPr/>
@@ -5268,7 +5268,7 @@
                       </a:r>
                     </a:p>
                   </a:txBody>
-                  <a:tcPr/>
+                  <a:tcPr marT="0" marB="0"/>
                 </a:tc>
                 <a:tc>
                   <a:txBody>
@@ -5281,7 +5281,1175 @@
                       </a:r>
                     </a:p>
                   </a:txBody>
-                  <a:tcPr/>
+                  <a:tcPr marT="0" marB="0"/>
+                </a:tc>
+                <a:tc>
+                  <a:txBody>
+                    <a:bodyPr/>
+                    <a:lstStyle/>
+                    <a:p>
+                      <a:r>
+                        <a:rPr sz="1100"/>
+                        <a:t>CONDENSER</a:t>
+                      </a:r>
+                    </a:p>
+                  </a:txBody>
+                  <a:tcPr marT="0" marB="0"/>
+                </a:tc>
+                <a:tc>
+                  <a:txBody>
+                    <a:bodyPr/>
+                    <a:lstStyle/>
+                    <a:p>
+                      <a:r>
+                        <a:rPr sz="1100"/>
+                        <a:t>0</a:t>
+                      </a:r>
+                    </a:p>
+                  </a:txBody>
+                  <a:tcPr marT="0" marB="0"/>
+                </a:tc>
+                <a:tc>
+                  <a:txBody>
+                    <a:bodyPr/>
+                    <a:lstStyle/>
+                    <a:p>
+                      <a:r>
+                        <a:rPr sz="1100"/>
+                        <a:t>0</a:t>
+                      </a:r>
+                    </a:p>
+                  </a:txBody>
+                  <a:tcPr marT="0" marB="0"/>
+                </a:tc>
+                <a:extLst>
+                  <a:ext uri="{0D108BD9-81ED-4DB2-BD59-A6C34878D82A}">
+                    <a16:rowId xmlns:a16="http://schemas.microsoft.com/office/drawing/2014/main" val="10001"/>
+                  </a:ext>
+                </a:extLst>
+              </a:tr>
+              <a:tr h="231382">
+                <a:tc>
+                  <a:txBody>
+                    <a:bodyPr/>
+                    <a:lstStyle/>
+                    <a:p>
+                      <a:r>
+                        <a:rPr sz="1100"/>
+                        <a:t>B106-G1</a:t>
+                      </a:r>
+                    </a:p>
+                  </a:txBody>
+                  <a:tcPr marT="0" marB="0"/>
+                </a:tc>
+                <a:tc>
+                  <a:txBody>
+                    <a:bodyPr/>
+                    <a:lstStyle/>
+                    <a:p>
+                      <a:r>
+                        <a:rPr sz="1100"/>
+                        <a:t>IEEE 14</a:t>
+                      </a:r>
+                    </a:p>
+                  </a:txBody>
+                  <a:tcPr marT="0" marB="0"/>
+                </a:tc>
+                <a:tc>
+                  <a:txBody>
+                    <a:bodyPr/>
+                    <a:lstStyle/>
+                    <a:p>
+                      <a:r>
+                        <a:rPr sz="1100"/>
+                        <a:t>CONDENSER</a:t>
+                      </a:r>
+                    </a:p>
+                  </a:txBody>
+                  <a:tcPr marT="0" marB="0"/>
+                </a:tc>
+                <a:tc>
+                  <a:txBody>
+                    <a:bodyPr/>
+                    <a:lstStyle/>
+                    <a:p>
+                      <a:r>
+                        <a:rPr sz="1100"/>
+                        <a:t>0</a:t>
+                      </a:r>
+                    </a:p>
+                  </a:txBody>
+                  <a:tcPr marT="0" marB="0"/>
+                </a:tc>
+                <a:tc>
+                  <a:txBody>
+                    <a:bodyPr/>
+                    <a:lstStyle/>
+                    <a:p>
+                      <a:r>
+                        <a:rPr sz="1100"/>
+                        <a:t>0</a:t>
+                      </a:r>
+                    </a:p>
+                  </a:txBody>
+                  <a:tcPr marT="0" marB="0"/>
+                </a:tc>
+                <a:extLst>
+                  <a:ext uri="{0D108BD9-81ED-4DB2-BD59-A6C34878D82A}">
+                    <a16:rowId xmlns:a16="http://schemas.microsoft.com/office/drawing/2014/main" val="10002"/>
+                  </a:ext>
+                </a:extLst>
+              </a:tr>
+              <a:tr h="231382">
+                <a:tc>
+                  <a:txBody>
+                    <a:bodyPr/>
+                    <a:lstStyle/>
+                    <a:p>
+                      <a:r>
+                        <a:rPr sz="1100"/>
+                        <a:t>B108-G1</a:t>
+                      </a:r>
+                    </a:p>
+                  </a:txBody>
+                  <a:tcPr marT="0" marB="0"/>
+                </a:tc>
+                <a:tc>
+                  <a:txBody>
+                    <a:bodyPr/>
+                    <a:lstStyle/>
+                    <a:p>
+                      <a:r>
+                        <a:rPr sz="1100"/>
+                        <a:t>IEEE 14</a:t>
+                      </a:r>
+                    </a:p>
+                  </a:txBody>
+                  <a:tcPr marT="0" marB="0"/>
+                </a:tc>
+                <a:tc>
+                  <a:txBody>
+                    <a:bodyPr/>
+                    <a:lstStyle/>
+                    <a:p>
+                      <a:r>
+                        <a:rPr sz="1100"/>
+                        <a:t>CONDENSER</a:t>
+                      </a:r>
+                    </a:p>
+                  </a:txBody>
+                  <a:tcPr marT="0" marB="0"/>
+                </a:tc>
+                <a:tc>
+                  <a:txBody>
+                    <a:bodyPr/>
+                    <a:lstStyle/>
+                    <a:p>
+                      <a:r>
+                        <a:rPr sz="1100"/>
+                        <a:t>0</a:t>
+                      </a:r>
+                    </a:p>
+                  </a:txBody>
+                  <a:tcPr marT="0" marB="0"/>
+                </a:tc>
+                <a:tc>
+                  <a:txBody>
+                    <a:bodyPr/>
+                    <a:lstStyle/>
+                    <a:p>
+                      <a:r>
+                        <a:rPr sz="1100"/>
+                        <a:t>0</a:t>
+                      </a:r>
+                    </a:p>
+                  </a:txBody>
+                  <a:tcPr marT="0" marB="0"/>
+                </a:tc>
+                <a:extLst>
+                  <a:ext uri="{0D108BD9-81ED-4DB2-BD59-A6C34878D82A}">
+                    <a16:rowId xmlns:a16="http://schemas.microsoft.com/office/drawing/2014/main" val="10001"/>
+                  </a:ext>
+                </a:extLst>
+              </a:tr>
+              <a:tr h="231382">
+                <a:tc>
+                  <a:txBody>
+                    <a:bodyPr/>
+                    <a:lstStyle/>
+                    <a:p>
+                      <a:r>
+                        <a:rPr sz="1100"/>
+                        <a:t>B30-G1</a:t>
+                      </a:r>
+                    </a:p>
+                  </a:txBody>
+                  <a:tcPr marT="0" marB="0"/>
+                </a:tc>
+                <a:tc>
+                  <a:txBody>
+                    <a:bodyPr/>
+                    <a:lstStyle/>
+                    <a:p>
+                      <a:r>
+                        <a:rPr sz="1100"/>
+                        <a:t>IEEE 39</a:t>
+                      </a:r>
+                    </a:p>
+                  </a:txBody>
+                  <a:tcPr marT="0" marB="0"/>
+                </a:tc>
+                <a:tc>
+                  <a:txBody>
+                    <a:bodyPr/>
+                    <a:lstStyle/>
+                    <a:p>
+                      <a:r>
+                        <a:rPr sz="1100" b="1">
+                          <a:solidFill>
+                            <a:srgbClr val="2E86AB"/>
+                          </a:solidFill>
+                        </a:rPr>
+                        <a:t>HYDRO</a:t>
+                      </a:r>
+                    </a:p>
+                  </a:txBody>
+                  <a:tcPr marT="0" marB="0"/>
+                </a:tc>
+                <a:tc>
+                  <a:txBody>
+                    <a:bodyPr/>
+                    <a:lstStyle/>
+                    <a:p>
+                      <a:r>
+                        <a:rPr sz="1100"/>
+                        <a:t>560.5</a:t>
+                      </a:r>
+                    </a:p>
+                  </a:txBody>
+                  <a:tcPr marT="0" marB="0"/>
+                </a:tc>
+                <a:tc>
+                  <a:txBody>
+                    <a:bodyPr/>
+                    <a:lstStyle/>
+                    <a:p>
+                      <a:r>
+                        <a:rPr sz="1100"/>
+                        <a:t>5</a:t>
+                      </a:r>
+                    </a:p>
+                  </a:txBody>
+                  <a:tcPr marT="0" marB="0"/>
+                </a:tc>
+                <a:extLst>
+                  <a:ext uri="{0D108BD9-81ED-4DB2-BD59-A6C34878D82A}">
+                    <a16:rowId xmlns:a16="http://schemas.microsoft.com/office/drawing/2014/main" val="10004"/>
+                  </a:ext>
+                </a:extLst>
+              </a:tr>
+              <a:tr h="231382">
+                <a:tc>
+                  <a:txBody>
+                    <a:bodyPr/>
+                    <a:lstStyle/>
+                    <a:p>
+                      <a:r>
+                        <a:rPr sz="1100"/>
+                        <a:t>B31-G1</a:t>
+                      </a:r>
+                    </a:p>
+                  </a:txBody>
+                  <a:tcPr marT="0" marB="0"/>
+                </a:tc>
+                <a:tc>
+                  <a:txBody>
+                    <a:bodyPr/>
+                    <a:lstStyle/>
+                    <a:p>
+                      <a:r>
+                        <a:rPr sz="1100"/>
+                        <a:t>IEEE 39</a:t>
+                      </a:r>
+                    </a:p>
+                  </a:txBody>
+                  <a:tcPr marT="0" marB="0"/>
+                </a:tc>
+                <a:tc>
+                  <a:txBody>
+                    <a:bodyPr/>
+                    <a:lstStyle/>
+                    <a:p>
+                      <a:r>
+                        <a:rPr sz="1100"/>
+                        <a:t>NUCLEAR</a:t>
+                      </a:r>
+                    </a:p>
+                  </a:txBody>
+                  <a:tcPr marT="0" marB="0"/>
+                </a:tc>
+                <a:tc>
+                  <a:txBody>
+                    <a:bodyPr/>
+                    <a:lstStyle/>
+                    <a:p>
+                      <a:r>
+                        <a:rPr sz="1100"/>
+                        <a:t>751.5</a:t>
+                      </a:r>
+                    </a:p>
+                  </a:txBody>
+                  <a:tcPr marT="0" marB="0"/>
+                </a:tc>
+                <a:tc>
+                  <a:txBody>
+                    <a:bodyPr/>
+                    <a:lstStyle/>
+                    <a:p>
+                      <a:r>
+                        <a:rPr sz="1100"/>
+                        <a:t>8</a:t>
+                      </a:r>
+                    </a:p>
+                  </a:txBody>
+                  <a:tcPr marT="0" marB="0"/>
+                </a:tc>
+                <a:extLst>
+                  <a:ext uri="{0D108BD9-81ED-4DB2-BD59-A6C34878D82A}">
+                    <a16:rowId xmlns:a16="http://schemas.microsoft.com/office/drawing/2014/main" val="10001"/>
+                  </a:ext>
+                </a:extLst>
+              </a:tr>
+              <a:tr h="231382">
+                <a:tc>
+                  <a:txBody>
+                    <a:bodyPr/>
+                    <a:lstStyle/>
+                    <a:p>
+                      <a:r>
+                        <a:rPr sz="1100"/>
+                        <a:t>B32-G1</a:t>
+                      </a:r>
+                    </a:p>
+                  </a:txBody>
+                  <a:tcPr marT="0" marB="0"/>
+                </a:tc>
+                <a:tc>
+                  <a:txBody>
+                    <a:bodyPr/>
+                    <a:lstStyle/>
+                    <a:p>
+                      <a:r>
+                        <a:rPr sz="1100"/>
+                        <a:t>IEEE 39</a:t>
+                      </a:r>
+                    </a:p>
+                  </a:txBody>
+                  <a:tcPr marT="0" marB="0"/>
+                </a:tc>
+                <a:tc>
+                  <a:txBody>
+                    <a:bodyPr/>
+                    <a:lstStyle/>
+                    <a:p>
+                      <a:r>
+                        <a:rPr sz="1100"/>
+                        <a:t>NUCLEAR</a:t>
+                      </a:r>
+                    </a:p>
+                  </a:txBody>
+                  <a:tcPr marT="0" marB="0"/>
+                </a:tc>
+                <a:tc>
+                  <a:txBody>
+                    <a:bodyPr/>
+                    <a:lstStyle/>
+                    <a:p>
+                      <a:r>
+                        <a:rPr sz="1100"/>
+                        <a:t>751.5</a:t>
+                      </a:r>
+                    </a:p>
+                  </a:txBody>
+                  <a:tcPr marT="0" marB="0"/>
+                </a:tc>
+                <a:tc>
+                  <a:txBody>
+                    <a:bodyPr/>
+                    <a:lstStyle/>
+                    <a:p>
+                      <a:r>
+                        <a:rPr sz="1100"/>
+                        <a:t>8</a:t>
+                      </a:r>
+                    </a:p>
+                  </a:txBody>
+                  <a:tcPr marT="0" marB="0"/>
+                </a:tc>
+                <a:extLst>
+                  <a:ext uri="{0D108BD9-81ED-4DB2-BD59-A6C34878D82A}">
+                    <a16:rowId xmlns:a16="http://schemas.microsoft.com/office/drawing/2014/main" val="10002"/>
+                  </a:ext>
+                </a:extLst>
+              </a:tr>
+              <a:tr h="231382">
+                <a:tc>
+                  <a:txBody>
+                    <a:bodyPr/>
+                    <a:lstStyle/>
+                    <a:p>
+                      <a:r>
+                        <a:rPr sz="1100"/>
+                        <a:t>B33-G1</a:t>
+                      </a:r>
+                    </a:p>
+                  </a:txBody>
+                  <a:tcPr marT="0" marB="0"/>
+                </a:tc>
+                <a:tc>
+                  <a:txBody>
+                    <a:bodyPr/>
+                    <a:lstStyle/>
+                    <a:p>
+                      <a:r>
+                        <a:rPr sz="1100"/>
+                        <a:t>IEEE 39</a:t>
+                      </a:r>
+                    </a:p>
+                  </a:txBody>
+                  <a:tcPr marT="0" marB="0"/>
+                </a:tc>
+                <a:tc>
+                  <a:txBody>
+                    <a:bodyPr/>
+                    <a:lstStyle/>
+                    <a:p>
+                      <a:r>
+                        <a:rPr sz="1100"/>
+                        <a:t>COAL</a:t>
+                      </a:r>
+                    </a:p>
+                  </a:txBody>
+                  <a:tcPr marT="0" marB="0"/>
+                </a:tc>
+                <a:tc>
+                  <a:txBody>
+                    <a:bodyPr/>
+                    <a:lstStyle/>
+                    <a:p>
+                      <a:r>
+                        <a:rPr sz="1100"/>
+                        <a:t>751.5</a:t>
+                      </a:r>
+                    </a:p>
+                  </a:txBody>
+                  <a:tcPr marT="0" marB="0"/>
+                </a:tc>
+                <a:tc>
+                  <a:txBody>
+                    <a:bodyPr/>
+                    <a:lstStyle/>
+                    <a:p>
+                      <a:r>
+                        <a:rPr sz="1100"/>
+                        <a:t>45</a:t>
+                      </a:r>
+                    </a:p>
+                  </a:txBody>
+                  <a:tcPr marT="0" marB="0"/>
+                </a:tc>
+                <a:extLst>
+                  <a:ext uri="{0D108BD9-81ED-4DB2-BD59-A6C34878D82A}">
+                    <a16:rowId xmlns:a16="http://schemas.microsoft.com/office/drawing/2014/main" val="10001"/>
+                  </a:ext>
+                </a:extLst>
+              </a:tr>
+              <a:tr h="231382">
+                <a:tc>
+                  <a:txBody>
+                    <a:bodyPr/>
+                    <a:lstStyle/>
+                    <a:p>
+                      <a:r>
+                        <a:rPr sz="1100"/>
+                        <a:t>B34-G1</a:t>
+                      </a:r>
+                    </a:p>
+                  </a:txBody>
+                  <a:tcPr marT="0" marB="0"/>
+                </a:tc>
+                <a:tc>
+                  <a:txBody>
+                    <a:bodyPr/>
+                    <a:lstStyle/>
+                    <a:p>
+                      <a:r>
+                        <a:rPr sz="1100"/>
+                        <a:t>IEEE 39</a:t>
+                      </a:r>
+                    </a:p>
+                  </a:txBody>
+                  <a:tcPr marT="0" marB="0"/>
+                </a:tc>
+                <a:tc>
+                  <a:txBody>
+                    <a:bodyPr/>
+                    <a:lstStyle/>
+                    <a:p>
+                      <a:r>
+                        <a:rPr sz="1100"/>
+                        <a:t>COAL</a:t>
+                      </a:r>
+                    </a:p>
+                  </a:txBody>
+                  <a:tcPr marT="0" marB="0"/>
+                </a:tc>
+                <a:tc>
+                  <a:txBody>
+                    <a:bodyPr/>
+                    <a:lstStyle/>
+                    <a:p>
+                      <a:r>
+                        <a:rPr sz="1100"/>
+                        <a:t>751.5</a:t>
+                      </a:r>
+                    </a:p>
+                  </a:txBody>
+                  <a:tcPr marT="0" marB="0"/>
+                </a:tc>
+                <a:tc>
+                  <a:txBody>
+                    <a:bodyPr/>
+                    <a:lstStyle/>
+                    <a:p>
+                      <a:r>
+                        <a:rPr sz="1100"/>
+                        <a:t>45</a:t>
+                      </a:r>
+                    </a:p>
+                  </a:txBody>
+                  <a:tcPr marT="0" marB="0"/>
+                </a:tc>
+                <a:extLst>
+                  <a:ext uri="{0D108BD9-81ED-4DB2-BD59-A6C34878D82A}">
+                    <a16:rowId xmlns:a16="http://schemas.microsoft.com/office/drawing/2014/main" val="10002"/>
+                  </a:ext>
+                </a:extLst>
+              </a:tr>
+              <a:tr h="231382">
+                <a:tc>
+                  <a:txBody>
+                    <a:bodyPr/>
+                    <a:lstStyle/>
+                    <a:p>
+                      <a:r>
+                        <a:rPr sz="1100"/>
+                        <a:t>B35-G1</a:t>
+                      </a:r>
+                    </a:p>
+                  </a:txBody>
+                  <a:tcPr marT="0" marB="0"/>
+                </a:tc>
+                <a:tc>
+                  <a:txBody>
+                    <a:bodyPr/>
+                    <a:lstStyle/>
+                    <a:p>
+                      <a:r>
+                        <a:rPr sz="1100"/>
+                        <a:t>IEEE 39</a:t>
+                      </a:r>
+                    </a:p>
+                  </a:txBody>
+                  <a:tcPr marT="0" marB="0"/>
+                </a:tc>
+                <a:tc>
+                  <a:txBody>
+                    <a:bodyPr/>
+                    <a:lstStyle/>
+                    <a:p>
+                      <a:r>
+                        <a:rPr sz="1100"/>
+                        <a:t>NUCLEAR</a:t>
+                      </a:r>
+                    </a:p>
+                  </a:txBody>
+                  <a:tcPr marT="0" marB="0"/>
+                </a:tc>
+                <a:tc>
+                  <a:txBody>
+                    <a:bodyPr/>
+                    <a:lstStyle/>
+                    <a:p>
+                      <a:r>
+                        <a:rPr sz="1100"/>
+                        <a:t>751.5</a:t>
+                      </a:r>
+                    </a:p>
+                  </a:txBody>
+                  <a:tcPr marT="0" marB="0"/>
+                </a:tc>
+                <a:tc>
+                  <a:txBody>
+                    <a:bodyPr/>
+                    <a:lstStyle/>
+                    <a:p>
+                      <a:r>
+                        <a:rPr sz="1100"/>
+                        <a:t>8</a:t>
+                      </a:r>
+                    </a:p>
+                  </a:txBody>
+                  <a:tcPr marT="0" marB="0"/>
+                </a:tc>
+                <a:extLst>
+                  <a:ext uri="{0D108BD9-81ED-4DB2-BD59-A6C34878D82A}">
+                    <a16:rowId xmlns:a16="http://schemas.microsoft.com/office/drawing/2014/main" val="10001"/>
+                  </a:ext>
+                </a:extLst>
+              </a:tr>
+              <a:tr h="231382">
+                <a:tc>
+                  <a:txBody>
+                    <a:bodyPr/>
+                    <a:lstStyle/>
+                    <a:p>
+                      <a:r>
+                        <a:rPr sz="1100"/>
+                        <a:t>B36-G1</a:t>
+                      </a:r>
+                    </a:p>
+                  </a:txBody>
+                  <a:tcPr marT="0" marB="0"/>
+                </a:tc>
+                <a:tc>
+                  <a:txBody>
+                    <a:bodyPr/>
+                    <a:lstStyle/>
+                    <a:p>
+                      <a:r>
+                        <a:rPr sz="1100"/>
+                        <a:t>IEEE 39</a:t>
+                      </a:r>
+                    </a:p>
+                  </a:txBody>
+                  <a:tcPr marT="0" marB="0"/>
+                </a:tc>
+                <a:tc>
+                  <a:txBody>
+                    <a:bodyPr/>
+                    <a:lstStyle/>
+                    <a:p>
+                      <a:r>
+                        <a:rPr sz="1100"/>
+                        <a:t>COAL</a:t>
+                      </a:r>
+                    </a:p>
+                  </a:txBody>
+                  <a:tcPr marT="0" marB="0"/>
+                </a:tc>
+                <a:tc>
+                  <a:txBody>
+                    <a:bodyPr/>
+                    <a:lstStyle/>
+                    <a:p>
+                      <a:r>
+                        <a:rPr sz="1100"/>
+                        <a:t>751.5</a:t>
+                      </a:r>
+                    </a:p>
+                  </a:txBody>
+                  <a:tcPr marT="0" marB="0"/>
+                </a:tc>
+                <a:tc>
+                  <a:txBody>
+                    <a:bodyPr/>
+                    <a:lstStyle/>
+                    <a:p>
+                      <a:r>
+                        <a:rPr sz="1100"/>
+                        <a:t>45</a:t>
+                      </a:r>
+                    </a:p>
+                  </a:txBody>
+                  <a:tcPr marT="0" marB="0"/>
+                </a:tc>
+                <a:extLst>
+                  <a:ext uri="{0D108BD9-81ED-4DB2-BD59-A6C34878D82A}">
+                    <a16:rowId xmlns:a16="http://schemas.microsoft.com/office/drawing/2014/main" val="10002"/>
+                  </a:ext>
+                </a:extLst>
+              </a:tr>
+              <a:tr h="231382">
+                <a:tc>
+                  <a:txBody>
+                    <a:bodyPr/>
+                    <a:lstStyle/>
+                    <a:p>
+                      <a:r>
+                        <a:rPr sz="1100"/>
+                        <a:t>B37-G1</a:t>
+                      </a:r>
+                    </a:p>
+                  </a:txBody>
+                  <a:tcPr marT="0" marB="0"/>
+                </a:tc>
+                <a:tc>
+                  <a:txBody>
+                    <a:bodyPr/>
+                    <a:lstStyle/>
+                    <a:p>
+                      <a:r>
+                        <a:rPr sz="1100"/>
+                        <a:t>IEEE 39</a:t>
+                      </a:r>
+                    </a:p>
+                  </a:txBody>
+                  <a:tcPr marT="0" marB="0"/>
+                </a:tc>
+                <a:tc>
+                  <a:txBody>
+                    <a:bodyPr/>
+                    <a:lstStyle/>
+                    <a:p>
+                      <a:r>
+                        <a:rPr sz="1100"/>
+                        <a:t>NUCLEAR</a:t>
+                      </a:r>
+                    </a:p>
+                  </a:txBody>
+                  <a:tcPr marT="0" marB="0"/>
+                </a:tc>
+                <a:tc>
+                  <a:txBody>
+                    <a:bodyPr/>
+                    <a:lstStyle/>
+                    <a:p>
+                      <a:r>
+                        <a:rPr sz="1100"/>
+                        <a:t>751.5</a:t>
+                      </a:r>
+                    </a:p>
+                  </a:txBody>
+                  <a:tcPr marT="0" marB="0"/>
+                </a:tc>
+                <a:tc>
+                  <a:txBody>
+                    <a:bodyPr/>
+                    <a:lstStyle/>
+                    <a:p>
+                      <a:r>
+                        <a:rPr sz="1100"/>
+                        <a:t>8</a:t>
+                      </a:r>
+                    </a:p>
+                  </a:txBody>
+                  <a:tcPr marT="0" marB="0"/>
+                </a:tc>
+                <a:extLst>
+                  <a:ext uri="{0D108BD9-81ED-4DB2-BD59-A6C34878D82A}">
+                    <a16:rowId xmlns:a16="http://schemas.microsoft.com/office/drawing/2014/main" val="10001"/>
+                  </a:ext>
+                </a:extLst>
+              </a:tr>
+              <a:tr h="231382">
+                <a:tc>
+                  <a:txBody>
+                    <a:bodyPr/>
+                    <a:lstStyle/>
+                    <a:p>
+                      <a:r>
+                        <a:rPr sz="1100"/>
+                        <a:t>B38-G1</a:t>
+                      </a:r>
+                    </a:p>
+                  </a:txBody>
+                  <a:tcPr marT="0" marB="0"/>
+                </a:tc>
+                <a:tc>
+                  <a:txBody>
+                    <a:bodyPr/>
+                    <a:lstStyle/>
+                    <a:p>
+                      <a:r>
+                        <a:rPr sz="1100"/>
+                        <a:t>IEEE 39</a:t>
+                      </a:r>
+                    </a:p>
+                  </a:txBody>
+                  <a:tcPr marT="0" marB="0"/>
+                </a:tc>
+                <a:tc>
+                  <a:txBody>
+                    <a:bodyPr/>
+                    <a:lstStyle/>
+                    <a:p>
+                      <a:r>
+                        <a:rPr sz="1100"/>
+                        <a:t>NUCLEAR</a:t>
+                      </a:r>
+                    </a:p>
+                  </a:txBody>
+                  <a:tcPr marT="0" marB="0"/>
+                </a:tc>
+                <a:tc>
+                  <a:txBody>
+                    <a:bodyPr/>
+                    <a:lstStyle/>
+                    <a:p>
+                      <a:r>
+                        <a:rPr sz="1100"/>
+                        <a:t>865.45</a:t>
+                      </a:r>
+                    </a:p>
+                  </a:txBody>
+                  <a:tcPr marT="0" marB="0"/>
+                </a:tc>
+                <a:tc>
+                  <a:txBody>
+                    <a:bodyPr/>
+                    <a:lstStyle/>
+                    <a:p>
+                      <a:r>
+                        <a:rPr sz="1100"/>
+                        <a:t>8</a:t>
+                      </a:r>
+                    </a:p>
+                  </a:txBody>
+                  <a:tcPr marT="0" marB="0"/>
+                </a:tc>
+                <a:extLst>
+                  <a:ext uri="{0D108BD9-81ED-4DB2-BD59-A6C34878D82A}">
+                    <a16:rowId xmlns:a16="http://schemas.microsoft.com/office/drawing/2014/main" val="10002"/>
+                  </a:ext>
+                </a:extLst>
+              </a:tr>
+              <a:tr h="231382">
+                <a:tc>
+                  <a:txBody>
+                    <a:bodyPr/>
+                    <a:lstStyle/>
+                    <a:p>
+                      <a:r>
+                        <a:rPr sz="1100"/>
+                        <a:t>B39-G1</a:t>
+                      </a:r>
+                    </a:p>
+                  </a:txBody>
+                  <a:tcPr marT="0" marB="0"/>
+                </a:tc>
+                <a:tc>
+                  <a:txBody>
+                    <a:bodyPr/>
+                    <a:lstStyle/>
+                    <a:p>
+                      <a:r>
+                        <a:rPr sz="1100"/>
+                        <a:t>IEEE 39</a:t>
+                      </a:r>
+                    </a:p>
+                  </a:txBody>
+                  <a:tcPr marT="0" marB="0"/>
+                </a:tc>
+                <a:tc>
+                  <a:txBody>
+                    <a:bodyPr/>
+                    <a:lstStyle/>
+                    <a:p>
+                      <a:r>
+                        <a:rPr sz="1100"/>
+                        <a:t>NUCLEAR</a:t>
+                      </a:r>
+                    </a:p>
+                  </a:txBody>
+                  <a:tcPr marT="0" marB="0"/>
+                </a:tc>
+                <a:tc>
+                  <a:txBody>
+                    <a:bodyPr/>
+                    <a:lstStyle/>
+                    <a:p>
+                      <a:r>
+                        <a:rPr sz="1100"/>
+                        <a:t>819.9</a:t>
+                      </a:r>
+                    </a:p>
+                  </a:txBody>
+                  <a:tcPr marT="0" marB="0"/>
+                </a:tc>
+                <a:tc>
+                  <a:txBody>
+                    <a:bodyPr/>
+                    <a:lstStyle/>
+                    <a:p>
+                      <a:r>
+                        <a:rPr sz="1100"/>
+                        <a:t>8</a:t>
+                      </a:r>
+                    </a:p>
+                  </a:txBody>
+                  <a:tcPr marT="0" marB="0"/>
+                </a:tc>
+                <a:extLst>
+                  <a:ext uri="{0D108BD9-81ED-4DB2-BD59-A6C34878D82A}">
+                    <a16:rowId xmlns:a16="http://schemas.microsoft.com/office/drawing/2014/main" val="10001"/>
+                  </a:ext>
+                </a:extLst>
+              </a:tr>
+              <a:tr h="231382">
+                <a:tc>
+                  <a:txBody>
+                    <a:bodyPr/>
+                    <a:lstStyle/>
+                    <a:p>
+                      <a:r>
+                        <a:rPr sz="1100"/>
+                        <a:t>PV-B106-1</a:t>
+                      </a:r>
+                    </a:p>
+                  </a:txBody>
+                  <a:tcPr marT="0" marB="0"/>
+                </a:tc>
+                <a:tc>
+                  <a:txBody>
+                    <a:bodyPr/>
+                    <a:lstStyle/>
+                    <a:p>
+                      <a:r>
+                        <a:rPr sz="1100"/>
+                        <a:t>IEEE 14</a:t>
+                      </a:r>
+                    </a:p>
+                  </a:txBody>
+                  <a:tcPr marT="0" marB="0"/>
+                </a:tc>
+                <a:tc>
+                  <a:txBody>
+                    <a:bodyPr/>
+                    <a:lstStyle/>
+                    <a:p>
+                      <a:r>
+                        <a:rPr sz="1100" b="1">
+                          <a:solidFill>
+                            <a:srgbClr val="2E86AB"/>
+                          </a:solidFill>
+                        </a:rPr>
+                        <a:t>SOLAR</a:t>
+                      </a:r>
+                    </a:p>
+                  </a:txBody>
+                  <a:tcPr marT="0" marB="0"/>
+                </a:tc>
+                <a:tc>
+                  <a:txBody>
+                    <a:bodyPr/>
+                    <a:lstStyle/>
+                    <a:p>
+                      <a:r>
+                        <a:rPr sz="1100"/>
+                        <a:t>30</a:t>
+                      </a:r>
+                    </a:p>
+                  </a:txBody>
+                  <a:tcPr marT="0" marB="0"/>
+                </a:tc>
+                <a:tc>
+                  <a:txBody>
+                    <a:bodyPr/>
+                    <a:lstStyle/>
+                    <a:p>
+                      <a:r>
+                        <a:rPr sz="1100"/>
+                        <a:t>0</a:t>
+                      </a:r>
+                    </a:p>
+                  </a:txBody>
+                  <a:tcPr marT="0" marB="0"/>
+                </a:tc>
+                <a:extLst>
+                  <a:ext uri="{0D108BD9-81ED-4DB2-BD59-A6C34878D82A}">
+                    <a16:rowId xmlns:a16="http://schemas.microsoft.com/office/drawing/2014/main" val="10004"/>
+                  </a:ext>
+                </a:extLst>
+              </a:tr>
+              <a:tr h="231382">
+                <a:tc>
+                  <a:txBody>
+                    <a:bodyPr/>
+                    <a:lstStyle/>
+                    <a:p>
+                      <a:r>
+                        <a:rPr sz="1100"/>
+                        <a:t>PV-B21-1</a:t>
+                      </a:r>
+                    </a:p>
+                  </a:txBody>
+                  <a:tcPr marT="0" marB="0"/>
+                </a:tc>
+                <a:tc>
+                  <a:txBody>
+                    <a:bodyPr/>
+                    <a:lstStyle/>
+                    <a:p>
+                      <a:r>
+                        <a:rPr sz="1100"/>
+                        <a:t>IEEE 39</a:t>
+                      </a:r>
+                    </a:p>
+                  </a:txBody>
+                  <a:tcPr marT="0" marB="0"/>
+                </a:tc>
+                <a:tc>
+                  <a:txBody>
+                    <a:bodyPr/>
+                    <a:lstStyle/>
+                    <a:p>
+                      <a:r>
+                        <a:rPr sz="1100" b="1">
+                          <a:solidFill>
+                            <a:srgbClr val="2E86AB"/>
+                          </a:solidFill>
+                        </a:rPr>
+                        <a:t>SOLAR</a:t>
+                      </a:r>
+                    </a:p>
+                  </a:txBody>
+                  <a:tcPr marT="0" marB="0"/>
+                </a:tc>
+                <a:tc>
+                  <a:txBody>
+                    <a:bodyPr/>
+                    <a:lstStyle/>
+                    <a:p>
+                      <a:r>
+                        <a:rPr sz="1100"/>
+                        <a:t>200</a:t>
+                      </a:r>
+                    </a:p>
+                  </a:txBody>
+                  <a:tcPr marT="0" marB="0"/>
+                </a:tc>
+                <a:tc>
+                  <a:txBody>
+                    <a:bodyPr/>
+                    <a:lstStyle/>
+                    <a:p>
+                      <a:r>
+                        <a:rPr sz="1100"/>
+                        <a:t>0</a:t>
+                      </a:r>
+                    </a:p>
+                  </a:txBody>
+                  <a:tcPr marT="0" marB="0"/>
+                </a:tc>
+                <a:extLst>
+                  <a:ext uri="{0D108BD9-81ED-4DB2-BD59-A6C34878D82A}">
+                    <a16:rowId xmlns:a16="http://schemas.microsoft.com/office/drawing/2014/main" val="10003"/>
+                  </a:ext>
+                </a:extLst>
+              </a:tr>
+              <a:tr h="231382">
+                <a:tc>
+                  <a:txBody>
+                    <a:bodyPr/>
+                    <a:lstStyle/>
+                    <a:p>
+                      <a:r>
+                        <a:rPr sz="1100"/>
+                        <a:t>PV-B6-1</a:t>
+                      </a:r>
+                    </a:p>
+                  </a:txBody>
+                  <a:tcPr marT="0" marB="0"/>
+                </a:tc>
+                <a:tc>
+                  <a:txBody>
+                    <a:bodyPr/>
+                    <a:lstStyle/>
+                    <a:p>
+                      <a:r>
+                        <a:rPr sz="1100"/>
+                        <a:t>IEEE 39</a:t>
+                      </a:r>
+                    </a:p>
+                  </a:txBody>
+                  <a:tcPr marT="0" marB="0"/>
+                </a:tc>
+                <a:tc>
+                  <a:txBody>
+                    <a:bodyPr/>
+                    <a:lstStyle/>
+                    <a:p>
+                      <a:r>
+                        <a:rPr sz="1100" b="1">
+                          <a:solidFill>
+                            <a:srgbClr val="2E86AB"/>
+                          </a:solidFill>
+                        </a:rPr>
+                        <a:t>SOLAR</a:t>
+                      </a:r>
+                    </a:p>
+                  </a:txBody>
+                  <a:tcPr marT="0" marB="0"/>
+                </a:tc>
+                <a:tc>
+                  <a:txBody>
+                    <a:bodyPr/>
+                    <a:lstStyle/>
+                    <a:p>
+                      <a:r>
+                        <a:rPr sz="1100"/>
+                        <a:t>400</a:t>
+                      </a:r>
+                    </a:p>
+                  </a:txBody>
+                  <a:tcPr marT="0" marB="0"/>
+                </a:tc>
+                <a:tc>
+                  <a:txBody>
+                    <a:bodyPr/>
+                    <a:lstStyle/>
+                    <a:p>
+                      <a:r>
+                        <a:rPr sz="1100"/>
+                        <a:t>0</a:t>
+                      </a:r>
+                    </a:p>
+                  </a:txBody>
+                  <a:tcPr marT="0" marB="0"/>
+                </a:tc>
+                <a:extLst>
+                  <a:ext uri="{0D108BD9-81ED-4DB2-BD59-A6C34878D82A}">
+                    <a16:rowId xmlns:a16="http://schemas.microsoft.com/office/drawing/2014/main" val="10004"/>
+                  </a:ext>
+                </a:extLst>
+              </a:tr>
+              <a:tr h="231382">
+                <a:tc>
+                  <a:txBody>
+                    <a:bodyPr/>
+                    <a:lstStyle/>
+                    <a:p>
+                      <a:r>
+                        <a:rPr sz="1100"/>
+                        <a:t>WF-B101-1</a:t>
+                      </a:r>
+                    </a:p>
+                  </a:txBody>
+                  <a:tcPr marT="0" marB="0"/>
+                </a:tc>
+                <a:tc>
+                  <a:txBody>
+                    <a:bodyPr/>
+                    <a:lstStyle/>
+                    <a:p>
+                      <a:r>
+                        <a:rPr sz="1100"/>
+                        <a:t>IEEE 14</a:t>
+                      </a:r>
+                    </a:p>
+                  </a:txBody>
+                  <a:tcPr marT="0" marB="0"/>
                 </a:tc>
                 <a:tc>
                   <a:txBody>
@@ -5298,7 +6466,7 @@
                       </a:r>
                     </a:p>
                   </a:txBody>
-                  <a:tcPr/>
+                  <a:tcPr marT="0" marB="0"/>
                 </a:tc>
                 <a:tc>
                   <a:txBody>
@@ -5311,7 +6479,7 @@
                       </a:r>
                     </a:p>
                   </a:txBody>
-                  <a:tcPr/>
+                  <a:tcPr marT="0" marB="0"/>
                 </a:tc>
                 <a:tc>
                   <a:txBody>
@@ -5324,7 +6492,7 @@
                       </a:r>
                     </a:p>
                   </a:txBody>
-                  <a:tcPr/>
+                  <a:tcPr marT="0" marB="0"/>
                 </a:tc>
                 <a:extLst>
                   <a:ext uri="{0D108BD9-81ED-4DB2-BD59-A6C34878D82A}">
@@ -5332,32 +6500,32 @@
                   </a:ext>
                 </a:extLst>
               </a:tr>
-              <a:tr h="320040">
-                <a:tc>
-                  <a:txBody>
-                    <a:bodyPr/>
-                    <a:lstStyle/>
-                    <a:p>
-                      <a:r>
-                        <a:rPr sz="1100"/>
-                        <a:t>B106-G1</a:t>
-                      </a:r>
-                    </a:p>
-                  </a:txBody>
-                  <a:tcPr/>
-                </a:tc>
-                <a:tc>
-                  <a:txBody>
-                    <a:bodyPr/>
-                    <a:lstStyle/>
-                    <a:p>
-                      <a:r>
-                        <a:rPr sz="1100"/>
-                        <a:t>IEEE 14</a:t>
-                      </a:r>
-                    </a:p>
-                  </a:txBody>
-                  <a:tcPr/>
+              <a:tr h="231382">
+                <a:tc>
+                  <a:txBody>
+                    <a:bodyPr/>
+                    <a:lstStyle/>
+                    <a:p>
+                      <a:r>
+                        <a:rPr sz="1100"/>
+                        <a:t>WF-B14-1</a:t>
+                      </a:r>
+                    </a:p>
+                  </a:txBody>
+                  <a:tcPr marT="0" marB="0"/>
+                </a:tc>
+                <a:tc>
+                  <a:txBody>
+                    <a:bodyPr/>
+                    <a:lstStyle/>
+                    <a:p>
+                      <a:r>
+                        <a:rPr sz="1100"/>
+                        <a:t>IEEE 39</a:t>
+                      </a:r>
+                    </a:p>
+                  </a:txBody>
+                  <a:tcPr marT="0" marB="0"/>
                 </a:tc>
                 <a:tc>
                   <a:txBody>
@@ -5370,37 +6538,37 @@
                             <a:srgbClr val="2E86AB"/>
                           </a:solidFill>
                         </a:rPr>
-                        <a:t>SOLAR</a:t>
-                      </a:r>
-                    </a:p>
-                  </a:txBody>
-                  <a:tcPr/>
-                </a:tc>
-                <a:tc>
-                  <a:txBody>
-                    <a:bodyPr/>
-                    <a:lstStyle/>
-                    <a:p>
-                      <a:r>
-                        <a:rPr sz="1100"/>
-                        <a:t>30</a:t>
-                      </a:r>
-                    </a:p>
-                  </a:txBody>
-                  <a:tcPr/>
-                </a:tc>
-                <a:tc>
-                  <a:txBody>
-                    <a:bodyPr/>
-                    <a:lstStyle/>
-                    <a:p>
-                      <a:r>
-                        <a:rPr sz="1100"/>
-                        <a:t>0</a:t>
-                      </a:r>
-                    </a:p>
-                  </a:txBody>
-                  <a:tcPr/>
+                        <a:t>WIND</a:t>
+                      </a:r>
+                    </a:p>
+                  </a:txBody>
+                  <a:tcPr marT="0" marB="0"/>
+                </a:tc>
+                <a:tc>
+                  <a:txBody>
+                    <a:bodyPr/>
+                    <a:lstStyle/>
+                    <a:p>
+                      <a:r>
+                        <a:rPr sz="1100"/>
+                        <a:t>400</a:t>
+                      </a:r>
+                    </a:p>
+                  </a:txBody>
+                  <a:tcPr marT="0" marB="0"/>
+                </a:tc>
+                <a:tc>
+                  <a:txBody>
+                    <a:bodyPr/>
+                    <a:lstStyle/>
+                    <a:p>
+                      <a:r>
+                        <a:rPr sz="1100"/>
+                        <a:t>1</a:t>
+                      </a:r>
+                    </a:p>
+                  </a:txBody>
+                  <a:tcPr marT="0" marB="0"/>
                 </a:tc>
                 <a:extLst>
                   <a:ext uri="{0D108BD9-81ED-4DB2-BD59-A6C34878D82A}">
@@ -5408,95 +6576,19 @@
                   </a:ext>
                 </a:extLst>
               </a:tr>
-              <a:tr h="320040">
-                <a:tc>
-                  <a:txBody>
-                    <a:bodyPr/>
-                    <a:lstStyle/>
-                    <a:p>
-                      <a:r>
-                        <a:rPr sz="1100"/>
-                        <a:t>B108-G1</a:t>
-                      </a:r>
-                    </a:p>
-                  </a:txBody>
-                  <a:tcPr/>
-                </a:tc>
-                <a:tc>
-                  <a:txBody>
-                    <a:bodyPr/>
-                    <a:lstStyle/>
-                    <a:p>
-                      <a:r>
-                        <a:rPr sz="1100"/>
-                        <a:t>IEEE 14</a:t>
-                      </a:r>
-                    </a:p>
-                  </a:txBody>
-                  <a:tcPr/>
-                </a:tc>
-                <a:tc>
-                  <a:txBody>
-                    <a:bodyPr/>
-                    <a:lstStyle/>
-                    <a:p>
-                      <a:r>
-                        <a:rPr sz="1100" b="1">
-                          <a:solidFill>
-                            <a:srgbClr val="2E86AB"/>
-                          </a:solidFill>
-                        </a:rPr>
-                        <a:t>HYDRO</a:t>
-                      </a:r>
-                    </a:p>
-                  </a:txBody>
-                  <a:tcPr/>
-                </a:tc>
-                <a:tc>
-                  <a:txBody>
-                    <a:bodyPr/>
-                    <a:lstStyle/>
-                    <a:p>
-                      <a:r>
-                        <a:rPr sz="1100"/>
-                        <a:t>25</a:t>
-                      </a:r>
-                    </a:p>
-                  </a:txBody>
-                  <a:tcPr/>
-                </a:tc>
-                <a:tc>
-                  <a:txBody>
-                    <a:bodyPr/>
-                    <a:lstStyle/>
-                    <a:p>
-                      <a:r>
-                        <a:rPr sz="1100"/>
-                        <a:t>5</a:t>
-                      </a:r>
-                    </a:p>
-                  </a:txBody>
-                  <a:tcPr/>
-                </a:tc>
-                <a:extLst>
-                  <a:ext uri="{0D108BD9-81ED-4DB2-BD59-A6C34878D82A}">
-                    <a16:rowId xmlns:a16="http://schemas.microsoft.com/office/drawing/2014/main" val="10005"/>
-                  </a:ext>
-                </a:extLst>
-              </a:tr>
-              <a:tr h="320040">
-                <a:tc>
-                  <a:txBody>
-                    <a:bodyPr/>
-                    <a:lstStyle/>
-                    <a:p>
-                      <a:r>
-                        <a:rPr sz="1100"/>
-                        <a:t>B30-G1</a:t>
-                      </a:r>
-                    </a:p>
-                  </a:txBody>
-                  <a:tcPr/>
+              <a:tr h="231382">
+                <a:tc>
+                  <a:txBody>
+                    <a:bodyPr/>
+                    <a:lstStyle/>
+                    <a:p>
+                      <a:r>
+                        <a:rPr sz="1100"/>
+                        <a:t>WF-B15-1</a:t>
+                      </a:r>
+                    </a:p>
+                  </a:txBody>
+                  <a:tcPr marT="0" marB="0"/>
                 </a:tc>
                 <a:tc>
                   <a:txBody>
@@ -5509,7 +6601,7 @@
                       </a:r>
                     </a:p>
                   </a:txBody>
-                  <a:tcPr/>
+                  <a:tcPr marT="0" marB="0"/>
                 </a:tc>
                 <a:tc>
                   <a:txBody>
@@ -5526,20 +6618,20 @@
                       </a:r>
                     </a:p>
                   </a:txBody>
-                  <a:tcPr/>
-                </a:tc>
-                <a:tc>
-                  <a:txBody>
-                    <a:bodyPr/>
-                    <a:lstStyle/>
-                    <a:p>
-                      <a:r>
-                        <a:rPr sz="1100"/>
-                        <a:t>250</a:t>
-                      </a:r>
-                    </a:p>
-                  </a:txBody>
-                  <a:tcPr/>
+                  <a:tcPr marT="0" marB="0"/>
+                </a:tc>
+                <a:tc>
+                  <a:txBody>
+                    <a:bodyPr/>
+                    <a:lstStyle/>
+                    <a:p>
+                      <a:r>
+                        <a:rPr sz="1100"/>
+                        <a:t>300</a:t>
+                      </a:r>
+                    </a:p>
+                  </a:txBody>
+                  <a:tcPr marT="0" marB="0"/>
                 </a:tc>
                 <a:tc>
                   <a:txBody>
@@ -5552,27 +6644,27 @@
                       </a:r>
                     </a:p>
                   </a:txBody>
-                  <a:tcPr/>
+                  <a:tcPr marT="0" marB="0"/>
                 </a:tc>
                 <a:extLst>
                   <a:ext uri="{0D108BD9-81ED-4DB2-BD59-A6C34878D82A}">
-                    <a16:rowId xmlns:a16="http://schemas.microsoft.com/office/drawing/2014/main" val="10006"/>
+                    <a16:rowId xmlns:a16="http://schemas.microsoft.com/office/drawing/2014/main" val="10003"/>
                   </a:ext>
                 </a:extLst>
               </a:tr>
-              <a:tr h="320040">
-                <a:tc>
-                  <a:txBody>
-                    <a:bodyPr/>
-                    <a:lstStyle/>
-                    <a:p>
-                      <a:r>
-                        <a:rPr sz="1100"/>
-                        <a:t>B31-G1</a:t>
-                      </a:r>
-                    </a:p>
-                  </a:txBody>
-                  <a:tcPr/>
+              <a:tr h="231382">
+                <a:tc>
+                  <a:txBody>
+                    <a:bodyPr/>
+                    <a:lstStyle/>
+                    <a:p>
+                      <a:r>
+                        <a:rPr sz="1100"/>
+                        <a:t>WF-B3-1</a:t>
+                      </a:r>
+                    </a:p>
+                  </a:txBody>
+                  <a:tcPr marT="0" marB="0"/>
                 </a:tc>
                 <a:tc>
                   <a:txBody>
@@ -5585,299 +6677,7 @@
                       </a:r>
                     </a:p>
                   </a:txBody>
-                  <a:tcPr/>
-                </a:tc>
-                <a:tc>
-                  <a:txBody>
-                    <a:bodyPr/>
-                    <a:lstStyle/>
-                    <a:p>
-                      <a:r>
-                        <a:rPr sz="1100" b="1" dirty="0">
-                          <a:solidFill>
-                            <a:srgbClr val="2E86AB"/>
-                          </a:solidFill>
-                        </a:rPr>
-                        <a:t>SOLAR</a:t>
-                      </a:r>
-                    </a:p>
-                  </a:txBody>
-                  <a:tcPr/>
-                </a:tc>
-                <a:tc>
-                  <a:txBody>
-                    <a:bodyPr/>
-                    <a:lstStyle/>
-                    <a:p>
-                      <a:r>
-                        <a:rPr sz="1100"/>
-                        <a:t>570</a:t>
-                      </a:r>
-                    </a:p>
-                  </a:txBody>
-                  <a:tcPr/>
-                </a:tc>
-                <a:tc>
-                  <a:txBody>
-                    <a:bodyPr/>
-                    <a:lstStyle/>
-                    <a:p>
-                      <a:r>
-                        <a:rPr sz="1100"/>
-                        <a:t>0</a:t>
-                      </a:r>
-                    </a:p>
-                  </a:txBody>
-                  <a:tcPr/>
-                </a:tc>
-                <a:extLst>
-                  <a:ext uri="{0D108BD9-81ED-4DB2-BD59-A6C34878D82A}">
-                    <a16:rowId xmlns:a16="http://schemas.microsoft.com/office/drawing/2014/main" val="10007"/>
-                  </a:ext>
-                </a:extLst>
-              </a:tr>
-              <a:tr h="320040">
-                <a:tc>
-                  <a:txBody>
-                    <a:bodyPr/>
-                    <a:lstStyle/>
-                    <a:p>
-                      <a:r>
-                        <a:rPr sz="1100"/>
-                        <a:t>B32-G1</a:t>
-                      </a:r>
-                    </a:p>
-                  </a:txBody>
-                  <a:tcPr/>
-                </a:tc>
-                <a:tc>
-                  <a:txBody>
-                    <a:bodyPr/>
-                    <a:lstStyle/>
-                    <a:p>
-                      <a:r>
-                        <a:rPr sz="1100"/>
-                        <a:t>IEEE 39</a:t>
-                      </a:r>
-                    </a:p>
-                  </a:txBody>
-                  <a:tcPr/>
-                </a:tc>
-                <a:tc>
-                  <a:txBody>
-                    <a:bodyPr/>
-                    <a:lstStyle/>
-                    <a:p>
-                      <a:r>
-                        <a:rPr sz="1100"/>
-                        <a:t>COAL</a:t>
-                      </a:r>
-                    </a:p>
-                  </a:txBody>
-                  <a:tcPr/>
-                </a:tc>
-                <a:tc>
-                  <a:txBody>
-                    <a:bodyPr/>
-                    <a:lstStyle/>
-                    <a:p>
-                      <a:r>
-                        <a:rPr sz="1100"/>
-                        <a:t>975</a:t>
-                      </a:r>
-                    </a:p>
-                  </a:txBody>
-                  <a:tcPr/>
-                </a:tc>
-                <a:tc>
-                  <a:txBody>
-                    <a:bodyPr/>
-                    <a:lstStyle/>
-                    <a:p>
-                      <a:r>
-                        <a:rPr sz="1100"/>
-                        <a:t>45</a:t>
-                      </a:r>
-                    </a:p>
-                  </a:txBody>
-                  <a:tcPr/>
-                </a:tc>
-                <a:extLst>
-                  <a:ext uri="{0D108BD9-81ED-4DB2-BD59-A6C34878D82A}">
-                    <a16:rowId xmlns:a16="http://schemas.microsoft.com/office/drawing/2014/main" val="10008"/>
-                  </a:ext>
-                </a:extLst>
-              </a:tr>
-              <a:tr h="320040">
-                <a:tc>
-                  <a:txBody>
-                    <a:bodyPr/>
-                    <a:lstStyle/>
-                    <a:p>
-                      <a:r>
-                        <a:rPr sz="1100"/>
-                        <a:t>B33-G1</a:t>
-                      </a:r>
-                    </a:p>
-                  </a:txBody>
-                  <a:tcPr/>
-                </a:tc>
-                <a:tc>
-                  <a:txBody>
-                    <a:bodyPr/>
-                    <a:lstStyle/>
-                    <a:p>
-                      <a:r>
-                        <a:rPr sz="1100" dirty="0"/>
-                        <a:t>IEEE 39</a:t>
-                      </a:r>
-                    </a:p>
-                  </a:txBody>
-                  <a:tcPr/>
-                </a:tc>
-                <a:tc>
-                  <a:txBody>
-                    <a:bodyPr/>
-                    <a:lstStyle/>
-                    <a:p>
-                      <a:r>
-                        <a:rPr sz="1100"/>
-                        <a:t>NUCLEAR</a:t>
-                      </a:r>
-                    </a:p>
-                  </a:txBody>
-                  <a:tcPr/>
-                </a:tc>
-                <a:tc>
-                  <a:txBody>
-                    <a:bodyPr/>
-                    <a:lstStyle/>
-                    <a:p>
-                      <a:r>
-                        <a:rPr sz="1100"/>
-                        <a:t>950</a:t>
-                      </a:r>
-                    </a:p>
-                  </a:txBody>
-                  <a:tcPr/>
-                </a:tc>
-                <a:tc>
-                  <a:txBody>
-                    <a:bodyPr/>
-                    <a:lstStyle/>
-                    <a:p>
-                      <a:r>
-                        <a:rPr sz="1100"/>
-                        <a:t>8</a:t>
-                      </a:r>
-                    </a:p>
-                  </a:txBody>
-                  <a:tcPr/>
-                </a:tc>
-                <a:extLst>
-                  <a:ext uri="{0D108BD9-81ED-4DB2-BD59-A6C34878D82A}">
-                    <a16:rowId xmlns:a16="http://schemas.microsoft.com/office/drawing/2014/main" val="10009"/>
-                  </a:ext>
-                </a:extLst>
-              </a:tr>
-              <a:tr h="320040">
-                <a:tc>
-                  <a:txBody>
-                    <a:bodyPr/>
-                    <a:lstStyle/>
-                    <a:p>
-                      <a:r>
-                        <a:rPr sz="1100"/>
-                        <a:t>B34-G1</a:t>
-                      </a:r>
-                    </a:p>
-                  </a:txBody>
-                  <a:tcPr/>
-                </a:tc>
-                <a:tc>
-                  <a:txBody>
-                    <a:bodyPr/>
-                    <a:lstStyle/>
-                    <a:p>
-                      <a:r>
-                        <a:rPr sz="1100"/>
-                        <a:t>IEEE 39</a:t>
-                      </a:r>
-                    </a:p>
-                  </a:txBody>
-                  <a:tcPr/>
-                </a:tc>
-                <a:tc>
-                  <a:txBody>
-                    <a:bodyPr/>
-                    <a:lstStyle/>
-                    <a:p>
-                      <a:r>
-                        <a:rPr sz="1100" dirty="0"/>
-                        <a:t>GAS</a:t>
-                      </a:r>
-                    </a:p>
-                  </a:txBody>
-                  <a:tcPr/>
-                </a:tc>
-                <a:tc>
-                  <a:txBody>
-                    <a:bodyPr/>
-                    <a:lstStyle/>
-                    <a:p>
-                      <a:r>
-                        <a:rPr sz="1100"/>
-                        <a:t>762</a:t>
-                      </a:r>
-                    </a:p>
-                  </a:txBody>
-                  <a:tcPr/>
-                </a:tc>
-                <a:tc>
-                  <a:txBody>
-                    <a:bodyPr/>
-                    <a:lstStyle/>
-                    <a:p>
-                      <a:r>
-                        <a:rPr sz="1100"/>
-                        <a:t>70</a:t>
-                      </a:r>
-                    </a:p>
-                  </a:txBody>
-                  <a:tcPr/>
-                </a:tc>
-                <a:extLst>
-                  <a:ext uri="{0D108BD9-81ED-4DB2-BD59-A6C34878D82A}">
-                    <a16:rowId xmlns:a16="http://schemas.microsoft.com/office/drawing/2014/main" val="10010"/>
-                  </a:ext>
-                </a:extLst>
-              </a:tr>
-              <a:tr h="320040">
-                <a:tc>
-                  <a:txBody>
-                    <a:bodyPr/>
-                    <a:lstStyle/>
-                    <a:p>
-                      <a:r>
-                        <a:rPr sz="1100"/>
-                        <a:t>B35-G1</a:t>
-                      </a:r>
-                    </a:p>
-                  </a:txBody>
-                  <a:tcPr/>
-                </a:tc>
-                <a:tc>
-                  <a:txBody>
-                    <a:bodyPr/>
-                    <a:lstStyle/>
-                    <a:p>
-                      <a:r>
-                        <a:rPr sz="1100"/>
-                        <a:t>IEEE 39</a:t>
-                      </a:r>
-                    </a:p>
-                  </a:txBody>
-                  <a:tcPr/>
+                  <a:tcPr marT="0" marB="0"/>
                 </a:tc>
                 <a:tc>
                   <a:txBody>
@@ -5890,329 +6690,41 @@
                             <a:srgbClr val="2E86AB"/>
                           </a:solidFill>
                         </a:rPr>
-                        <a:t>HYDRO</a:t>
-                      </a:r>
-                    </a:p>
-                  </a:txBody>
-                  <a:tcPr/>
-                </a:tc>
-                <a:tc>
-                  <a:txBody>
-                    <a:bodyPr/>
-                    <a:lstStyle/>
-                    <a:p>
-                      <a:r>
-                        <a:rPr sz="1100"/>
-                        <a:t>650</a:t>
-                      </a:r>
-                    </a:p>
-                  </a:txBody>
-                  <a:tcPr/>
-                </a:tc>
-                <a:tc>
-                  <a:txBody>
-                    <a:bodyPr/>
-                    <a:lstStyle/>
-                    <a:p>
-                      <a:r>
-                        <a:rPr sz="1100"/>
-                        <a:t>5</a:t>
-                      </a:r>
-                    </a:p>
-                  </a:txBody>
-                  <a:tcPr/>
+                        <a:t>WIND</a:t>
+                      </a:r>
+                    </a:p>
+                  </a:txBody>
+                  <a:tcPr marT="0" marB="0"/>
+                </a:tc>
+                <a:tc>
+                  <a:txBody>
+                    <a:bodyPr/>
+                    <a:lstStyle/>
+                    <a:p>
+                      <a:r>
+                        <a:rPr sz="1100"/>
+                        <a:t>200</a:t>
+                      </a:r>
+                    </a:p>
+                  </a:txBody>
+                  <a:tcPr marT="0" marB="0"/>
+                </a:tc>
+                <a:tc>
+                  <a:txBody>
+                    <a:bodyPr/>
+                    <a:lstStyle/>
+                    <a:p>
+                      <a:r>
+                        <a:rPr sz="1100"/>
+                        <a:t>1</a:t>
+                      </a:r>
+                    </a:p>
+                  </a:txBody>
+                  <a:tcPr marT="0" marB="0"/>
                 </a:tc>
                 <a:extLst>
                   <a:ext uri="{0D108BD9-81ED-4DB2-BD59-A6C34878D82A}">
-                    <a16:rowId xmlns:a16="http://schemas.microsoft.com/office/drawing/2014/main" val="10011"/>
-                  </a:ext>
-                </a:extLst>
-              </a:tr>
-              <a:tr h="320040">
-                <a:tc>
-                  <a:txBody>
-                    <a:bodyPr/>
-                    <a:lstStyle/>
-                    <a:p>
-                      <a:r>
-                        <a:rPr sz="1100"/>
-                        <a:t>B36-G1</a:t>
-                      </a:r>
-                    </a:p>
-                  </a:txBody>
-                  <a:tcPr/>
-                </a:tc>
-                <a:tc>
-                  <a:txBody>
-                    <a:bodyPr/>
-                    <a:lstStyle/>
-                    <a:p>
-                      <a:r>
-                        <a:rPr sz="1100"/>
-                        <a:t>IEEE 39</a:t>
-                      </a:r>
-                    </a:p>
-                  </a:txBody>
-                  <a:tcPr/>
-                </a:tc>
-                <a:tc>
-                  <a:txBody>
-                    <a:bodyPr/>
-                    <a:lstStyle/>
-                    <a:p>
-                      <a:r>
-                        <a:rPr sz="1100"/>
-                        <a:t>COAL</a:t>
-                      </a:r>
-                    </a:p>
-                  </a:txBody>
-                  <a:tcPr/>
-                </a:tc>
-                <a:tc>
-                  <a:txBody>
-                    <a:bodyPr/>
-                    <a:lstStyle/>
-                    <a:p>
-                      <a:r>
-                        <a:rPr sz="1100"/>
-                        <a:t>840</a:t>
-                      </a:r>
-                    </a:p>
-                  </a:txBody>
-                  <a:tcPr/>
-                </a:tc>
-                <a:tc>
-                  <a:txBody>
-                    <a:bodyPr/>
-                    <a:lstStyle/>
-                    <a:p>
-                      <a:r>
-                        <a:rPr sz="1100"/>
-                        <a:t>45</a:t>
-                      </a:r>
-                    </a:p>
-                  </a:txBody>
-                  <a:tcPr/>
-                </a:tc>
-                <a:extLst>
-                  <a:ext uri="{0D108BD9-81ED-4DB2-BD59-A6C34878D82A}">
-                    <a16:rowId xmlns:a16="http://schemas.microsoft.com/office/drawing/2014/main" val="10012"/>
-                  </a:ext>
-                </a:extLst>
-              </a:tr>
-              <a:tr h="320040">
-                <a:tc>
-                  <a:txBody>
-                    <a:bodyPr/>
-                    <a:lstStyle/>
-                    <a:p>
-                      <a:r>
-                        <a:rPr sz="1100"/>
-                        <a:t>B37-G1</a:t>
-                      </a:r>
-                    </a:p>
-                  </a:txBody>
-                  <a:tcPr/>
-                </a:tc>
-                <a:tc>
-                  <a:txBody>
-                    <a:bodyPr/>
-                    <a:lstStyle/>
-                    <a:p>
-                      <a:r>
-                        <a:rPr sz="1100"/>
-                        <a:t>IEEE 39</a:t>
-                      </a:r>
-                    </a:p>
-                  </a:txBody>
-                  <a:tcPr/>
-                </a:tc>
-                <a:tc>
-                  <a:txBody>
-                    <a:bodyPr/>
-                    <a:lstStyle/>
-                    <a:p>
-                      <a:r>
-                        <a:rPr sz="1100"/>
-                        <a:t>GAS</a:t>
-                      </a:r>
-                    </a:p>
-                  </a:txBody>
-                  <a:tcPr/>
-                </a:tc>
-                <a:tc>
-                  <a:txBody>
-                    <a:bodyPr/>
-                    <a:lstStyle/>
-                    <a:p>
-                      <a:r>
-                        <a:rPr sz="1100"/>
-                        <a:t>810</a:t>
-                      </a:r>
-                    </a:p>
-                  </a:txBody>
-                  <a:tcPr/>
-                </a:tc>
-                <a:tc>
-                  <a:txBody>
-                    <a:bodyPr/>
-                    <a:lstStyle/>
-                    <a:p>
-                      <a:r>
-                        <a:rPr sz="1100"/>
-                        <a:t>70</a:t>
-                      </a:r>
-                    </a:p>
-                  </a:txBody>
-                  <a:tcPr/>
-                </a:tc>
-                <a:extLst>
-                  <a:ext uri="{0D108BD9-81ED-4DB2-BD59-A6C34878D82A}">
-                    <a16:rowId xmlns:a16="http://schemas.microsoft.com/office/drawing/2014/main" val="10013"/>
-                  </a:ext>
-                </a:extLst>
-              </a:tr>
-              <a:tr h="320040">
-                <a:tc>
-                  <a:txBody>
-                    <a:bodyPr/>
-                    <a:lstStyle/>
-                    <a:p>
-                      <a:r>
-                        <a:rPr sz="1100"/>
-                        <a:t>B38-G1</a:t>
-                      </a:r>
-                    </a:p>
-                  </a:txBody>
-                  <a:tcPr/>
-                </a:tc>
-                <a:tc>
-                  <a:txBody>
-                    <a:bodyPr/>
-                    <a:lstStyle/>
-                    <a:p>
-                      <a:r>
-                        <a:rPr sz="1100"/>
-                        <a:t>IEEE 39</a:t>
-                      </a:r>
-                    </a:p>
-                  </a:txBody>
-                  <a:tcPr/>
-                </a:tc>
-                <a:tc>
-                  <a:txBody>
-                    <a:bodyPr/>
-                    <a:lstStyle/>
-                    <a:p>
-                      <a:r>
-                        <a:rPr sz="1100"/>
-                        <a:t>NUCLEAR</a:t>
-                      </a:r>
-                    </a:p>
-                  </a:txBody>
-                  <a:tcPr/>
-                </a:tc>
-                <a:tc>
-                  <a:txBody>
-                    <a:bodyPr/>
-                    <a:lstStyle/>
-                    <a:p>
-                      <a:r>
-                        <a:rPr sz="1100"/>
-                        <a:t>1245</a:t>
-                      </a:r>
-                    </a:p>
-                  </a:txBody>
-                  <a:tcPr/>
-                </a:tc>
-                <a:tc>
-                  <a:txBody>
-                    <a:bodyPr/>
-                    <a:lstStyle/>
-                    <a:p>
-                      <a:r>
-                        <a:rPr sz="1100"/>
-                        <a:t>8</a:t>
-                      </a:r>
-                    </a:p>
-                  </a:txBody>
-                  <a:tcPr/>
-                </a:tc>
-                <a:extLst>
-                  <a:ext uri="{0D108BD9-81ED-4DB2-BD59-A6C34878D82A}">
-                    <a16:rowId xmlns:a16="http://schemas.microsoft.com/office/drawing/2014/main" val="10014"/>
-                  </a:ext>
-                </a:extLst>
-              </a:tr>
-              <a:tr h="0">
-                <a:tc>
-                  <a:txBody>
-                    <a:bodyPr/>
-                    <a:lstStyle/>
-                    <a:p>
-                      <a:r>
-                        <a:rPr sz="1100"/>
-                        <a:t>B39-G1</a:t>
-                      </a:r>
-                    </a:p>
-                  </a:txBody>
-                  <a:tcPr/>
-                </a:tc>
-                <a:tc>
-                  <a:txBody>
-                    <a:bodyPr/>
-                    <a:lstStyle/>
-                    <a:p>
-                      <a:r>
-                        <a:rPr sz="1100"/>
-                        <a:t>IEEE 39</a:t>
-                      </a:r>
-                    </a:p>
-                  </a:txBody>
-                  <a:tcPr/>
-                </a:tc>
-                <a:tc>
-                  <a:txBody>
-                    <a:bodyPr/>
-                    <a:lstStyle/>
-                    <a:p>
-                      <a:r>
-                        <a:rPr sz="1100"/>
-                        <a:t>NUCLEAR</a:t>
-                      </a:r>
-                    </a:p>
-                  </a:txBody>
-                  <a:tcPr/>
-                </a:tc>
-                <a:tc>
-                  <a:txBody>
-                    <a:bodyPr/>
-                    <a:lstStyle/>
-                    <a:p>
-                      <a:r>
-                        <a:rPr sz="1100"/>
-                        <a:t>1500</a:t>
-                      </a:r>
-                    </a:p>
-                  </a:txBody>
-                  <a:tcPr/>
-                </a:tc>
-                <a:tc>
-                  <a:txBody>
-                    <a:bodyPr/>
-                    <a:lstStyle/>
-                    <a:p>
-                      <a:r>
-                        <a:rPr sz="1100" dirty="0"/>
-                        <a:t>8</a:t>
-                      </a:r>
-                    </a:p>
-                  </a:txBody>
-                  <a:tcPr/>
-                </a:tc>
-                <a:extLst>
-                  <a:ext uri="{0D108BD9-81ED-4DB2-BD59-A6C34878D82A}">
-                    <a16:rowId xmlns:a16="http://schemas.microsoft.com/office/drawing/2014/main" val="10015"/>
+                    <a16:rowId xmlns:a16="http://schemas.microsoft.com/office/drawing/2014/main" val="10004"/>
                   </a:ext>
                 </a:extLst>
               </a:tr>
@@ -6366,7 +6878,7 @@
             </a:pPr>
             <a:r>
               <a:rPr lang="en-GB" dirty="0"/>
-              <a:t>Loads at their source values (× 1.00 on P and Q).</a:t>
+              <a:t>Loads at their base-case values (× 1.00 on P and Q).</a:t>
             </a:r>
           </a:p>
           <a:p>
@@ -6380,7 +6892,7 @@
             </a:pPr>
             <a:r>
               <a:rPr lang="en-GB" dirty="0"/>
-              <a:t>RES units (wind, solar, hydro) at 50 % of nominal P.</a:t>
+              <a:t>Wind and solar units at 50 % of their rating; condensers at 0 MW.</a:t>
             </a:r>
           </a:p>
           <a:p>
@@ -6394,7 +6906,7 @@
             </a:pPr>
             <a:r>
               <a:rPr lang="en-GB" dirty="0"/>
-              <a:t>Other units in merit order within each AC island (ties in file order).</a:t>
+              <a:t>Synchronous units at 30 % minimum, the rest in merit order within each AC island.</a:t>
             </a:r>
           </a:p>
           <a:p>
@@ -6408,7 +6920,7 @@
             </a:pPr>
             <a:r>
               <a:rPr lang="en-GB" dirty="0"/>
-              <a:t>HVDC link at 50 MW from IEEE 39 → IEEE 14.</a:t>
+              <a:t>HVDC link at 40 MW from IEEE 39 → IEEE 14.</a:t>
             </a:r>
           </a:p>
           <a:p>
@@ -6509,7 +7021,7 @@
             </a:pPr>
             <a:r>
               <a:rPr lang="en-GB" dirty="0"/>
-              <a:t>HVDC: 50 MW (IEEE 39 → IEEE 14), maximum 60 MW</a:t>
+              <a:t>HVDC: 40 MW (IEEE 39 → IEEE 14), rating 50 MW</a:t>
             </a:r>
           </a:p>
           <a:p>
@@ -6523,7 +7035,7 @@
             </a:pPr>
             <a:r>
               <a:rPr lang="en-GB" dirty="0"/>
-              <a:t>Dispatched generation: IEEE 14: 209.0 MW  |  IEEE 39: 6199.5 MW (losses covered by the distributed slack)</a:t>
+              <a:t>Dispatched generation: IEEE 14: 219.0 MW  |  IEEE 39: 6234.5 MW (losses covered by the distributed slack)</a:t>
             </a:r>
           </a:p>
           <a:p>
@@ -6537,7 +7049,7 @@
             </a:pPr>
             <a:r>
               <a:rPr lang="en-GB" dirty="0"/>
-              <a:t>Load: IEEE 14: 259.0 MW / 73.5 Mvar  |  IEEE 39: 6149.5 MW / 1408.9 Mvar</a:t>
+              <a:t>Load: IEEE 14: 259.0 MW / 73.5 Mvar  |  IEEE 39: 6194.7 MW / 1453.1 Mvar</a:t>
             </a:r>
           </a:p>
           <a:p>
@@ -6551,7 +7063,7 @@
             </a:pPr>
             <a:r>
               <a:rPr lang="en-GB" dirty="0"/>
-              <a:t>Bus voltages: 0.98–1.09 p.u.</a:t>
+              <a:t>Bus voltages: 0.98–1.06 p.u.</a:t>
             </a:r>
           </a:p>
           <a:p>
@@ -6565,7 +7077,7 @@
             </a:pPr>
             <a:r>
               <a:rPr lang="en-GB" dirty="0"/>
-              <a:t>Highest branch loading: 92 % (T-10-32-1), no overload</a:t>
+              <a:t>Highest branch loading: 91 % (L-113-114-1), no overload</a:t>
             </a:r>
           </a:p>
         </p:txBody>
@@ -6729,7 +7241,7 @@
             </a:pPr>
             <a:r>
               <a:rPr lang="en-GB" dirty="0"/>
-              <a:t>RES units (wind, solar, hydro) at 100 % of nominal P.</a:t>
+              <a:t>Wind and solar units at 100 % of their rating; condensers at 0 MW.</a:t>
             </a:r>
           </a:p>
           <a:p>
@@ -6743,7 +7255,7 @@
             </a:pPr>
             <a:r>
               <a:rPr lang="en-GB" dirty="0"/>
-              <a:t>Other units in merit order within each AC island (ties in file order).</a:t>
+              <a:t>Synchronous units at 30 % minimum (scaled down in IEEE 14), the rest in merit order.</a:t>
             </a:r>
           </a:p>
           <a:p>
@@ -6757,7 +7269,7 @@
             </a:pPr>
             <a:r>
               <a:rPr lang="en-GB" dirty="0"/>
-              <a:t>HVDC link forced to its maximum: 60 MW from IEEE 39 → IEEE 14.</a:t>
+              <a:t>HVDC link forced to its 50 MW rating from IEEE 39 → IEEE 14.</a:t>
             </a:r>
           </a:p>
           <a:p>
@@ -6858,7 +7370,7 @@
             </a:pPr>
             <a:r>
               <a:rPr lang="en-GB" dirty="0"/>
-              <a:t>HVDC: 60 MW (IEEE 39 → IEEE 14), at its maximum</a:t>
+              <a:t>HVDC: 50 MW (IEEE 39 → IEEE 14), at its maximum</a:t>
             </a:r>
           </a:p>
           <a:p>
@@ -6872,7 +7384,7 @@
             </a:pPr>
             <a:r>
               <a:rPr lang="en-GB" dirty="0"/>
-              <a:t>Dispatched generation: IEEE 14: 121.3 MW  |  IEEE 39: 4364.6 MW (losses covered by the distributed slack)</a:t>
+              <a:t>Dispatched generation: IEEE 14: 131.3 MW  |  IEEE 39: 4386.0 MW (losses covered by the distributed slack)</a:t>
             </a:r>
           </a:p>
           <a:p>
@@ -6886,7 +7398,7 @@
             </a:pPr>
             <a:r>
               <a:rPr lang="en-GB" dirty="0"/>
-              <a:t>Load: IEEE 14: 181.3 MW / 51.4 Mvar  |  IEEE 39: 4304.6 MW / 986.2 Mvar</a:t>
+              <a:t>Load: IEEE 14: 181.3 MW / 51.4 Mvar  |  IEEE 39: 4336.3 MW / 1017.2 Mvar</a:t>
             </a:r>
           </a:p>
           <a:p>
@@ -6900,7 +7412,7 @@
             </a:pPr>
             <a:r>
               <a:rPr lang="en-GB" dirty="0"/>
-              <a:t>Bus voltages: 0.98–1.09 p.u.; largest rise from S1 +0.026 p.u. at B12 (IEEE 39)</a:t>
+              <a:t>Bus voltages: 0.98–1.08 p.u.; largest rise from S1 +0.035 p.u. at B4 (IEEE 39)</a:t>
             </a:r>
           </a:p>
           <a:p>
@@ -6914,7 +7426,7 @@
             </a:pPr>
             <a:r>
               <a:rPr lang="en-GB" dirty="0"/>
-              <a:t>Highest branch loading: 95 % (L-28-29-1), no overload</a:t>
+              <a:t>Highest branch loading: 99 % (L-113-114-1), no overload</a:t>
             </a:r>
           </a:p>
         </p:txBody>
@@ -7064,7 +7576,7 @@
             </a:pPr>
             <a:r>
               <a:rPr lang="en-GB" dirty="0"/>
-              <a:t>Loads scaled by 1.08 on P and 1.50 on Q.</a:t>
+              <a:t>Loads scaled by 1.08 on P and 1.80 on Q.</a:t>
             </a:r>
           </a:p>
           <a:p>
@@ -7078,7 +7590,7 @@
             </a:pPr>
             <a:r>
               <a:rPr lang="en-GB" dirty="0"/>
-              <a:t>RES units (wind, solar, hydro) at 10 % of nominal P.</a:t>
+              <a:t>Wind and solar units at 10 % of their rating; condensers at 0 MW.</a:t>
             </a:r>
           </a:p>
           <a:p>
@@ -7092,7 +7604,7 @@
             </a:pPr>
             <a:r>
               <a:rPr lang="en-GB" dirty="0"/>
-              <a:t>Other units in merit order within each AC island (ties in file order).</a:t>
+              <a:t>Synchronous units at 30 % minimum, the rest in merit order within each AC island.</a:t>
             </a:r>
           </a:p>
           <a:p>
@@ -7106,7 +7618,7 @@
             </a:pPr>
             <a:r>
               <a:rPr lang="en-GB" dirty="0"/>
-              <a:t>HVDC link at 50 MW from IEEE 39 → IEEE 14.</a:t>
+              <a:t>HVDC link at 40 MW from IEEE 39 → IEEE 14.</a:t>
             </a:r>
           </a:p>
           <a:p>
@@ -7207,7 +7719,7 @@
             </a:pPr>
             <a:r>
               <a:rPr lang="en-GB" dirty="0"/>
-              <a:t>HVDC: 50 MW (IEEE 39 → IEEE 14), maximum 60 MW</a:t>
+              <a:t>HVDC: 40 MW (IEEE 39 → IEEE 14), rating 50 MW</a:t>
             </a:r>
           </a:p>
           <a:p>
@@ -7221,7 +7733,7 @@
             </a:pPr>
             <a:r>
               <a:rPr lang="en-GB" dirty="0"/>
-              <a:t>Dispatched generation: IEEE 14: 229.7 MW  |  IEEE 39: 6691.5 MW (losses covered by the distributed slack)</a:t>
+              <a:t>Dispatched generation: IEEE 14: 239.7 MW  |  IEEE 39: 6730.2 MW (losses covered by the distributed slack)</a:t>
             </a:r>
           </a:p>
           <a:p>
@@ -7235,7 +7747,7 @@
             </a:pPr>
             <a:r>
               <a:rPr lang="en-GB" dirty="0"/>
-              <a:t>Load: IEEE 14: 279.7 MW / 110.2 Mvar  |  IEEE 39: 6641.5 MW / 2113.4 Mvar</a:t>
+              <a:t>Load: IEEE 14: 279.7 MW / 132.3 Mvar  |  IEEE 39: 6690.3 MW / 2615.6 Mvar</a:t>
             </a:r>
           </a:p>
           <a:p>
@@ -7249,7 +7761,7 @@
             </a:pPr>
             <a:r>
               <a:rPr lang="en-GB" dirty="0"/>
-              <a:t>Bus voltages: 0.94–1.06 p.u.; largest drop from S1 −0.070 p.u. at B102 (IEEE 14)</a:t>
+              <a:t>Bus voltages: 0.95–1.06 p.u.; largest drop from S1 −0.050 p.u. at B109 (IEEE 14)</a:t>
             </a:r>
           </a:p>
           <a:p>
@@ -7263,7 +7775,7 @@
             </a:pPr>
             <a:r>
               <a:rPr lang="en-GB" dirty="0"/>
-              <a:t>Overloads: L-16-19-1 162 %, L-101-102-1 118 %, L-6-11-1 106 %, L-10-11-1 103 %</a:t>
+              <a:t>Overloads: L-2-3-1 104 %, L-113-114-1 102 %</a:t>
             </a:r>
           </a:p>
         </p:txBody>

</xml_diff>